<commit_message>
Pwp: B coefficient sign change - to +
</commit_message>
<xml_diff>
--- a/MEC8211-Devoir2.pptx
+++ b/MEC8211-Devoir2.pptx
@@ -201,7 +201,7 @@
           <a:p>
             <a:fld id="{BB0B2023-C595-443A-8D8C-AB9DF5A28D48}" type="datetimeFigureOut">
               <a:rPr lang="fr-FR" smtClean="0"/>
-              <a:t>26/02/2026</a:t>
+              <a:t>02/03/2026</a:t>
             </a:fld>
             <a:endParaRPr lang="fr-FR"/>
           </a:p>
@@ -1023,7 +1023,7 @@
           <a:p>
             <a:fld id="{4E51AFDA-D128-4B68-A211-269E2451E5DE}" type="datetimeFigureOut">
               <a:rPr lang="fr-FR" smtClean="0"/>
-              <a:t>26/02/2026</a:t>
+              <a:t>02/03/2026</a:t>
             </a:fld>
             <a:endParaRPr lang="fr-FR"/>
           </a:p>
@@ -1221,7 +1221,7 @@
           <a:p>
             <a:fld id="{4E51AFDA-D128-4B68-A211-269E2451E5DE}" type="datetimeFigureOut">
               <a:rPr lang="fr-FR" smtClean="0"/>
-              <a:t>26/02/2026</a:t>
+              <a:t>02/03/2026</a:t>
             </a:fld>
             <a:endParaRPr lang="fr-FR"/>
           </a:p>
@@ -1429,7 +1429,7 @@
           <a:p>
             <a:fld id="{4E51AFDA-D128-4B68-A211-269E2451E5DE}" type="datetimeFigureOut">
               <a:rPr lang="fr-FR" smtClean="0"/>
-              <a:t>26/02/2026</a:t>
+              <a:t>02/03/2026</a:t>
             </a:fld>
             <a:endParaRPr lang="fr-FR"/>
           </a:p>
@@ -1627,7 +1627,7 @@
           <a:p>
             <a:fld id="{4E51AFDA-D128-4B68-A211-269E2451E5DE}" type="datetimeFigureOut">
               <a:rPr lang="fr-FR" smtClean="0"/>
-              <a:t>26/02/2026</a:t>
+              <a:t>02/03/2026</a:t>
             </a:fld>
             <a:endParaRPr lang="fr-FR"/>
           </a:p>
@@ -1902,7 +1902,7 @@
           <a:p>
             <a:fld id="{4E51AFDA-D128-4B68-A211-269E2451E5DE}" type="datetimeFigureOut">
               <a:rPr lang="fr-FR" smtClean="0"/>
-              <a:t>26/02/2026</a:t>
+              <a:t>02/03/2026</a:t>
             </a:fld>
             <a:endParaRPr lang="fr-FR"/>
           </a:p>
@@ -2167,7 +2167,7 @@
           <a:p>
             <a:fld id="{4E51AFDA-D128-4B68-A211-269E2451E5DE}" type="datetimeFigureOut">
               <a:rPr lang="fr-FR" smtClean="0"/>
-              <a:t>26/02/2026</a:t>
+              <a:t>02/03/2026</a:t>
             </a:fld>
             <a:endParaRPr lang="fr-FR"/>
           </a:p>
@@ -2579,7 +2579,7 @@
           <a:p>
             <a:fld id="{4E51AFDA-D128-4B68-A211-269E2451E5DE}" type="datetimeFigureOut">
               <a:rPr lang="fr-FR" smtClean="0"/>
-              <a:t>26/02/2026</a:t>
+              <a:t>02/03/2026</a:t>
             </a:fld>
             <a:endParaRPr lang="fr-FR"/>
           </a:p>
@@ -2720,7 +2720,7 @@
           <a:p>
             <a:fld id="{4E51AFDA-D128-4B68-A211-269E2451E5DE}" type="datetimeFigureOut">
               <a:rPr lang="fr-FR" smtClean="0"/>
-              <a:t>26/02/2026</a:t>
+              <a:t>02/03/2026</a:t>
             </a:fld>
             <a:endParaRPr lang="fr-FR"/>
           </a:p>
@@ -2833,7 +2833,7 @@
           <a:p>
             <a:fld id="{4E51AFDA-D128-4B68-A211-269E2451E5DE}" type="datetimeFigureOut">
               <a:rPr lang="fr-FR" smtClean="0"/>
-              <a:t>26/02/2026</a:t>
+              <a:t>02/03/2026</a:t>
             </a:fld>
             <a:endParaRPr lang="fr-FR"/>
           </a:p>
@@ -3144,7 +3144,7 @@
           <a:p>
             <a:fld id="{4E51AFDA-D128-4B68-A211-269E2451E5DE}" type="datetimeFigureOut">
               <a:rPr lang="fr-FR" smtClean="0"/>
-              <a:t>26/02/2026</a:t>
+              <a:t>02/03/2026</a:t>
             </a:fld>
             <a:endParaRPr lang="fr-FR"/>
           </a:p>
@@ -3432,7 +3432,7 @@
           <a:p>
             <a:fld id="{4E51AFDA-D128-4B68-A211-269E2451E5DE}" type="datetimeFigureOut">
               <a:rPr lang="fr-FR" smtClean="0"/>
-              <a:t>26/02/2026</a:t>
+              <a:t>02/03/2026</a:t>
             </a:fld>
             <a:endParaRPr lang="fr-FR"/>
           </a:p>
@@ -3673,7 +3673,7 @@
           <a:p>
             <a:fld id="{4E51AFDA-D128-4B68-A211-269E2451E5DE}" type="datetimeFigureOut">
               <a:rPr lang="fr-FR" smtClean="0"/>
-              <a:t>26/02/2026</a:t>
+              <a:t>02/03/2026</a:t>
             </a:fld>
             <a:endParaRPr lang="fr-FR"/>
           </a:p>
@@ -4287,8 +4287,8 @@
           </a:p>
         </p:txBody>
       </p:sp>
-      <mc:AlternateContent xmlns:mc="http://schemas.openxmlformats.org/markup-compatibility/2006">
-        <mc:Choice xmlns:a14="http://schemas.microsoft.com/office/drawing/2010/main" Requires="a14">
+      <mc:AlternateContent xmlns:mc="http://schemas.openxmlformats.org/markup-compatibility/2006" xmlns:a14="http://schemas.microsoft.com/office/drawing/2010/main">
+        <mc:Choice Requires="a14">
           <p:sp>
             <p:nvSpPr>
               <p:cNvPr id="3" name="Espace réservé du contenu 2">
@@ -4329,49 +4329,67 @@
                     <m:f>
                       <m:fPr>
                         <m:ctrlPr>
-                          <a:rPr lang="fr-FR" sz="2500" i="1"/>
+                          <a:rPr lang="fr-FR" sz="2500" i="1">
+                            <a:latin typeface="Cambria Math" panose="02040503050406030204" pitchFamily="18" charset="0"/>
+                          </a:rPr>
                         </m:ctrlPr>
                       </m:fPr>
                       <m:num>
                         <m:r>
-                          <a:rPr lang="fr-FR" sz="2500"/>
-                          <m:t>∂</m:t>
-                        </m:r>
-                        <m:r>
-                          <a:rPr lang="fr-FR" sz="2500" i="1"/>
+                          <a:rPr lang="fr-FR" sz="2500">
+                            <a:latin typeface="Cambria Math" panose="02040503050406030204" pitchFamily="18" charset="0"/>
+                          </a:rPr>
+                          <m:t>𝜕</m:t>
+                        </m:r>
+                        <m:r>
+                          <a:rPr lang="fr-FR" sz="2500" i="1">
+                            <a:latin typeface="Cambria Math" panose="02040503050406030204" pitchFamily="18" charset="0"/>
+                          </a:rPr>
                           <m:t>𝐶</m:t>
                         </m:r>
                       </m:num>
                       <m:den>
                         <m:r>
-                          <a:rPr lang="fr-FR" sz="2500"/>
-                          <m:t>∂</m:t>
-                        </m:r>
-                        <m:r>
-                          <a:rPr lang="fr-FR" sz="2500" i="1"/>
+                          <a:rPr lang="fr-FR" sz="2500">
+                            <a:latin typeface="Cambria Math" panose="02040503050406030204" pitchFamily="18" charset="0"/>
+                          </a:rPr>
+                          <m:t>𝜕</m:t>
+                        </m:r>
+                        <m:r>
+                          <a:rPr lang="fr-FR" sz="2500" i="1">
+                            <a:latin typeface="Cambria Math" panose="02040503050406030204" pitchFamily="18" charset="0"/>
+                          </a:rPr>
                           <m:t>𝑡</m:t>
                         </m:r>
                       </m:den>
                     </m:f>
                     <m:r>
-                      <a:rPr lang="fr-FR" sz="2500" i="1"/>
+                      <a:rPr lang="fr-FR" sz="2500" i="1">
+                        <a:latin typeface="Cambria Math" panose="02040503050406030204" pitchFamily="18" charset="0"/>
+                      </a:rPr>
                       <m:t>=</m:t>
                     </m:r>
                     <m:sSub>
                       <m:sSubPr>
                         <m:ctrlPr>
-                          <a:rPr lang="fr-FR" sz="2500" i="1"/>
+                          <a:rPr lang="fr-FR" sz="2500" i="1">
+                            <a:latin typeface="Cambria Math" panose="02040503050406030204" pitchFamily="18" charset="0"/>
+                          </a:rPr>
                         </m:ctrlPr>
                       </m:sSubPr>
                       <m:e>
                         <m:r>
-                          <a:rPr lang="fr-FR" sz="2500" i="1"/>
+                          <a:rPr lang="fr-FR" sz="2500" i="1">
+                            <a:latin typeface="Cambria Math" panose="02040503050406030204" pitchFamily="18" charset="0"/>
+                          </a:rPr>
                           <m:t>𝐷</m:t>
                         </m:r>
                       </m:e>
                       <m:sub>
                         <m:r>
-                          <a:rPr lang="fr-FR" sz="2500" i="1"/>
+                          <a:rPr lang="fr-FR" sz="2500" i="1">
+                            <a:latin typeface="Cambria Math" panose="02040503050406030204" pitchFamily="18" charset="0"/>
+                          </a:rPr>
                           <m:t>𝑒𝑓𝑓</m:t>
                         </m:r>
                       </m:sub>
@@ -4379,7 +4397,9 @@
                     <m:sSup>
                       <m:sSupPr>
                         <m:ctrlPr>
-                          <a:rPr lang="fr-FR" sz="2500" i="1"/>
+                          <a:rPr lang="fr-FR" sz="2500" i="1">
+                            <a:latin typeface="Cambria Math" panose="02040503050406030204" pitchFamily="18" charset="0"/>
+                          </a:rPr>
                         </m:ctrlPr>
                       </m:sSupPr>
                       <m:e>
@@ -4387,27 +4407,37 @@
                           <m:rPr>
                             <m:sty m:val="p"/>
                           </m:rPr>
-                          <a:rPr lang="fr-FR" sz="2500"/>
+                          <a:rPr lang="fr-FR" sz="2500">
+                            <a:latin typeface="Cambria Math" panose="02040503050406030204" pitchFamily="18" charset="0"/>
+                          </a:rPr>
                           <m:t>∇</m:t>
                         </m:r>
                       </m:e>
                       <m:sup>
                         <m:r>
-                          <a:rPr lang="fr-FR" sz="2500" i="1"/>
+                          <a:rPr lang="fr-FR" sz="2500" i="1">
+                            <a:latin typeface="Cambria Math" panose="02040503050406030204" pitchFamily="18" charset="0"/>
+                          </a:rPr>
                           <m:t>2</m:t>
                         </m:r>
                       </m:sup>
                     </m:sSup>
                     <m:r>
-                      <a:rPr lang="fr-FR" sz="2500" i="1"/>
+                      <a:rPr lang="fr-FR" sz="2500" i="1">
+                        <a:latin typeface="Cambria Math" panose="02040503050406030204" pitchFamily="18" charset="0"/>
+                      </a:rPr>
                       <m:t>𝐶</m:t>
                     </m:r>
                     <m:r>
-                      <a:rPr lang="fr-FR" sz="2500" i="1"/>
+                      <a:rPr lang="fr-FR" sz="2500" i="1">
+                        <a:latin typeface="Cambria Math" panose="02040503050406030204" pitchFamily="18" charset="0"/>
+                      </a:rPr>
                       <m:t>−</m:t>
                     </m:r>
                     <m:r>
-                      <a:rPr lang="fr-FR" sz="2500" i="1"/>
+                      <a:rPr lang="fr-FR" sz="2500" i="1">
+                        <a:latin typeface="Cambria Math" panose="02040503050406030204" pitchFamily="18" charset="0"/>
+                      </a:rPr>
                       <m:t>𝑆</m:t>
                     </m:r>
                   </m:oMath>
@@ -4436,64 +4466,86 @@
                     <m:f>
                       <m:fPr>
                         <m:ctrlPr>
-                          <a:rPr lang="fr-FR" sz="2500" i="1"/>
+                          <a:rPr lang="fr-FR" sz="2500" i="1">
+                            <a:latin typeface="Cambria Math" panose="02040503050406030204" pitchFamily="18" charset="0"/>
+                          </a:rPr>
                         </m:ctrlPr>
                       </m:fPr>
                       <m:num>
                         <m:sSubSup>
                           <m:sSubSupPr>
                             <m:ctrlPr>
-                              <a:rPr lang="fr-FR" sz="2500" i="1"/>
+                              <a:rPr lang="fr-FR" sz="2500" i="1">
+                                <a:latin typeface="Cambria Math" panose="02040503050406030204" pitchFamily="18" charset="0"/>
+                              </a:rPr>
                             </m:ctrlPr>
                           </m:sSubSupPr>
                           <m:e>
                             <m:r>
-                              <a:rPr lang="fr-FR" sz="2500" i="1"/>
+                              <a:rPr lang="fr-FR" sz="2500" i="1">
+                                <a:latin typeface="Cambria Math" panose="02040503050406030204" pitchFamily="18" charset="0"/>
+                              </a:rPr>
                               <m:t>𝐶</m:t>
                             </m:r>
                           </m:e>
                           <m:sub>
                             <m:r>
-                              <a:rPr lang="fr-FR" sz="2500" i="1"/>
+                              <a:rPr lang="fr-FR" sz="2500" i="1">
+                                <a:latin typeface="Cambria Math" panose="02040503050406030204" pitchFamily="18" charset="0"/>
+                              </a:rPr>
                               <m:t>𝑖</m:t>
                             </m:r>
                           </m:sub>
                           <m:sup>
                             <m:r>
-                              <a:rPr lang="fr-FR" sz="2500" i="1"/>
+                              <a:rPr lang="fr-FR" sz="2500" i="1">
+                                <a:latin typeface="Cambria Math" panose="02040503050406030204" pitchFamily="18" charset="0"/>
+                              </a:rPr>
                               <m:t>𝑡</m:t>
                             </m:r>
                             <m:r>
-                              <a:rPr lang="fr-FR" sz="2500" i="1"/>
+                              <a:rPr lang="fr-FR" sz="2500" i="1">
+                                <a:latin typeface="Cambria Math" panose="02040503050406030204" pitchFamily="18" charset="0"/>
+                              </a:rPr>
                               <m:t>+1</m:t>
                             </m:r>
                           </m:sup>
                         </m:sSubSup>
                         <m:r>
-                          <a:rPr lang="fr-FR" sz="2500" i="1"/>
+                          <a:rPr lang="fr-FR" sz="2500" i="1">
+                            <a:latin typeface="Cambria Math" panose="02040503050406030204" pitchFamily="18" charset="0"/>
+                          </a:rPr>
                           <m:t>−</m:t>
                         </m:r>
                         <m:sSubSup>
                           <m:sSubSupPr>
                             <m:ctrlPr>
-                              <a:rPr lang="fr-FR" sz="2500" i="1"/>
+                              <a:rPr lang="fr-FR" sz="2500" i="1">
+                                <a:latin typeface="Cambria Math" panose="02040503050406030204" pitchFamily="18" charset="0"/>
+                              </a:rPr>
                             </m:ctrlPr>
                           </m:sSubSupPr>
                           <m:e>
                             <m:r>
-                              <a:rPr lang="fr-FR" sz="2500" i="1"/>
+                              <a:rPr lang="fr-FR" sz="2500" i="1">
+                                <a:latin typeface="Cambria Math" panose="02040503050406030204" pitchFamily="18" charset="0"/>
+                              </a:rPr>
                               <m:t>𝐶</m:t>
                             </m:r>
                           </m:e>
                           <m:sub>
                             <m:r>
-                              <a:rPr lang="fr-FR" sz="2500" i="1"/>
+                              <a:rPr lang="fr-FR" sz="2500" i="1">
+                                <a:latin typeface="Cambria Math" panose="02040503050406030204" pitchFamily="18" charset="0"/>
+                              </a:rPr>
                               <m:t>𝑖</m:t>
                             </m:r>
                           </m:sub>
                           <m:sup>
                             <m:r>
-                              <a:rPr lang="fr-FR" sz="2500" i="1"/>
+                              <a:rPr lang="fr-FR" sz="2500" i="1">
+                                <a:latin typeface="Cambria Math" panose="02040503050406030204" pitchFamily="18" charset="0"/>
+                              </a:rPr>
                               <m:t>𝑡</m:t>
                             </m:r>
                           </m:sup>
@@ -4504,34 +4556,46 @@
                           <m:rPr>
                             <m:sty m:val="p"/>
                           </m:rPr>
-                          <a:rPr lang="fr-FR" sz="2500"/>
+                          <a:rPr lang="fr-FR" sz="2500">
+                            <a:latin typeface="Cambria Math" panose="02040503050406030204" pitchFamily="18" charset="0"/>
+                          </a:rPr>
                           <m:t>Δ</m:t>
                         </m:r>
                         <m:r>
-                          <a:rPr lang="fr-FR" sz="2500" i="1"/>
+                          <a:rPr lang="fr-FR" sz="2500" i="1">
+                            <a:latin typeface="Cambria Math" panose="02040503050406030204" pitchFamily="18" charset="0"/>
+                          </a:rPr>
                           <m:t>𝑡</m:t>
                         </m:r>
                       </m:den>
                     </m:f>
                     <m:r>
-                      <a:rPr lang="fr-FR" sz="2500" i="1"/>
+                      <a:rPr lang="fr-FR" sz="2500" i="1">
+                        <a:latin typeface="Cambria Math" panose="02040503050406030204" pitchFamily="18" charset="0"/>
+                      </a:rPr>
                       <m:t>=</m:t>
                     </m:r>
                     <m:sSub>
                       <m:sSubPr>
                         <m:ctrlPr>
-                          <a:rPr lang="fr-FR" sz="2500" i="1"/>
+                          <a:rPr lang="fr-FR" sz="2500" i="1">
+                            <a:latin typeface="Cambria Math" panose="02040503050406030204" pitchFamily="18" charset="0"/>
+                          </a:rPr>
                         </m:ctrlPr>
                       </m:sSubPr>
                       <m:e>
                         <m:r>
-                          <a:rPr lang="fr-FR" sz="2500" i="1"/>
+                          <a:rPr lang="fr-FR" sz="2500" i="1">
+                            <a:latin typeface="Cambria Math" panose="02040503050406030204" pitchFamily="18" charset="0"/>
+                          </a:rPr>
                           <m:t>𝐷</m:t>
                         </m:r>
                       </m:e>
                       <m:sub>
                         <m:r>
-                          <a:rPr lang="fr-FR" sz="2500" i="1"/>
+                          <a:rPr lang="fr-FR" sz="2500" i="1">
+                            <a:latin typeface="Cambria Math" panose="02040503050406030204" pitchFamily="18" charset="0"/>
+                          </a:rPr>
                           <m:t>𝑒𝑓𝑓</m:t>
                         </m:r>
                       </m:sub>
@@ -4541,19 +4605,25 @@
                         <m:begChr m:val="["/>
                         <m:endChr m:val="]"/>
                         <m:ctrlPr>
-                          <a:rPr lang="fr-FR" sz="2500" i="1"/>
+                          <a:rPr lang="fr-FR" sz="2500" i="1">
+                            <a:latin typeface="Cambria Math" panose="02040503050406030204" pitchFamily="18" charset="0"/>
+                          </a:rPr>
                         </m:ctrlPr>
                       </m:dPr>
                       <m:e>
                         <m:f>
                           <m:fPr>
                             <m:ctrlPr>
-                              <a:rPr lang="fr-FR" sz="2500" i="1"/>
+                              <a:rPr lang="fr-FR" sz="2500" i="1">
+                                <a:latin typeface="Cambria Math" panose="02040503050406030204" pitchFamily="18" charset="0"/>
+                              </a:rPr>
                             </m:ctrlPr>
                           </m:fPr>
                           <m:num>
                             <m:r>
-                              <a:rPr lang="fr-FR" sz="2500"/>
+                              <a:rPr lang="fr-FR" sz="2500">
+                                <a:latin typeface="Cambria Math" panose="02040503050406030204" pitchFamily="18" charset="0"/>
+                              </a:rPr>
                               <m:t>1</m:t>
                             </m:r>
                           </m:num>
@@ -4561,7 +4631,9 @@
                             <m:sSub>
                               <m:sSubPr>
                                 <m:ctrlPr>
-                                  <a:rPr lang="fr-FR" sz="2500" i="1"/>
+                                  <a:rPr lang="fr-FR" sz="2500" i="1">
+                                    <a:latin typeface="Cambria Math" panose="02040503050406030204" pitchFamily="18" charset="0"/>
+                                  </a:rPr>
                                 </m:ctrlPr>
                               </m:sSubPr>
                               <m:e>
@@ -4569,7 +4641,9 @@
                                   <m:rPr>
                                     <m:sty m:val="p"/>
                                   </m:rPr>
-                                  <a:rPr lang="fr-FR" sz="2500"/>
+                                  <a:rPr lang="fr-FR" sz="2500">
+                                    <a:latin typeface="Cambria Math" panose="02040503050406030204" pitchFamily="18" charset="0"/>
+                                  </a:rPr>
                                   <m:t>r</m:t>
                                 </m:r>
                               </m:e>
@@ -4578,7 +4652,9 @@
                                   <m:rPr>
                                     <m:sty m:val="p"/>
                                   </m:rPr>
-                                  <a:rPr lang="fr-FR" sz="2500"/>
+                                  <a:rPr lang="fr-FR" sz="2500">
+                                    <a:latin typeface="Cambria Math" panose="02040503050406030204" pitchFamily="18" charset="0"/>
+                                  </a:rPr>
                                   <m:t>i</m:t>
                                 </m:r>
                               </m:sub>
@@ -4588,14 +4664,18 @@
                         <m:f>
                           <m:fPr>
                             <m:ctrlPr>
-                              <a:rPr lang="fr-FR" sz="2500" i="1"/>
+                              <a:rPr lang="fr-FR" sz="2500" i="1">
+                                <a:latin typeface="Cambria Math" panose="02040503050406030204" pitchFamily="18" charset="0"/>
+                              </a:rPr>
                             </m:ctrlPr>
                           </m:fPr>
                           <m:num>
                             <m:sSubSup>
                               <m:sSubSupPr>
                                 <m:ctrlPr>
-                                  <a:rPr lang="fr-FR" sz="2500" i="1"/>
+                                  <a:rPr lang="fr-FR" sz="2500" i="1">
+                                    <a:latin typeface="Cambria Math" panose="02040503050406030204" pitchFamily="18" charset="0"/>
+                                  </a:rPr>
                                 </m:ctrlPr>
                               </m:sSubSupPr>
                               <m:e>
@@ -4603,7 +4683,9 @@
                                   <m:rPr>
                                     <m:sty m:val="p"/>
                                   </m:rPr>
-                                  <a:rPr lang="fr-FR" sz="2500"/>
+                                  <a:rPr lang="fr-FR" sz="2500">
+                                    <a:latin typeface="Cambria Math" panose="02040503050406030204" pitchFamily="18" charset="0"/>
+                                  </a:rPr>
                                   <m:t>C</m:t>
                                 </m:r>
                               </m:e>
@@ -4612,11 +4694,15 @@
                                   <m:rPr>
                                     <m:sty m:val="p"/>
                                   </m:rPr>
-                                  <a:rPr lang="fr-FR" sz="2500"/>
+                                  <a:rPr lang="fr-FR" sz="2500">
+                                    <a:latin typeface="Cambria Math" panose="02040503050406030204" pitchFamily="18" charset="0"/>
+                                  </a:rPr>
                                   <m:t>i</m:t>
                                 </m:r>
                                 <m:r>
-                                  <a:rPr lang="fr-FR" sz="2500"/>
+                                  <a:rPr lang="fr-FR" sz="2500">
+                                    <a:latin typeface="Cambria Math" panose="02040503050406030204" pitchFamily="18" charset="0"/>
+                                  </a:rPr>
                                   <m:t>+1</m:t>
                                 </m:r>
                               </m:sub>
@@ -4625,23 +4711,31 @@
                                   <m:rPr>
                                     <m:sty m:val="p"/>
                                   </m:rPr>
-                                  <a:rPr lang="fr-FR" sz="2500"/>
+                                  <a:rPr lang="fr-FR" sz="2500">
+                                    <a:latin typeface="Cambria Math" panose="02040503050406030204" pitchFamily="18" charset="0"/>
+                                  </a:rPr>
                                   <m:t>t</m:t>
                                 </m:r>
                                 <m:r>
-                                  <a:rPr lang="fr-FR" sz="2500"/>
+                                  <a:rPr lang="fr-FR" sz="2500">
+                                    <a:latin typeface="Cambria Math" panose="02040503050406030204" pitchFamily="18" charset="0"/>
+                                  </a:rPr>
                                   <m:t>+1</m:t>
                                 </m:r>
                               </m:sup>
                             </m:sSubSup>
                             <m:r>
-                              <a:rPr lang="fr-FR" sz="2500"/>
+                              <a:rPr lang="fr-FR" sz="2500">
+                                <a:latin typeface="Cambria Math" panose="02040503050406030204" pitchFamily="18" charset="0"/>
+                              </a:rPr>
                               <m:t>−</m:t>
                             </m:r>
                             <m:sSubSup>
                               <m:sSubSupPr>
                                 <m:ctrlPr>
-                                  <a:rPr lang="fr-FR" sz="2500" i="1"/>
+                                  <a:rPr lang="fr-FR" sz="2500" i="1">
+                                    <a:latin typeface="Cambria Math" panose="02040503050406030204" pitchFamily="18" charset="0"/>
+                                  </a:rPr>
                                 </m:ctrlPr>
                               </m:sSubSupPr>
                               <m:e>
@@ -4649,7 +4743,9 @@
                                   <m:rPr>
                                     <m:sty m:val="p"/>
                                   </m:rPr>
-                                  <a:rPr lang="fr-FR" sz="2500"/>
+                                  <a:rPr lang="fr-FR" sz="2500">
+                                    <a:latin typeface="Cambria Math" panose="02040503050406030204" pitchFamily="18" charset="0"/>
+                                  </a:rPr>
                                   <m:t>C</m:t>
                                 </m:r>
                               </m:e>
@@ -4658,11 +4754,15 @@
                                   <m:rPr>
                                     <m:sty m:val="p"/>
                                   </m:rPr>
-                                  <a:rPr lang="fr-FR" sz="2500"/>
+                                  <a:rPr lang="fr-FR" sz="2500">
+                                    <a:latin typeface="Cambria Math" panose="02040503050406030204" pitchFamily="18" charset="0"/>
+                                  </a:rPr>
                                   <m:t>i</m:t>
                                 </m:r>
                                 <m:r>
-                                  <a:rPr lang="fr-FR" sz="2500"/>
+                                  <a:rPr lang="fr-FR" sz="2500">
+                                    <a:latin typeface="Cambria Math" panose="02040503050406030204" pitchFamily="18" charset="0"/>
+                                  </a:rPr>
                                   <m:t>−1</m:t>
                                 </m:r>
                               </m:sub>
@@ -4671,11 +4771,15 @@
                                   <m:rPr>
                                     <m:sty m:val="p"/>
                                   </m:rPr>
-                                  <a:rPr lang="fr-FR" sz="2500"/>
+                                  <a:rPr lang="fr-FR" sz="2500">
+                                    <a:latin typeface="Cambria Math" panose="02040503050406030204" pitchFamily="18" charset="0"/>
+                                  </a:rPr>
                                   <m:t>t</m:t>
                                 </m:r>
                                 <m:r>
-                                  <a:rPr lang="fr-FR" sz="2500"/>
+                                  <a:rPr lang="fr-FR" sz="2500">
+                                    <a:latin typeface="Cambria Math" panose="02040503050406030204" pitchFamily="18" charset="0"/>
+                                  </a:rPr>
                                   <m:t>+1</m:t>
                                 </m:r>
                               </m:sup>
@@ -4683,33 +4787,43 @@
                           </m:num>
                           <m:den>
                             <m:r>
-                              <a:rPr lang="fr-FR" sz="2500"/>
+                              <a:rPr lang="fr-FR" sz="2500">
+                                <a:latin typeface="Cambria Math" panose="02040503050406030204" pitchFamily="18" charset="0"/>
+                              </a:rPr>
                               <m:t>2</m:t>
                             </m:r>
                             <m:r>
                               <m:rPr>
                                 <m:sty m:val="p"/>
                               </m:rPr>
-                              <a:rPr lang="fr-FR" sz="2500"/>
+                              <a:rPr lang="fr-FR" sz="2500">
+                                <a:latin typeface="Cambria Math" panose="02040503050406030204" pitchFamily="18" charset="0"/>
+                              </a:rPr>
                               <m:t>Δr</m:t>
                             </m:r>
                           </m:den>
                         </m:f>
                         <m:r>
-                          <a:rPr lang="fr-FR" sz="2500" i="1"/>
+                          <a:rPr lang="fr-FR" sz="2500" i="1">
+                            <a:latin typeface="Cambria Math" panose="02040503050406030204" pitchFamily="18" charset="0"/>
+                          </a:rPr>
                           <m:t>+</m:t>
                         </m:r>
                         <m:f>
                           <m:fPr>
                             <m:ctrlPr>
-                              <a:rPr lang="fr-FR" sz="2500" i="1"/>
+                              <a:rPr lang="fr-FR" sz="2500" i="1">
+                                <a:latin typeface="Cambria Math" panose="02040503050406030204" pitchFamily="18" charset="0"/>
+                              </a:rPr>
                             </m:ctrlPr>
                           </m:fPr>
                           <m:num>
                             <m:sSubSup>
                               <m:sSubSupPr>
                                 <m:ctrlPr>
-                                  <a:rPr lang="fr-FR" sz="2500" i="1"/>
+                                  <a:rPr lang="fr-FR" sz="2500" i="1">
+                                    <a:latin typeface="Cambria Math" panose="02040503050406030204" pitchFamily="18" charset="0"/>
+                                  </a:rPr>
                                 </m:ctrlPr>
                               </m:sSubSupPr>
                               <m:e>
@@ -4717,7 +4831,9 @@
                                   <m:rPr>
                                     <m:sty m:val="p"/>
                                   </m:rPr>
-                                  <a:rPr lang="fr-FR" sz="2500"/>
+                                  <a:rPr lang="fr-FR" sz="2500">
+                                    <a:latin typeface="Cambria Math" panose="02040503050406030204" pitchFamily="18" charset="0"/>
+                                  </a:rPr>
                                   <m:t>C</m:t>
                                 </m:r>
                               </m:e>
@@ -4726,11 +4842,15 @@
                                   <m:rPr>
                                     <m:sty m:val="p"/>
                                   </m:rPr>
-                                  <a:rPr lang="fr-FR" sz="2500"/>
+                                  <a:rPr lang="fr-FR" sz="2500">
+                                    <a:latin typeface="Cambria Math" panose="02040503050406030204" pitchFamily="18" charset="0"/>
+                                  </a:rPr>
                                   <m:t>i</m:t>
                                 </m:r>
                                 <m:r>
-                                  <a:rPr lang="fr-FR" sz="2500"/>
+                                  <a:rPr lang="fr-FR" sz="2500">
+                                    <a:latin typeface="Cambria Math" panose="02040503050406030204" pitchFamily="18" charset="0"/>
+                                  </a:rPr>
                                   <m:t>+1</m:t>
                                 </m:r>
                               </m:sub>
@@ -4739,35 +4859,47 @@
                                   <m:rPr>
                                     <m:sty m:val="p"/>
                                   </m:rPr>
-                                  <a:rPr lang="fr-FR" sz="2500"/>
+                                  <a:rPr lang="fr-FR" sz="2500">
+                                    <a:latin typeface="Cambria Math" panose="02040503050406030204" pitchFamily="18" charset="0"/>
+                                  </a:rPr>
                                   <m:t>t</m:t>
                                 </m:r>
                                 <m:r>
-                                  <a:rPr lang="fr-FR" sz="2500"/>
+                                  <a:rPr lang="fr-FR" sz="2500">
+                                    <a:latin typeface="Cambria Math" panose="02040503050406030204" pitchFamily="18" charset="0"/>
+                                  </a:rPr>
                                   <m:t>+1</m:t>
                                 </m:r>
                               </m:sup>
                             </m:sSubSup>
                             <m:r>
-                              <a:rPr lang="fr-FR" sz="2500"/>
+                              <a:rPr lang="fr-FR" sz="2500">
+                                <a:latin typeface="Cambria Math" panose="02040503050406030204" pitchFamily="18" charset="0"/>
+                              </a:rPr>
                               <m:t>−</m:t>
                             </m:r>
                             <m:sSubSup>
                               <m:sSubSupPr>
                                 <m:ctrlPr>
-                                  <a:rPr lang="fr-FR" sz="2500" i="1"/>
+                                  <a:rPr lang="fr-FR" sz="2500" i="1">
+                                    <a:latin typeface="Cambria Math" panose="02040503050406030204" pitchFamily="18" charset="0"/>
+                                  </a:rPr>
                                 </m:ctrlPr>
                               </m:sSubSupPr>
                               <m:e>
                                 <m:r>
-                                  <a:rPr lang="fr-FR" sz="2500"/>
+                                  <a:rPr lang="fr-FR" sz="2500">
+                                    <a:latin typeface="Cambria Math" panose="02040503050406030204" pitchFamily="18" charset="0"/>
+                                  </a:rPr>
                                   <m:t>2</m:t>
                                 </m:r>
                                 <m:r>
                                   <m:rPr>
                                     <m:sty m:val="p"/>
                                   </m:rPr>
-                                  <a:rPr lang="fr-FR" sz="2500"/>
+                                  <a:rPr lang="fr-FR" sz="2500">
+                                    <a:latin typeface="Cambria Math" panose="02040503050406030204" pitchFamily="18" charset="0"/>
+                                  </a:rPr>
                                   <m:t>C</m:t>
                                 </m:r>
                               </m:e>
@@ -4776,7 +4908,9 @@
                                   <m:rPr>
                                     <m:sty m:val="p"/>
                                   </m:rPr>
-                                  <a:rPr lang="fr-FR" sz="2500"/>
+                                  <a:rPr lang="fr-FR" sz="2500">
+                                    <a:latin typeface="Cambria Math" panose="02040503050406030204" pitchFamily="18" charset="0"/>
+                                  </a:rPr>
                                   <m:t>i</m:t>
                                 </m:r>
                               </m:sub>
@@ -4785,23 +4919,31 @@
                                   <m:rPr>
                                     <m:sty m:val="p"/>
                                   </m:rPr>
-                                  <a:rPr lang="fr-FR" sz="2500"/>
+                                  <a:rPr lang="fr-FR" sz="2500">
+                                    <a:latin typeface="Cambria Math" panose="02040503050406030204" pitchFamily="18" charset="0"/>
+                                  </a:rPr>
                                   <m:t>t</m:t>
                                 </m:r>
                                 <m:r>
-                                  <a:rPr lang="fr-FR" sz="2500"/>
+                                  <a:rPr lang="fr-FR" sz="2500">
+                                    <a:latin typeface="Cambria Math" panose="02040503050406030204" pitchFamily="18" charset="0"/>
+                                  </a:rPr>
                                   <m:t>+1</m:t>
                                 </m:r>
                               </m:sup>
                             </m:sSubSup>
                             <m:r>
-                              <a:rPr lang="fr-FR" sz="2500" i="1"/>
+                              <a:rPr lang="fr-FR" sz="2500" i="1">
+                                <a:latin typeface="Cambria Math" panose="02040503050406030204" pitchFamily="18" charset="0"/>
+                              </a:rPr>
                               <m:t>+</m:t>
                             </m:r>
                             <m:sSubSup>
                               <m:sSubSupPr>
                                 <m:ctrlPr>
-                                  <a:rPr lang="fr-FR" sz="2500" i="1"/>
+                                  <a:rPr lang="fr-FR" sz="2500" i="1">
+                                    <a:latin typeface="Cambria Math" panose="02040503050406030204" pitchFamily="18" charset="0"/>
+                                  </a:rPr>
                                 </m:ctrlPr>
                               </m:sSubSupPr>
                               <m:e>
@@ -4809,7 +4951,9 @@
                                   <m:rPr>
                                     <m:sty m:val="p"/>
                                   </m:rPr>
-                                  <a:rPr lang="fr-FR" sz="2500"/>
+                                  <a:rPr lang="fr-FR" sz="2500">
+                                    <a:latin typeface="Cambria Math" panose="02040503050406030204" pitchFamily="18" charset="0"/>
+                                  </a:rPr>
                                   <m:t>C</m:t>
                                 </m:r>
                               </m:e>
@@ -4818,11 +4962,15 @@
                                   <m:rPr>
                                     <m:sty m:val="p"/>
                                   </m:rPr>
-                                  <a:rPr lang="fr-FR" sz="2500"/>
+                                  <a:rPr lang="fr-FR" sz="2500">
+                                    <a:latin typeface="Cambria Math" panose="02040503050406030204" pitchFamily="18" charset="0"/>
+                                  </a:rPr>
                                   <m:t>i</m:t>
                                 </m:r>
                                 <m:r>
-                                  <a:rPr lang="fr-FR" sz="2500"/>
+                                  <a:rPr lang="fr-FR" sz="2500">
+                                    <a:latin typeface="Cambria Math" panose="02040503050406030204" pitchFamily="18" charset="0"/>
+                                  </a:rPr>
                                   <m:t>−1</m:t>
                                 </m:r>
                               </m:sub>
@@ -4831,11 +4979,15 @@
                                   <m:rPr>
                                     <m:sty m:val="p"/>
                                   </m:rPr>
-                                  <a:rPr lang="fr-FR" sz="2500"/>
+                                  <a:rPr lang="fr-FR" sz="2500">
+                                    <a:latin typeface="Cambria Math" panose="02040503050406030204" pitchFamily="18" charset="0"/>
+                                  </a:rPr>
                                   <m:t>t</m:t>
                                 </m:r>
                                 <m:r>
-                                  <a:rPr lang="fr-FR" sz="2500"/>
+                                  <a:rPr lang="fr-FR" sz="2500">
+                                    <a:latin typeface="Cambria Math" panose="02040503050406030204" pitchFamily="18" charset="0"/>
+                                  </a:rPr>
                                   <m:t>+1</m:t>
                                 </m:r>
                               </m:sup>
@@ -4846,13 +4998,17 @@
                               <m:rPr>
                                 <m:sty m:val="p"/>
                               </m:rPr>
-                              <a:rPr lang="fr-FR" sz="2500"/>
+                              <a:rPr lang="fr-FR" sz="2500">
+                                <a:latin typeface="Cambria Math" panose="02040503050406030204" pitchFamily="18" charset="0"/>
+                              </a:rPr>
                               <m:t>Δ</m:t>
                             </m:r>
                             <m:sSup>
                               <m:sSupPr>
                                 <m:ctrlPr>
-                                  <a:rPr lang="fr-FR" sz="2500" i="1"/>
+                                  <a:rPr lang="fr-FR" sz="2500" i="1">
+                                    <a:latin typeface="Cambria Math" panose="02040503050406030204" pitchFamily="18" charset="0"/>
+                                  </a:rPr>
                                 </m:ctrlPr>
                               </m:sSupPr>
                               <m:e>
@@ -4860,13 +5016,17 @@
                                   <m:rPr>
                                     <m:sty m:val="p"/>
                                   </m:rPr>
-                                  <a:rPr lang="fr-FR" sz="2500"/>
+                                  <a:rPr lang="fr-FR" sz="2500">
+                                    <a:latin typeface="Cambria Math" panose="02040503050406030204" pitchFamily="18" charset="0"/>
+                                  </a:rPr>
                                   <m:t>r</m:t>
                                 </m:r>
                               </m:e>
                               <m:sup>
                                 <m:r>
-                                  <a:rPr lang="fr-FR" sz="2500"/>
+                                  <a:rPr lang="fr-FR" sz="2500">
+                                    <a:latin typeface="Cambria Math" panose="02040503050406030204" pitchFamily="18" charset="0"/>
+                                  </a:rPr>
                                   <m:t>2</m:t>
                                 </m:r>
                               </m:sup>
@@ -4876,17 +5036,23 @@
                       </m:e>
                     </m:d>
                     <m:r>
-                      <a:rPr lang="fr-FR" sz="2500" i="1"/>
+                      <a:rPr lang="fr-FR" sz="2500" i="1">
+                        <a:latin typeface="Cambria Math" panose="02040503050406030204" pitchFamily="18" charset="0"/>
+                      </a:rPr>
                       <m:t>−</m:t>
                     </m:r>
                     <m:r>
-                      <a:rPr lang="fr-FR" sz="2500" i="1"/>
+                      <a:rPr lang="fr-FR" sz="2500" i="1">
+                        <a:latin typeface="Cambria Math" panose="02040503050406030204" pitchFamily="18" charset="0"/>
+                      </a:rPr>
                       <m:t>𝑘</m:t>
                     </m:r>
                     <m:sSubSup>
                       <m:sSubSupPr>
                         <m:ctrlPr>
-                          <a:rPr lang="fr-FR" sz="2500" i="1"/>
+                          <a:rPr lang="fr-FR" sz="2500" i="1">
+                            <a:latin typeface="Cambria Math" panose="02040503050406030204" pitchFamily="18" charset="0"/>
+                          </a:rPr>
                         </m:ctrlPr>
                       </m:sSubSupPr>
                       <m:e>
@@ -4894,7 +5060,9 @@
                           <m:rPr>
                             <m:sty m:val="p"/>
                           </m:rPr>
-                          <a:rPr lang="fr-FR" sz="2500"/>
+                          <a:rPr lang="fr-FR" sz="2500">
+                            <a:latin typeface="Cambria Math" panose="02040503050406030204" pitchFamily="18" charset="0"/>
+                          </a:rPr>
                           <m:t>C</m:t>
                         </m:r>
                       </m:e>
@@ -4903,7 +5071,9 @@
                           <m:rPr>
                             <m:sty m:val="p"/>
                           </m:rPr>
-                          <a:rPr lang="fr-FR" sz="2500"/>
+                          <a:rPr lang="fr-FR" sz="2500">
+                            <a:latin typeface="Cambria Math" panose="02040503050406030204" pitchFamily="18" charset="0"/>
+                          </a:rPr>
                           <m:t>i</m:t>
                         </m:r>
                       </m:sub>
@@ -4912,11 +5082,15 @@
                           <m:rPr>
                             <m:sty m:val="p"/>
                           </m:rPr>
-                          <a:rPr lang="fr-FR" sz="2500"/>
+                          <a:rPr lang="fr-FR" sz="2500">
+                            <a:latin typeface="Cambria Math" panose="02040503050406030204" pitchFamily="18" charset="0"/>
+                          </a:rPr>
                           <m:t>t</m:t>
                         </m:r>
                         <m:r>
-                          <a:rPr lang="fr-FR" sz="2500"/>
+                          <a:rPr lang="fr-FR" sz="2500">
+                            <a:latin typeface="Cambria Math" panose="02040503050406030204" pitchFamily="18" charset="0"/>
+                          </a:rPr>
                           <m:t>+1</m:t>
                         </m:r>
                       </m:sup>
@@ -4944,66 +5118,90 @@
                     <m:sSubSup>
                       <m:sSubSupPr>
                         <m:ctrlPr>
-                          <a:rPr lang="fr-FR" sz="2500" i="1"/>
+                          <a:rPr lang="fr-FR" sz="2500" i="1">
+                            <a:latin typeface="Cambria Math" panose="02040503050406030204" pitchFamily="18" charset="0"/>
+                          </a:rPr>
                         </m:ctrlPr>
                       </m:sSubSupPr>
                       <m:e>
                         <m:r>
-                          <a:rPr lang="fr-FR" sz="2500" i="1"/>
+                          <a:rPr lang="fr-FR" sz="2500" i="1">
+                            <a:latin typeface="Cambria Math" panose="02040503050406030204" pitchFamily="18" charset="0"/>
+                          </a:rPr>
                           <m:t>𝐶</m:t>
                         </m:r>
                       </m:e>
                       <m:sub>
                         <m:r>
-                          <a:rPr lang="fr-FR" sz="2500" i="1"/>
+                          <a:rPr lang="fr-FR" sz="2500" i="1">
+                            <a:latin typeface="Cambria Math" panose="02040503050406030204" pitchFamily="18" charset="0"/>
+                          </a:rPr>
                           <m:t>𝑖</m:t>
                         </m:r>
                       </m:sub>
                       <m:sup>
                         <m:r>
-                          <a:rPr lang="fr-FR" sz="2500" i="1"/>
+                          <a:rPr lang="fr-FR" sz="2500" i="1">
+                            <a:latin typeface="Cambria Math" panose="02040503050406030204" pitchFamily="18" charset="0"/>
+                          </a:rPr>
                           <m:t>𝑡</m:t>
                         </m:r>
                       </m:sup>
                     </m:sSubSup>
                     <m:r>
-                      <a:rPr lang="fr-FR" sz="2500" i="1"/>
+                      <a:rPr lang="fr-FR" sz="2500" i="1">
+                        <a:latin typeface="Cambria Math" panose="02040503050406030204" pitchFamily="18" charset="0"/>
+                      </a:rPr>
                       <m:t>=</m:t>
                     </m:r>
                     <m:sSub>
                       <m:sSubPr>
                         <m:ctrlPr>
-                          <a:rPr lang="fr-FR" sz="2500" i="1"/>
+                          <a:rPr lang="fr-FR" sz="2500" i="1">
+                            <a:latin typeface="Cambria Math" panose="02040503050406030204" pitchFamily="18" charset="0"/>
+                          </a:rPr>
                         </m:ctrlPr>
                       </m:sSubPr>
                       <m:e>
                         <m:r>
-                          <a:rPr lang="fr-FR" sz="2500" i="1"/>
+                          <a:rPr lang="fr-FR" sz="2500" i="1">
+                            <a:latin typeface="Cambria Math" panose="02040503050406030204" pitchFamily="18" charset="0"/>
+                          </a:rPr>
                           <m:t>− </m:t>
                         </m:r>
                         <m:r>
                           <m:rPr>
                             <m:sty m:val="p"/>
                           </m:rPr>
-                          <a:rPr lang="fr-FR" sz="2500"/>
+                          <a:rPr lang="fr-FR" sz="2500">
+                            <a:latin typeface="Cambria Math" panose="02040503050406030204" pitchFamily="18" charset="0"/>
+                          </a:rPr>
                           <m:t>Δ</m:t>
                         </m:r>
                         <m:r>
-                          <a:rPr lang="fr-FR" sz="2500" i="1"/>
+                          <a:rPr lang="fr-FR" sz="2500" i="1">
+                            <a:latin typeface="Cambria Math" panose="02040503050406030204" pitchFamily="18" charset="0"/>
+                          </a:rPr>
                           <m:t>𝑡</m:t>
                         </m:r>
                         <m:r>
-                          <a:rPr lang="fr-FR" sz="2500"/>
+                          <a:rPr lang="fr-FR" sz="2500">
+                            <a:latin typeface="Cambria Math" panose="02040503050406030204" pitchFamily="18" charset="0"/>
+                          </a:rPr>
                           <m:t> </m:t>
                         </m:r>
                         <m:r>
-                          <a:rPr lang="fr-FR" sz="2500" i="1"/>
+                          <a:rPr lang="fr-FR" sz="2500" i="1">
+                            <a:latin typeface="Cambria Math" panose="02040503050406030204" pitchFamily="18" charset="0"/>
+                          </a:rPr>
                           <m:t>𝐷</m:t>
                         </m:r>
                       </m:e>
                       <m:sub>
                         <m:r>
-                          <a:rPr lang="fr-FR" sz="2500" i="1"/>
+                          <a:rPr lang="fr-FR" sz="2500" i="1">
+                            <a:latin typeface="Cambria Math" panose="02040503050406030204" pitchFamily="18" charset="0"/>
+                          </a:rPr>
                           <m:t>𝑒𝑓𝑓</m:t>
                         </m:r>
                       </m:sub>
@@ -5013,19 +5211,25 @@
                         <m:begChr m:val="["/>
                         <m:endChr m:val="]"/>
                         <m:ctrlPr>
-                          <a:rPr lang="fr-FR" sz="2500" i="1"/>
+                          <a:rPr lang="fr-FR" sz="2500" i="1">
+                            <a:latin typeface="Cambria Math" panose="02040503050406030204" pitchFamily="18" charset="0"/>
+                          </a:rPr>
                         </m:ctrlPr>
                       </m:dPr>
                       <m:e>
                         <m:f>
                           <m:fPr>
                             <m:ctrlPr>
-                              <a:rPr lang="fr-FR" sz="2500" i="1"/>
+                              <a:rPr lang="fr-FR" sz="2500" i="1">
+                                <a:latin typeface="Cambria Math" panose="02040503050406030204" pitchFamily="18" charset="0"/>
+                              </a:rPr>
                             </m:ctrlPr>
                           </m:fPr>
                           <m:num>
                             <m:r>
-                              <a:rPr lang="fr-FR" sz="2500"/>
+                              <a:rPr lang="fr-FR" sz="2500">
+                                <a:latin typeface="Cambria Math" panose="02040503050406030204" pitchFamily="18" charset="0"/>
+                              </a:rPr>
                               <m:t>1</m:t>
                             </m:r>
                           </m:num>
@@ -5033,7 +5237,9 @@
                             <m:sSub>
                               <m:sSubPr>
                                 <m:ctrlPr>
-                                  <a:rPr lang="fr-FR" sz="2500" i="1"/>
+                                  <a:rPr lang="fr-FR" sz="2500" i="1">
+                                    <a:latin typeface="Cambria Math" panose="02040503050406030204" pitchFamily="18" charset="0"/>
+                                  </a:rPr>
                                 </m:ctrlPr>
                               </m:sSubPr>
                               <m:e>
@@ -5041,7 +5247,9 @@
                                   <m:rPr>
                                     <m:sty m:val="p"/>
                                   </m:rPr>
-                                  <a:rPr lang="fr-FR" sz="2500"/>
+                                  <a:rPr lang="fr-FR" sz="2500">
+                                    <a:latin typeface="Cambria Math" panose="02040503050406030204" pitchFamily="18" charset="0"/>
+                                  </a:rPr>
                                   <m:t>r</m:t>
                                 </m:r>
                               </m:e>
@@ -5050,7 +5258,9 @@
                                   <m:rPr>
                                     <m:sty m:val="p"/>
                                   </m:rPr>
-                                  <a:rPr lang="fr-FR" sz="2500"/>
+                                  <a:rPr lang="fr-FR" sz="2500">
+                                    <a:latin typeface="Cambria Math" panose="02040503050406030204" pitchFamily="18" charset="0"/>
+                                  </a:rPr>
                                   <m:t>i</m:t>
                                 </m:r>
                               </m:sub>
@@ -5060,14 +5270,18 @@
                         <m:f>
                           <m:fPr>
                             <m:ctrlPr>
-                              <a:rPr lang="fr-FR" sz="2500" i="1"/>
+                              <a:rPr lang="fr-FR" sz="2500" i="1">
+                                <a:latin typeface="Cambria Math" panose="02040503050406030204" pitchFamily="18" charset="0"/>
+                              </a:rPr>
                             </m:ctrlPr>
                           </m:fPr>
                           <m:num>
                             <m:sSubSup>
                               <m:sSubSupPr>
                                 <m:ctrlPr>
-                                  <a:rPr lang="fr-FR" sz="2500" i="1"/>
+                                  <a:rPr lang="fr-FR" sz="2500" i="1">
+                                    <a:latin typeface="Cambria Math" panose="02040503050406030204" pitchFamily="18" charset="0"/>
+                                  </a:rPr>
                                 </m:ctrlPr>
                               </m:sSubSupPr>
                               <m:e>
@@ -5075,7 +5289,9 @@
                                   <m:rPr>
                                     <m:sty m:val="p"/>
                                   </m:rPr>
-                                  <a:rPr lang="fr-FR" sz="2500"/>
+                                  <a:rPr lang="fr-FR" sz="2500">
+                                    <a:latin typeface="Cambria Math" panose="02040503050406030204" pitchFamily="18" charset="0"/>
+                                  </a:rPr>
                                   <m:t>C</m:t>
                                 </m:r>
                               </m:e>
@@ -5084,11 +5300,15 @@
                                   <m:rPr>
                                     <m:sty m:val="p"/>
                                   </m:rPr>
-                                  <a:rPr lang="fr-FR" sz="2500"/>
+                                  <a:rPr lang="fr-FR" sz="2500">
+                                    <a:latin typeface="Cambria Math" panose="02040503050406030204" pitchFamily="18" charset="0"/>
+                                  </a:rPr>
                                   <m:t>i</m:t>
                                 </m:r>
                                 <m:r>
-                                  <a:rPr lang="fr-FR" sz="2500"/>
+                                  <a:rPr lang="fr-FR" sz="2500">
+                                    <a:latin typeface="Cambria Math" panose="02040503050406030204" pitchFamily="18" charset="0"/>
+                                  </a:rPr>
                                   <m:t>+1</m:t>
                                 </m:r>
                               </m:sub>
@@ -5097,23 +5317,31 @@
                                   <m:rPr>
                                     <m:sty m:val="p"/>
                                   </m:rPr>
-                                  <a:rPr lang="fr-FR" sz="2500"/>
+                                  <a:rPr lang="fr-FR" sz="2500">
+                                    <a:latin typeface="Cambria Math" panose="02040503050406030204" pitchFamily="18" charset="0"/>
+                                  </a:rPr>
                                   <m:t>t</m:t>
                                 </m:r>
                                 <m:r>
-                                  <a:rPr lang="fr-FR" sz="2500"/>
+                                  <a:rPr lang="fr-FR" sz="2500">
+                                    <a:latin typeface="Cambria Math" panose="02040503050406030204" pitchFamily="18" charset="0"/>
+                                  </a:rPr>
                                   <m:t>+1</m:t>
                                 </m:r>
                               </m:sup>
                             </m:sSubSup>
                             <m:r>
-                              <a:rPr lang="fr-FR" sz="2500"/>
+                              <a:rPr lang="fr-FR" sz="2500">
+                                <a:latin typeface="Cambria Math" panose="02040503050406030204" pitchFamily="18" charset="0"/>
+                              </a:rPr>
                               <m:t>−</m:t>
                             </m:r>
                             <m:sSubSup>
                               <m:sSubSupPr>
                                 <m:ctrlPr>
-                                  <a:rPr lang="fr-FR" sz="2500" i="1"/>
+                                  <a:rPr lang="fr-FR" sz="2500" i="1">
+                                    <a:latin typeface="Cambria Math" panose="02040503050406030204" pitchFamily="18" charset="0"/>
+                                  </a:rPr>
                                 </m:ctrlPr>
                               </m:sSubSupPr>
                               <m:e>
@@ -5121,7 +5349,9 @@
                                   <m:rPr>
                                     <m:sty m:val="p"/>
                                   </m:rPr>
-                                  <a:rPr lang="fr-FR" sz="2500"/>
+                                  <a:rPr lang="fr-FR" sz="2500">
+                                    <a:latin typeface="Cambria Math" panose="02040503050406030204" pitchFamily="18" charset="0"/>
+                                  </a:rPr>
                                   <m:t>C</m:t>
                                 </m:r>
                               </m:e>
@@ -5130,11 +5360,15 @@
                                   <m:rPr>
                                     <m:sty m:val="p"/>
                                   </m:rPr>
-                                  <a:rPr lang="fr-FR" sz="2500"/>
+                                  <a:rPr lang="fr-FR" sz="2500">
+                                    <a:latin typeface="Cambria Math" panose="02040503050406030204" pitchFamily="18" charset="0"/>
+                                  </a:rPr>
                                   <m:t>i</m:t>
                                 </m:r>
                                 <m:r>
-                                  <a:rPr lang="fr-FR" sz="2500"/>
+                                  <a:rPr lang="fr-FR" sz="2500">
+                                    <a:latin typeface="Cambria Math" panose="02040503050406030204" pitchFamily="18" charset="0"/>
+                                  </a:rPr>
                                   <m:t>−1</m:t>
                                 </m:r>
                               </m:sub>
@@ -5143,11 +5377,15 @@
                                   <m:rPr>
                                     <m:sty m:val="p"/>
                                   </m:rPr>
-                                  <a:rPr lang="fr-FR" sz="2500"/>
+                                  <a:rPr lang="fr-FR" sz="2500">
+                                    <a:latin typeface="Cambria Math" panose="02040503050406030204" pitchFamily="18" charset="0"/>
+                                  </a:rPr>
                                   <m:t>t</m:t>
                                 </m:r>
                                 <m:r>
-                                  <a:rPr lang="fr-FR" sz="2500"/>
+                                  <a:rPr lang="fr-FR" sz="2500">
+                                    <a:latin typeface="Cambria Math" panose="02040503050406030204" pitchFamily="18" charset="0"/>
+                                  </a:rPr>
                                   <m:t>+1</m:t>
                                 </m:r>
                               </m:sup>
@@ -5155,33 +5393,43 @@
                           </m:num>
                           <m:den>
                             <m:r>
-                              <a:rPr lang="fr-FR" sz="2500"/>
+                              <a:rPr lang="fr-FR" sz="2500">
+                                <a:latin typeface="Cambria Math" panose="02040503050406030204" pitchFamily="18" charset="0"/>
+                              </a:rPr>
                               <m:t>2</m:t>
                             </m:r>
                             <m:r>
                               <m:rPr>
                                 <m:sty m:val="p"/>
                               </m:rPr>
-                              <a:rPr lang="fr-FR" sz="2500"/>
+                              <a:rPr lang="fr-FR" sz="2500">
+                                <a:latin typeface="Cambria Math" panose="02040503050406030204" pitchFamily="18" charset="0"/>
+                              </a:rPr>
                               <m:t>Δr</m:t>
                             </m:r>
                           </m:den>
                         </m:f>
                         <m:r>
-                          <a:rPr lang="fr-FR" sz="2500" i="1"/>
+                          <a:rPr lang="fr-FR" sz="2500" i="1">
+                            <a:latin typeface="Cambria Math" panose="02040503050406030204" pitchFamily="18" charset="0"/>
+                          </a:rPr>
                           <m:t>+</m:t>
                         </m:r>
                         <m:f>
                           <m:fPr>
                             <m:ctrlPr>
-                              <a:rPr lang="fr-FR" sz="2500" i="1"/>
+                              <a:rPr lang="fr-FR" sz="2500" i="1">
+                                <a:latin typeface="Cambria Math" panose="02040503050406030204" pitchFamily="18" charset="0"/>
+                              </a:rPr>
                             </m:ctrlPr>
                           </m:fPr>
                           <m:num>
                             <m:sSubSup>
                               <m:sSubSupPr>
                                 <m:ctrlPr>
-                                  <a:rPr lang="fr-FR" sz="2500" i="1"/>
+                                  <a:rPr lang="fr-FR" sz="2500" i="1">
+                                    <a:latin typeface="Cambria Math" panose="02040503050406030204" pitchFamily="18" charset="0"/>
+                                  </a:rPr>
                                 </m:ctrlPr>
                               </m:sSubSupPr>
                               <m:e>
@@ -5189,7 +5437,9 @@
                                   <m:rPr>
                                     <m:sty m:val="p"/>
                                   </m:rPr>
-                                  <a:rPr lang="fr-FR" sz="2500"/>
+                                  <a:rPr lang="fr-FR" sz="2500">
+                                    <a:latin typeface="Cambria Math" panose="02040503050406030204" pitchFamily="18" charset="0"/>
+                                  </a:rPr>
                                   <m:t>C</m:t>
                                 </m:r>
                               </m:e>
@@ -5198,11 +5448,15 @@
                                   <m:rPr>
                                     <m:sty m:val="p"/>
                                   </m:rPr>
-                                  <a:rPr lang="fr-FR" sz="2500"/>
+                                  <a:rPr lang="fr-FR" sz="2500">
+                                    <a:latin typeface="Cambria Math" panose="02040503050406030204" pitchFamily="18" charset="0"/>
+                                  </a:rPr>
                                   <m:t>i</m:t>
                                 </m:r>
                                 <m:r>
-                                  <a:rPr lang="fr-FR" sz="2500"/>
+                                  <a:rPr lang="fr-FR" sz="2500">
+                                    <a:latin typeface="Cambria Math" panose="02040503050406030204" pitchFamily="18" charset="0"/>
+                                  </a:rPr>
                                   <m:t>+1</m:t>
                                 </m:r>
                               </m:sub>
@@ -5211,35 +5465,47 @@
                                   <m:rPr>
                                     <m:sty m:val="p"/>
                                   </m:rPr>
-                                  <a:rPr lang="fr-FR" sz="2500"/>
+                                  <a:rPr lang="fr-FR" sz="2500">
+                                    <a:latin typeface="Cambria Math" panose="02040503050406030204" pitchFamily="18" charset="0"/>
+                                  </a:rPr>
                                   <m:t>t</m:t>
                                 </m:r>
                                 <m:r>
-                                  <a:rPr lang="fr-FR" sz="2500"/>
+                                  <a:rPr lang="fr-FR" sz="2500">
+                                    <a:latin typeface="Cambria Math" panose="02040503050406030204" pitchFamily="18" charset="0"/>
+                                  </a:rPr>
                                   <m:t>+1</m:t>
                                 </m:r>
                               </m:sup>
                             </m:sSubSup>
                             <m:r>
-                              <a:rPr lang="fr-FR" sz="2500"/>
+                              <a:rPr lang="fr-FR" sz="2500">
+                                <a:latin typeface="Cambria Math" panose="02040503050406030204" pitchFamily="18" charset="0"/>
+                              </a:rPr>
                               <m:t>−</m:t>
                             </m:r>
                             <m:sSubSup>
                               <m:sSubSupPr>
                                 <m:ctrlPr>
-                                  <a:rPr lang="fr-FR" sz="2500" i="1"/>
+                                  <a:rPr lang="fr-FR" sz="2500" i="1">
+                                    <a:latin typeface="Cambria Math" panose="02040503050406030204" pitchFamily="18" charset="0"/>
+                                  </a:rPr>
                                 </m:ctrlPr>
                               </m:sSubSupPr>
                               <m:e>
                                 <m:r>
-                                  <a:rPr lang="fr-FR" sz="2500"/>
+                                  <a:rPr lang="fr-FR" sz="2500">
+                                    <a:latin typeface="Cambria Math" panose="02040503050406030204" pitchFamily="18" charset="0"/>
+                                  </a:rPr>
                                   <m:t>2</m:t>
                                 </m:r>
                                 <m:r>
                                   <m:rPr>
                                     <m:sty m:val="p"/>
                                   </m:rPr>
-                                  <a:rPr lang="fr-FR" sz="2500"/>
+                                  <a:rPr lang="fr-FR" sz="2500">
+                                    <a:latin typeface="Cambria Math" panose="02040503050406030204" pitchFamily="18" charset="0"/>
+                                  </a:rPr>
                                   <m:t>C</m:t>
                                 </m:r>
                               </m:e>
@@ -5248,7 +5514,9 @@
                                   <m:rPr>
                                     <m:sty m:val="p"/>
                                   </m:rPr>
-                                  <a:rPr lang="fr-FR" sz="2500"/>
+                                  <a:rPr lang="fr-FR" sz="2500">
+                                    <a:latin typeface="Cambria Math" panose="02040503050406030204" pitchFamily="18" charset="0"/>
+                                  </a:rPr>
                                   <m:t>i</m:t>
                                 </m:r>
                               </m:sub>
@@ -5257,23 +5525,31 @@
                                   <m:rPr>
                                     <m:sty m:val="p"/>
                                   </m:rPr>
-                                  <a:rPr lang="fr-FR" sz="2500"/>
+                                  <a:rPr lang="fr-FR" sz="2500">
+                                    <a:latin typeface="Cambria Math" panose="02040503050406030204" pitchFamily="18" charset="0"/>
+                                  </a:rPr>
                                   <m:t>t</m:t>
                                 </m:r>
                                 <m:r>
-                                  <a:rPr lang="fr-FR" sz="2500"/>
+                                  <a:rPr lang="fr-FR" sz="2500">
+                                    <a:latin typeface="Cambria Math" panose="02040503050406030204" pitchFamily="18" charset="0"/>
+                                  </a:rPr>
                                   <m:t>+1</m:t>
                                 </m:r>
                               </m:sup>
                             </m:sSubSup>
                             <m:r>
-                              <a:rPr lang="fr-FR" sz="2500" i="1"/>
+                              <a:rPr lang="fr-FR" sz="2500" i="1">
+                                <a:latin typeface="Cambria Math" panose="02040503050406030204" pitchFamily="18" charset="0"/>
+                              </a:rPr>
                               <m:t>+</m:t>
                             </m:r>
                             <m:sSubSup>
                               <m:sSubSupPr>
                                 <m:ctrlPr>
-                                  <a:rPr lang="fr-FR" sz="2500" i="1"/>
+                                  <a:rPr lang="fr-FR" sz="2500" i="1">
+                                    <a:latin typeface="Cambria Math" panose="02040503050406030204" pitchFamily="18" charset="0"/>
+                                  </a:rPr>
                                 </m:ctrlPr>
                               </m:sSubSupPr>
                               <m:e>
@@ -5281,7 +5557,9 @@
                                   <m:rPr>
                                     <m:sty m:val="p"/>
                                   </m:rPr>
-                                  <a:rPr lang="fr-FR" sz="2500"/>
+                                  <a:rPr lang="fr-FR" sz="2500">
+                                    <a:latin typeface="Cambria Math" panose="02040503050406030204" pitchFamily="18" charset="0"/>
+                                  </a:rPr>
                                   <m:t>C</m:t>
                                 </m:r>
                               </m:e>
@@ -5290,11 +5568,15 @@
                                   <m:rPr>
                                     <m:sty m:val="p"/>
                                   </m:rPr>
-                                  <a:rPr lang="fr-FR" sz="2500"/>
+                                  <a:rPr lang="fr-FR" sz="2500">
+                                    <a:latin typeface="Cambria Math" panose="02040503050406030204" pitchFamily="18" charset="0"/>
+                                  </a:rPr>
                                   <m:t>i</m:t>
                                 </m:r>
                                 <m:r>
-                                  <a:rPr lang="fr-FR" sz="2500"/>
+                                  <a:rPr lang="fr-FR" sz="2500">
+                                    <a:latin typeface="Cambria Math" panose="02040503050406030204" pitchFamily="18" charset="0"/>
+                                  </a:rPr>
                                   <m:t>−1</m:t>
                                 </m:r>
                               </m:sub>
@@ -5303,11 +5585,15 @@
                                   <m:rPr>
                                     <m:sty m:val="p"/>
                                   </m:rPr>
-                                  <a:rPr lang="fr-FR" sz="2500"/>
+                                  <a:rPr lang="fr-FR" sz="2500">
+                                    <a:latin typeface="Cambria Math" panose="02040503050406030204" pitchFamily="18" charset="0"/>
+                                  </a:rPr>
                                   <m:t>t</m:t>
                                 </m:r>
                                 <m:r>
-                                  <a:rPr lang="fr-FR" sz="2500"/>
+                                  <a:rPr lang="fr-FR" sz="2500">
+                                    <a:latin typeface="Cambria Math" panose="02040503050406030204" pitchFamily="18" charset="0"/>
+                                  </a:rPr>
                                   <m:t>+1</m:t>
                                 </m:r>
                               </m:sup>
@@ -5318,13 +5604,17 @@
                               <m:rPr>
                                 <m:sty m:val="p"/>
                               </m:rPr>
-                              <a:rPr lang="fr-FR" sz="2500"/>
+                              <a:rPr lang="fr-FR" sz="2500">
+                                <a:latin typeface="Cambria Math" panose="02040503050406030204" pitchFamily="18" charset="0"/>
+                              </a:rPr>
                               <m:t>Δ</m:t>
                             </m:r>
                             <m:sSup>
                               <m:sSupPr>
                                 <m:ctrlPr>
-                                  <a:rPr lang="fr-FR" sz="2500" i="1"/>
+                                  <a:rPr lang="fr-FR" sz="2500" i="1">
+                                    <a:latin typeface="Cambria Math" panose="02040503050406030204" pitchFamily="18" charset="0"/>
+                                  </a:rPr>
                                 </m:ctrlPr>
                               </m:sSupPr>
                               <m:e>
@@ -5332,13 +5622,17 @@
                                   <m:rPr>
                                     <m:sty m:val="p"/>
                                   </m:rPr>
-                                  <a:rPr lang="fr-FR" sz="2500"/>
+                                  <a:rPr lang="fr-FR" sz="2500">
+                                    <a:latin typeface="Cambria Math" panose="02040503050406030204" pitchFamily="18" charset="0"/>
+                                  </a:rPr>
                                   <m:t>r</m:t>
                                 </m:r>
                               </m:e>
                               <m:sup>
                                 <m:r>
-                                  <a:rPr lang="fr-FR" sz="2500"/>
+                                  <a:rPr lang="fr-FR" sz="2500">
+                                    <a:latin typeface="Cambria Math" panose="02040503050406030204" pitchFamily="18" charset="0"/>
+                                  </a:rPr>
                                   <m:t>2</m:t>
                                 </m:r>
                               </m:sup>
@@ -5348,13 +5642,17 @@
                       </m:e>
                     </m:d>
                     <m:r>
-                      <a:rPr lang="fr-FR" sz="2500" i="1"/>
+                      <a:rPr lang="fr-FR" sz="2500" i="1">
+                        <a:latin typeface="Cambria Math" panose="02040503050406030204" pitchFamily="18" charset="0"/>
+                      </a:rPr>
                       <m:t>+</m:t>
                     </m:r>
                     <m:sSubSup>
                       <m:sSubSupPr>
                         <m:ctrlPr>
-                          <a:rPr lang="fr-FR" sz="2500" i="1"/>
+                          <a:rPr lang="fr-FR" sz="2500" i="1">
+                            <a:latin typeface="Cambria Math" panose="02040503050406030204" pitchFamily="18" charset="0"/>
+                          </a:rPr>
                         </m:ctrlPr>
                       </m:sSubSupPr>
                       <m:e>
@@ -5362,7 +5660,9 @@
                           <m:rPr>
                             <m:sty m:val="p"/>
                           </m:rPr>
-                          <a:rPr lang="fr-FR" sz="2500"/>
+                          <a:rPr lang="fr-FR" sz="2500">
+                            <a:latin typeface="Cambria Math" panose="02040503050406030204" pitchFamily="18" charset="0"/>
+                          </a:rPr>
                           <m:t>C</m:t>
                         </m:r>
                       </m:e>
@@ -5371,7 +5671,9 @@
                           <m:rPr>
                             <m:sty m:val="p"/>
                           </m:rPr>
-                          <a:rPr lang="fr-FR" sz="2500"/>
+                          <a:rPr lang="fr-FR" sz="2500">
+                            <a:latin typeface="Cambria Math" panose="02040503050406030204" pitchFamily="18" charset="0"/>
+                          </a:rPr>
                           <m:t>i</m:t>
                         </m:r>
                       </m:sub>
@@ -5380,11 +5682,15 @@
                           <m:rPr>
                             <m:sty m:val="p"/>
                           </m:rPr>
-                          <a:rPr lang="fr-FR" sz="2500"/>
+                          <a:rPr lang="fr-FR" sz="2500">
+                            <a:latin typeface="Cambria Math" panose="02040503050406030204" pitchFamily="18" charset="0"/>
+                          </a:rPr>
                           <m:t>t</m:t>
                         </m:r>
                         <m:r>
-                          <a:rPr lang="fr-FR" sz="2500"/>
+                          <a:rPr lang="fr-FR" sz="2500">
+                            <a:latin typeface="Cambria Math" panose="02040503050406030204" pitchFamily="18" charset="0"/>
+                          </a:rPr>
                           <m:t>+1</m:t>
                         </m:r>
                       </m:sup>
@@ -5392,27 +5698,37 @@
                     <m:d>
                       <m:dPr>
                         <m:ctrlPr>
-                          <a:rPr lang="fr-FR" sz="2500" i="1"/>
+                          <a:rPr lang="fr-FR" sz="2500" i="1">
+                            <a:latin typeface="Cambria Math" panose="02040503050406030204" pitchFamily="18" charset="0"/>
+                          </a:rPr>
                         </m:ctrlPr>
                       </m:dPr>
                       <m:e>
                         <m:r>
-                          <a:rPr lang="fr-FR" sz="2500" i="1"/>
+                          <a:rPr lang="fr-FR" sz="2500" i="1">
+                            <a:latin typeface="Cambria Math" panose="02040503050406030204" pitchFamily="18" charset="0"/>
+                          </a:rPr>
                           <m:t>𝑘</m:t>
                         </m:r>
                         <m:r>
                           <m:rPr>
                             <m:sty m:val="p"/>
                           </m:rPr>
-                          <a:rPr lang="fr-FR" sz="2500"/>
+                          <a:rPr lang="fr-FR" sz="2500">
+                            <a:latin typeface="Cambria Math" panose="02040503050406030204" pitchFamily="18" charset="0"/>
+                          </a:rPr>
                           <m:t>Δ</m:t>
                         </m:r>
                         <m:r>
-                          <a:rPr lang="fr-FR" sz="2500" i="1"/>
+                          <a:rPr lang="fr-FR" sz="2500" i="1">
+                            <a:latin typeface="Cambria Math" panose="02040503050406030204" pitchFamily="18" charset="0"/>
+                          </a:rPr>
                           <m:t>𝑡</m:t>
                         </m:r>
                         <m:r>
-                          <a:rPr lang="fr-FR" sz="2500" i="1"/>
+                          <a:rPr lang="fr-FR" sz="2500" i="1">
+                            <a:latin typeface="Cambria Math" panose="02040503050406030204" pitchFamily="18" charset="0"/>
+                          </a:rPr>
                           <m:t>+1</m:t>
                         </m:r>
                       </m:e>
@@ -5440,29 +5756,39 @@
                     <m:f>
                       <m:fPr>
                         <m:ctrlPr>
-                          <a:rPr lang="fr-FR" sz="2500" i="1"/>
+                          <a:rPr lang="fr-FR" sz="2500" i="1">
+                            <a:latin typeface="Cambria Math" panose="02040503050406030204" pitchFamily="18" charset="0"/>
+                          </a:rPr>
                         </m:ctrlPr>
                       </m:fPr>
                       <m:num>
                         <m:r>
-                          <a:rPr lang="fr-FR" sz="2500"/>
-                          <m:t>∂</m:t>
-                        </m:r>
-                        <m:r>
-                          <a:rPr lang="fr-FR" sz="2500" i="1"/>
+                          <a:rPr lang="fr-FR" sz="2500">
+                            <a:latin typeface="Cambria Math" panose="02040503050406030204" pitchFamily="18" charset="0"/>
+                          </a:rPr>
+                          <m:t>𝜕</m:t>
+                        </m:r>
+                        <m:r>
+                          <a:rPr lang="fr-FR" sz="2500" i="1">
+                            <a:latin typeface="Cambria Math" panose="02040503050406030204" pitchFamily="18" charset="0"/>
+                          </a:rPr>
                           <m:t>𝐶</m:t>
                         </m:r>
                       </m:num>
                       <m:den>
                         <m:r>
-                          <a:rPr lang="fr-FR" sz="2500"/>
-                          <m:t>∂</m:t>
+                          <a:rPr lang="fr-FR" sz="2500">
+                            <a:latin typeface="Cambria Math" panose="02040503050406030204" pitchFamily="18" charset="0"/>
+                          </a:rPr>
+                          <m:t>𝜕</m:t>
                         </m:r>
                         <m:r>
                           <m:rPr>
                             <m:sty m:val="p"/>
                           </m:rPr>
-                          <a:rPr lang="fr-FR" sz="2500"/>
+                          <a:rPr lang="fr-FR" sz="2500">
+                            <a:latin typeface="Cambria Math" panose="02040503050406030204" pitchFamily="18" charset="0"/>
+                          </a:rPr>
                           <m:t>r</m:t>
                         </m:r>
                       </m:den>
@@ -5470,7 +5796,9 @@
                     <m:sSub>
                       <m:sSubPr>
                         <m:ctrlPr>
-                          <a:rPr lang="fr-FR" sz="2500" i="1"/>
+                          <a:rPr lang="fr-FR" sz="2500" i="1">
+                            <a:latin typeface="Cambria Math" panose="02040503050406030204" pitchFamily="18" charset="0"/>
+                          </a:rPr>
                         </m:ctrlPr>
                       </m:sSubPr>
                       <m:e>
@@ -5479,12 +5807,16 @@
                             <m:begChr m:val=""/>
                             <m:endChr m:val="|"/>
                             <m:ctrlPr>
-                              <a:rPr lang="fr-FR" sz="2500" i="1"/>
+                              <a:rPr lang="fr-FR" sz="2500" i="1">
+                                <a:latin typeface="Cambria Math" panose="02040503050406030204" pitchFamily="18" charset="0"/>
+                              </a:rPr>
                             </m:ctrlPr>
                           </m:dPr>
                           <m:e>
                             <m:r>
-                              <a:rPr lang="fr-FR" sz="2500" i="1"/>
+                              <a:rPr lang="fr-FR" sz="2500" i="1">
+                                <a:latin typeface="Cambria Math" panose="02040503050406030204" pitchFamily="18" charset="0"/>
+                              </a:rPr>
                               <m:t>​</m:t>
                             </m:r>
                           </m:e>
@@ -5495,28 +5827,38 @@
                           <m:rPr>
                             <m:sty m:val="p"/>
                           </m:rPr>
-                          <a:rPr lang="fr-FR" sz="2500"/>
+                          <a:rPr lang="fr-FR" sz="2500">
+                            <a:latin typeface="Cambria Math" panose="02040503050406030204" pitchFamily="18" charset="0"/>
+                          </a:rPr>
                           <m:t>i</m:t>
                         </m:r>
                         <m:r>
-                          <a:rPr lang="fr-FR" sz="2500"/>
+                          <a:rPr lang="fr-FR" sz="2500">
+                            <a:latin typeface="Cambria Math" panose="02040503050406030204" pitchFamily="18" charset="0"/>
+                          </a:rPr>
                           <m:t>=0,</m:t>
                         </m:r>
                         <m:r>
                           <m:rPr>
                             <m:sty m:val="p"/>
                           </m:rPr>
-                          <a:rPr lang="fr-FR" sz="2500"/>
+                          <a:rPr lang="fr-FR" sz="2500">
+                            <a:latin typeface="Cambria Math" panose="02040503050406030204" pitchFamily="18" charset="0"/>
+                          </a:rPr>
                           <m:t>t</m:t>
                         </m:r>
                         <m:r>
-                          <a:rPr lang="fr-FR" sz="2500"/>
+                          <a:rPr lang="fr-FR" sz="2500">
+                            <a:latin typeface="Cambria Math" panose="02040503050406030204" pitchFamily="18" charset="0"/>
+                          </a:rPr>
                           <m:t>+1</m:t>
                         </m:r>
                       </m:sub>
                     </m:sSub>
                     <m:r>
-                      <a:rPr lang="fr-FR" sz="2500" i="1"/>
+                      <a:rPr lang="fr-FR" sz="2500" i="1">
+                        <a:latin typeface="Cambria Math" panose="02040503050406030204" pitchFamily="18" charset="0"/>
+                      </a:rPr>
                       <m:t>=0</m:t>
                     </m:r>
                   </m:oMath>
@@ -5751,7 +6093,7 @@
             </p:txBody>
           </p:sp>
         </mc:Choice>
-        <mc:Fallback>
+        <mc:Fallback xmlns="">
           <p:sp>
             <p:nvSpPr>
               <p:cNvPr id="3" name="Espace réservé du contenu 2">
@@ -5864,8 +6206,8 @@
           </a:p>
         </p:txBody>
       </p:sp>
-      <mc:AlternateContent xmlns:mc="http://schemas.openxmlformats.org/markup-compatibility/2006">
-        <mc:Choice xmlns:a14="http://schemas.microsoft.com/office/drawing/2010/main" Requires="a14">
+      <mc:AlternateContent xmlns:mc="http://schemas.openxmlformats.org/markup-compatibility/2006" xmlns:a14="http://schemas.microsoft.com/office/drawing/2010/main">
+        <mc:Choice Requires="a14">
           <p:sp>
             <p:nvSpPr>
               <p:cNvPr id="3" name="Espace réservé du contenu 2">
@@ -5912,14 +6254,18 @@
                     <m:sSubSup>
                       <m:sSubSupPr>
                         <m:ctrlPr>
-                          <a:rPr lang="fr-FR" sz="2500" i="1"/>
+                          <a:rPr lang="fr-FR" sz="2500" i="1">
+                            <a:latin typeface="Cambria Math" panose="02040503050406030204" pitchFamily="18" charset="0"/>
+                          </a:rPr>
                         </m:ctrlPr>
                       </m:sSubSupPr>
                       <m:e>
                         <m:sSubSup>
                           <m:sSubSupPr>
                             <m:ctrlPr>
-                              <a:rPr lang="fr-FR" sz="2500" i="1"/>
+                              <a:rPr lang="fr-FR" sz="2500" i="1">
+                                <a:latin typeface="Cambria Math" panose="02040503050406030204" pitchFamily="18" charset="0"/>
+                              </a:rPr>
                             </m:ctrlPr>
                           </m:sSubSupPr>
                           <m:e>
@@ -5927,13 +6273,17 @@
                               <m:rPr>
                                 <m:sty m:val="p"/>
                               </m:rPr>
-                              <a:rPr lang="fr-FR" sz="2500"/>
+                              <a:rPr lang="fr-FR" sz="2500">
+                                <a:latin typeface="Cambria Math" panose="02040503050406030204" pitchFamily="18" charset="0"/>
+                              </a:rPr>
                               <m:t>C</m:t>
                             </m:r>
                           </m:e>
                           <m:sub>
                             <m:r>
-                              <a:rPr lang="fr-FR" sz="2500"/>
+                              <a:rPr lang="fr-FR" sz="2500">
+                                <a:latin typeface="Cambria Math" panose="02040503050406030204" pitchFamily="18" charset="0"/>
+                              </a:rPr>
                               <m:t>0</m:t>
                             </m:r>
                           </m:sub>
@@ -5942,96 +6292,128 @@
                               <m:rPr>
                                 <m:sty m:val="p"/>
                               </m:rPr>
-                              <a:rPr lang="fr-FR" sz="2500"/>
+                              <a:rPr lang="fr-FR" sz="2500">
+                                <a:latin typeface="Cambria Math" panose="02040503050406030204" pitchFamily="18" charset="0"/>
+                              </a:rPr>
                               <m:t>t</m:t>
                             </m:r>
                           </m:sup>
                         </m:sSubSup>
                         <m:r>
-                          <a:rPr lang="fr-FR" sz="2500"/>
+                          <a:rPr lang="fr-FR" sz="2500">
+                            <a:latin typeface="Cambria Math" panose="02040503050406030204" pitchFamily="18" charset="0"/>
+                          </a:rPr>
                           <m:t>=−</m:t>
                         </m:r>
                         <m:f>
                           <m:fPr>
                             <m:ctrlPr>
-                              <a:rPr lang="fr-FR" sz="2500" i="1"/>
+                              <a:rPr lang="fr-FR" sz="2500" i="1">
+                                <a:latin typeface="Cambria Math" panose="02040503050406030204" pitchFamily="18" charset="0"/>
+                              </a:rPr>
                             </m:ctrlPr>
                           </m:fPr>
                           <m:num>
                             <m:r>
-                              <a:rPr lang="fr-FR" sz="2500"/>
+                              <a:rPr lang="fr-FR" sz="2500">
+                                <a:latin typeface="Cambria Math" panose="02040503050406030204" pitchFamily="18" charset="0"/>
+                              </a:rPr>
                               <m:t>1</m:t>
                             </m:r>
                           </m:num>
                           <m:den>
                             <m:r>
-                              <a:rPr lang="fr-FR" sz="2500"/>
+                              <a:rPr lang="fr-FR" sz="2500">
+                                <a:latin typeface="Cambria Math" panose="02040503050406030204" pitchFamily="18" charset="0"/>
+                              </a:rPr>
                               <m:t>3</m:t>
                             </m:r>
                           </m:den>
                         </m:f>
                         <m:r>
-                          <a:rPr lang="fr-FR" sz="2500" i="1"/>
+                          <a:rPr lang="fr-FR" sz="2500" i="1">
+                            <a:latin typeface="Cambria Math" panose="02040503050406030204" pitchFamily="18" charset="0"/>
+                          </a:rPr>
                           <m:t>𝐶</m:t>
                         </m:r>
                       </m:e>
                       <m:sub>
                         <m:r>
-                          <a:rPr lang="fr-FR" sz="2500" i="1"/>
+                          <a:rPr lang="fr-FR" sz="2500" i="1">
+                            <a:latin typeface="Cambria Math" panose="02040503050406030204" pitchFamily="18" charset="0"/>
+                          </a:rPr>
                           <m:t>2</m:t>
                         </m:r>
                       </m:sub>
                       <m:sup>
                         <m:r>
-                          <a:rPr lang="fr-FR" sz="2500" i="1"/>
+                          <a:rPr lang="fr-FR" sz="2500" i="1">
+                            <a:latin typeface="Cambria Math" panose="02040503050406030204" pitchFamily="18" charset="0"/>
+                          </a:rPr>
                           <m:t>𝑡</m:t>
                         </m:r>
                       </m:sup>
                     </m:sSubSup>
                     <m:r>
-                      <a:rPr lang="fr-FR" sz="2500" i="1"/>
+                      <a:rPr lang="fr-FR" sz="2500" i="1">
+                        <a:latin typeface="Cambria Math" panose="02040503050406030204" pitchFamily="18" charset="0"/>
+                      </a:rPr>
                       <m:t>+</m:t>
                     </m:r>
                     <m:sSubSup>
                       <m:sSubSupPr>
                         <m:ctrlPr>
-                          <a:rPr lang="fr-FR" sz="2500" i="1"/>
+                          <a:rPr lang="fr-FR" sz="2500" i="1">
+                            <a:latin typeface="Cambria Math" panose="02040503050406030204" pitchFamily="18" charset="0"/>
+                          </a:rPr>
                         </m:ctrlPr>
                       </m:sSubSupPr>
                       <m:e>
                         <m:f>
                           <m:fPr>
                             <m:ctrlPr>
-                              <a:rPr lang="fr-FR" sz="2500" i="1"/>
+                              <a:rPr lang="fr-FR" sz="2500" i="1">
+                                <a:latin typeface="Cambria Math" panose="02040503050406030204" pitchFamily="18" charset="0"/>
+                              </a:rPr>
                             </m:ctrlPr>
                           </m:fPr>
                           <m:num>
                             <m:r>
-                              <a:rPr lang="fr-FR" sz="2500"/>
+                              <a:rPr lang="fr-FR" sz="2500">
+                                <a:latin typeface="Cambria Math" panose="02040503050406030204" pitchFamily="18" charset="0"/>
+                              </a:rPr>
                               <m:t>4</m:t>
                             </m:r>
                           </m:num>
                           <m:den>
                             <m:r>
-                              <a:rPr lang="fr-FR" sz="2500"/>
+                              <a:rPr lang="fr-FR" sz="2500">
+                                <a:latin typeface="Cambria Math" panose="02040503050406030204" pitchFamily="18" charset="0"/>
+                              </a:rPr>
                               <m:t>3</m:t>
                             </m:r>
                           </m:den>
                         </m:f>
                         <m:r>
-                          <a:rPr lang="fr-FR" sz="2500" i="1"/>
+                          <a:rPr lang="fr-FR" sz="2500" i="1">
+                            <a:latin typeface="Cambria Math" panose="02040503050406030204" pitchFamily="18" charset="0"/>
+                          </a:rPr>
                           <m:t>𝐶</m:t>
                         </m:r>
                       </m:e>
                       <m:sub>
                         <m:r>
-                          <a:rPr lang="fr-FR" sz="2500"/>
+                          <a:rPr lang="fr-FR" sz="2500">
+                            <a:latin typeface="Cambria Math" panose="02040503050406030204" pitchFamily="18" charset="0"/>
+                          </a:rPr>
                           <m:t>1</m:t>
                         </m:r>
                       </m:sub>
                       <m:sup>
                         <m:r>
-                          <a:rPr lang="fr-FR" sz="2500" i="1"/>
+                          <a:rPr lang="fr-FR" sz="2500" i="1">
+                            <a:latin typeface="Cambria Math" panose="02040503050406030204" pitchFamily="18" charset="0"/>
+                          </a:rPr>
                           <m:t>𝑡</m:t>
                         </m:r>
                       </m:sup>
@@ -6655,13 +7037,7 @@
                           <a:rPr lang="fr-FR" sz="2500" i="1">
                             <a:latin typeface="Cambria Math" panose="02040503050406030204" pitchFamily="18" charset="0"/>
                           </a:rPr>
-                          <m:t>=</m:t>
-                        </m:r>
-                        <m:r>
-                          <a:rPr lang="fr-FR" sz="2500" i="1">
-                            <a:latin typeface="Cambria Math" panose="02040503050406030204" pitchFamily="18" charset="0"/>
-                          </a:rPr>
-                          <m:t>− </m:t>
+                          <m:t>=− </m:t>
                         </m:r>
                         <m:r>
                           <m:rPr>
@@ -7223,13 +7599,7 @@
                           <a:rPr lang="fr-FR" sz="2500" i="1">
                             <a:latin typeface="Cambria Math" panose="02040503050406030204" pitchFamily="18" charset="0"/>
                           </a:rPr>
-                          <m:t>=</m:t>
-                        </m:r>
-                        <m:r>
-                          <a:rPr lang="fr-FR" sz="2500" i="1">
-                            <a:latin typeface="Cambria Math" panose="02040503050406030204" pitchFamily="18" charset="0"/>
-                          </a:rPr>
-                          <m:t>− </m:t>
+                          <m:t>=− </m:t>
                         </m:r>
                         <m:r>
                           <m:rPr>
@@ -7791,13 +8161,7 @@
                           <a:rPr lang="fr-FR" sz="2500" i="1">
                             <a:latin typeface="Cambria Math" panose="02040503050406030204" pitchFamily="18" charset="0"/>
                           </a:rPr>
-                          <m:t>=</m:t>
-                        </m:r>
-                        <m:r>
-                          <a:rPr lang="fr-FR" sz="2500" i="1">
-                            <a:latin typeface="Cambria Math" panose="02040503050406030204" pitchFamily="18" charset="0"/>
-                          </a:rPr>
-                          <m:t>− </m:t>
+                          <m:t>=− </m:t>
                         </m:r>
                         <m:r>
                           <m:rPr>
@@ -7890,7 +8254,7 @@
                             <m:sSub>
                               <m:sSubPr>
                                 <m:ctrlPr>
-                                  <a:rPr lang="fr-FR" sz="2500" b="0" i="0" smtClean="0">
+                                  <a:rPr lang="fr-FR" sz="2500" b="0" i="1" smtClean="0">
                                     <a:latin typeface="Cambria Math" panose="02040503050406030204" pitchFamily="18" charset="0"/>
                                   </a:rPr>
                                 </m:ctrlPr>
@@ -8006,7 +8370,7 @@
                             <m:sSub>
                               <m:sSubPr>
                                 <m:ctrlPr>
-                                  <a:rPr lang="fr-FR" sz="2500" b="0" i="0" smtClean="0">
+                                  <a:rPr lang="fr-FR" sz="2500" b="0" i="1" smtClean="0">
                                     <a:latin typeface="Cambria Math" panose="02040503050406030204" pitchFamily="18" charset="0"/>
                                   </a:rPr>
                                 </m:ctrlPr>
@@ -8327,7 +8691,7 @@
                     <m:sSub>
                       <m:sSubPr>
                         <m:ctrlPr>
-                          <a:rPr lang="fr-FR" sz="2500" b="0" i="0" smtClean="0">
+                          <a:rPr lang="fr-FR" sz="2500" b="0" i="1" smtClean="0">
                             <a:latin typeface="Cambria Math" panose="02040503050406030204" pitchFamily="18" charset="0"/>
                           </a:rPr>
                         </m:ctrlPr>
@@ -8374,7 +8738,7 @@
             </p:txBody>
           </p:sp>
         </mc:Choice>
-        <mc:Fallback>
+        <mc:Fallback xmlns="">
           <p:sp>
             <p:nvSpPr>
               <p:cNvPr id="3" name="Espace réservé du contenu 2">
@@ -8807,32 +9171,38 @@
                 <a14:m>
                   <m:oMath xmlns:m="http://schemas.openxmlformats.org/officeDocument/2006/math">
                     <m:r>
-                      <a:rPr lang="fr-FR" sz="2200" i="1"/>
+                      <a:rPr lang="fr-FR" sz="2200" i="1">
+                        <a:latin typeface="Cambria Math" panose="02040503050406030204" pitchFamily="18" charset="0"/>
+                      </a:rPr>
                       <m:t>𝐵</m:t>
                     </m:r>
                     <m:r>
-                      <a:rPr lang="fr-FR" sz="2200" i="1"/>
+                      <a:rPr lang="fr-FR" sz="2200" i="1">
+                        <a:latin typeface="Cambria Math" panose="02040503050406030204" pitchFamily="18" charset="0"/>
+                      </a:rPr>
                       <m:t>=</m:t>
                     </m:r>
                     <m:sSub>
                       <m:sSubPr>
                         <m:ctrlPr>
-                          <a:rPr lang="fr-FR" sz="2200" i="1"/>
+                          <a:rPr lang="fr-FR" sz="2200" i="1">
+                            <a:latin typeface="Cambria Math" panose="02040503050406030204" pitchFamily="18" charset="0"/>
+                          </a:rPr>
                         </m:ctrlPr>
                       </m:sSubPr>
                       <m:e>
                         <m:r>
-                          <a:rPr lang="fr-FR" sz="2200"/>
-                          <m:t>−</m:t>
-                        </m:r>
-                        <m:r>
-                          <a:rPr lang="fr-FR" sz="2200" i="1"/>
+                          <a:rPr lang="fr-FR" sz="2200" i="1">
+                            <a:latin typeface="Cambria Math" panose="02040503050406030204" pitchFamily="18" charset="0"/>
+                          </a:rPr>
                           <m:t>𝐷</m:t>
                         </m:r>
                       </m:e>
                       <m:sub>
                         <m:r>
-                          <a:rPr lang="fr-FR" sz="2200" i="1"/>
+                          <a:rPr lang="fr-FR" sz="2200" i="1">
+                            <a:latin typeface="Cambria Math" panose="02040503050406030204" pitchFamily="18" charset="0"/>
+                          </a:rPr>
                           <m:t>𝑒𝑓𝑓</m:t>
                         </m:r>
                       </m:sub>
@@ -8841,22 +9211,30 @@
                       <m:rPr>
                         <m:sty m:val="p"/>
                       </m:rPr>
-                      <a:rPr lang="fr-FR" sz="2200"/>
+                      <a:rPr lang="fr-FR" sz="2200">
+                        <a:latin typeface="Cambria Math" panose="02040503050406030204" pitchFamily="18" charset="0"/>
+                      </a:rPr>
                       <m:t>Δ</m:t>
                     </m:r>
                     <m:r>
-                      <a:rPr lang="fr-FR" sz="2200" i="1"/>
+                      <a:rPr lang="fr-FR" sz="2200" i="1">
+                        <a:latin typeface="Cambria Math" panose="02040503050406030204" pitchFamily="18" charset="0"/>
+                      </a:rPr>
                       <m:t>𝑡</m:t>
                     </m:r>
                     <m:f>
                       <m:fPr>
                         <m:ctrlPr>
-                          <a:rPr lang="fr-FR" sz="2200" i="1"/>
+                          <a:rPr lang="fr-FR" sz="2200" i="1">
+                            <a:latin typeface="Cambria Math" panose="02040503050406030204" pitchFamily="18" charset="0"/>
+                          </a:rPr>
                         </m:ctrlPr>
                       </m:fPr>
                       <m:num>
                         <m:r>
-                          <a:rPr lang="fr-FR" sz="2200"/>
+                          <a:rPr lang="fr-FR" sz="2200">
+                            <a:latin typeface="Cambria Math" panose="02040503050406030204" pitchFamily="18" charset="0"/>
+                          </a:rPr>
                           <m:t>2</m:t>
                         </m:r>
                       </m:num>
@@ -8865,13 +9243,17 @@
                           <m:rPr>
                             <m:sty m:val="p"/>
                           </m:rPr>
-                          <a:rPr lang="fr-FR" sz="2200"/>
+                          <a:rPr lang="fr-FR" sz="2200">
+                            <a:latin typeface="Cambria Math" panose="02040503050406030204" pitchFamily="18" charset="0"/>
+                          </a:rPr>
                           <m:t>Δ</m:t>
                         </m:r>
                         <m:sSup>
                           <m:sSupPr>
                             <m:ctrlPr>
-                              <a:rPr lang="fr-FR" sz="2200" i="1"/>
+                              <a:rPr lang="fr-FR" sz="2200" i="1">
+                                <a:latin typeface="Cambria Math" panose="02040503050406030204" pitchFamily="18" charset="0"/>
+                              </a:rPr>
                             </m:ctrlPr>
                           </m:sSupPr>
                           <m:e>
@@ -8879,13 +9261,17 @@
                               <m:rPr>
                                 <m:sty m:val="p"/>
                               </m:rPr>
-                              <a:rPr lang="fr-FR" sz="2200"/>
+                              <a:rPr lang="fr-FR" sz="2200">
+                                <a:latin typeface="Cambria Math" panose="02040503050406030204" pitchFamily="18" charset="0"/>
+                              </a:rPr>
                               <m:t>r</m:t>
                             </m:r>
                           </m:e>
                           <m:sup>
                             <m:r>
-                              <a:rPr lang="fr-FR" sz="2200"/>
+                              <a:rPr lang="fr-FR" sz="2200">
+                                <a:latin typeface="Cambria Math" panose="02040503050406030204" pitchFamily="18" charset="0"/>
+                              </a:rPr>
                               <m:t>2</m:t>
                             </m:r>
                           </m:sup>
@@ -8893,26 +9279,36 @@
                       </m:den>
                     </m:f>
                     <m:r>
-                      <a:rPr lang="fr-FR" sz="2200" i="1"/>
+                      <a:rPr lang="fr-FR" sz="2200" i="1">
+                        <a:latin typeface="Cambria Math" panose="02040503050406030204" pitchFamily="18" charset="0"/>
+                      </a:rPr>
                       <m:t>+</m:t>
                     </m:r>
                     <m:r>
-                      <a:rPr lang="fr-FR" sz="2200" i="1"/>
+                      <a:rPr lang="fr-FR" sz="2200" i="1">
+                        <a:latin typeface="Cambria Math" panose="02040503050406030204" pitchFamily="18" charset="0"/>
+                      </a:rPr>
                       <m:t>𝑘</m:t>
                     </m:r>
                     <m:r>
                       <m:rPr>
                         <m:sty m:val="p"/>
                       </m:rPr>
-                      <a:rPr lang="fr-FR" sz="2200"/>
+                      <a:rPr lang="fr-FR" sz="2200">
+                        <a:latin typeface="Cambria Math" panose="02040503050406030204" pitchFamily="18" charset="0"/>
+                      </a:rPr>
                       <m:t>Δ</m:t>
                     </m:r>
                     <m:r>
-                      <a:rPr lang="fr-FR" sz="2200" i="1"/>
+                      <a:rPr lang="fr-FR" sz="2200" i="1">
+                        <a:latin typeface="Cambria Math" panose="02040503050406030204" pitchFamily="18" charset="0"/>
+                      </a:rPr>
                       <m:t>𝑡</m:t>
                     </m:r>
                     <m:r>
-                      <a:rPr lang="fr-FR" sz="2200" i="1"/>
+                      <a:rPr lang="fr-FR" sz="2200" i="1">
+                        <a:latin typeface="Cambria Math" panose="02040503050406030204" pitchFamily="18" charset="0"/>
+                      </a:rPr>
                       <m:t> +1</m:t>
                     </m:r>
                   </m:oMath>
@@ -8924,32 +9320,44 @@
                 <a14:m>
                   <m:oMath xmlns:m="http://schemas.openxmlformats.org/officeDocument/2006/math">
                     <m:r>
-                      <a:rPr lang="fr-FR" sz="2200" i="1"/>
+                      <a:rPr lang="fr-FR" sz="2200" i="1">
+                        <a:latin typeface="Cambria Math" panose="02040503050406030204" pitchFamily="18" charset="0"/>
+                      </a:rPr>
                       <m:t>𝐶</m:t>
                     </m:r>
                     <m:r>
-                      <a:rPr lang="fr-FR" sz="2200" i="1"/>
+                      <a:rPr lang="fr-FR" sz="2200" i="1">
+                        <a:latin typeface="Cambria Math" panose="02040503050406030204" pitchFamily="18" charset="0"/>
+                      </a:rPr>
                       <m:t>=</m:t>
                     </m:r>
                     <m:sSub>
                       <m:sSubPr>
                         <m:ctrlPr>
-                          <a:rPr lang="fr-FR" sz="2200" i="1"/>
+                          <a:rPr lang="fr-FR" sz="2200" i="1">
+                            <a:latin typeface="Cambria Math" panose="02040503050406030204" pitchFamily="18" charset="0"/>
+                          </a:rPr>
                         </m:ctrlPr>
                       </m:sSubPr>
                       <m:e>
                         <m:r>
-                          <a:rPr lang="fr-FR" sz="2200"/>
+                          <a:rPr lang="fr-FR" sz="2200">
+                            <a:latin typeface="Cambria Math" panose="02040503050406030204" pitchFamily="18" charset="0"/>
+                          </a:rPr>
                           <m:t>−</m:t>
                         </m:r>
                         <m:r>
-                          <a:rPr lang="fr-FR" sz="2200" i="1"/>
+                          <a:rPr lang="fr-FR" sz="2200" i="1">
+                            <a:latin typeface="Cambria Math" panose="02040503050406030204" pitchFamily="18" charset="0"/>
+                          </a:rPr>
                           <m:t>𝐷</m:t>
                         </m:r>
                       </m:e>
                       <m:sub>
                         <m:r>
-                          <a:rPr lang="fr-FR" sz="2200" i="1"/>
+                          <a:rPr lang="fr-FR" sz="2200" i="1">
+                            <a:latin typeface="Cambria Math" panose="02040503050406030204" pitchFamily="18" charset="0"/>
+                          </a:rPr>
                           <m:t>𝑒𝑓𝑓</m:t>
                         </m:r>
                       </m:sub>
@@ -8958,11 +9366,15 @@
                       <m:rPr>
                         <m:sty m:val="p"/>
                       </m:rPr>
-                      <a:rPr lang="fr-FR" sz="2200"/>
+                      <a:rPr lang="fr-FR" sz="2200">
+                        <a:latin typeface="Cambria Math" panose="02040503050406030204" pitchFamily="18" charset="0"/>
+                      </a:rPr>
                       <m:t>Δ</m:t>
                     </m:r>
                     <m:r>
-                      <a:rPr lang="fr-FR" sz="2200" i="1"/>
+                      <a:rPr lang="fr-FR" sz="2200" i="1">
+                        <a:latin typeface="Cambria Math" panose="02040503050406030204" pitchFamily="18" charset="0"/>
+                      </a:rPr>
                       <m:t>𝑡</m:t>
                     </m:r>
                     <m:d>
@@ -8970,31 +9382,41 @@
                         <m:begChr m:val="["/>
                         <m:endChr m:val="]"/>
                         <m:ctrlPr>
-                          <a:rPr lang="fr-FR" sz="2200" i="1"/>
+                          <a:rPr lang="fr-FR" sz="2200" i="1">
+                            <a:latin typeface="Cambria Math" panose="02040503050406030204" pitchFamily="18" charset="0"/>
+                          </a:rPr>
                         </m:ctrlPr>
                       </m:dPr>
                       <m:e>
                         <m:f>
                           <m:fPr>
                             <m:ctrlPr>
-                              <a:rPr lang="fr-FR" sz="2200" i="1"/>
+                              <a:rPr lang="fr-FR" sz="2200" i="1">
+                                <a:latin typeface="Cambria Math" panose="02040503050406030204" pitchFamily="18" charset="0"/>
+                              </a:rPr>
                             </m:ctrlPr>
                           </m:fPr>
                           <m:num>
                             <m:r>
-                              <a:rPr lang="fr-FR" sz="2200" i="1"/>
+                              <a:rPr lang="fr-FR" sz="2200" i="1">
+                                <a:latin typeface="Cambria Math" panose="02040503050406030204" pitchFamily="18" charset="0"/>
+                              </a:rPr>
                               <m:t>2</m:t>
                             </m:r>
                           </m:num>
                           <m:den>
                             <m:r>
-                              <a:rPr lang="fr-FR" sz="2200"/>
+                              <a:rPr lang="fr-FR" sz="2200">
+                                <a:latin typeface="Cambria Math" panose="02040503050406030204" pitchFamily="18" charset="0"/>
+                              </a:rPr>
                               <m:t>2</m:t>
                             </m:r>
                             <m:sSub>
                               <m:sSubPr>
                                 <m:ctrlPr>
-                                  <a:rPr lang="fr-FR" sz="2200" i="1"/>
+                                  <a:rPr lang="fr-FR" sz="2200" i="1">
+                                    <a:latin typeface="Cambria Math" panose="02040503050406030204" pitchFamily="18" charset="0"/>
+                                  </a:rPr>
                                 </m:ctrlPr>
                               </m:sSubPr>
                               <m:e>
@@ -9002,7 +9424,9 @@
                                   <m:rPr>
                                     <m:sty m:val="p"/>
                                   </m:rPr>
-                                  <a:rPr lang="fr-FR" sz="2200"/>
+                                  <a:rPr lang="fr-FR" sz="2200">
+                                    <a:latin typeface="Cambria Math" panose="02040503050406030204" pitchFamily="18" charset="0"/>
+                                  </a:rPr>
                                   <m:t>r</m:t>
                                 </m:r>
                               </m:e>
@@ -9011,7 +9435,9 @@
                                   <m:rPr>
                                     <m:sty m:val="p"/>
                                   </m:rPr>
-                                  <a:rPr lang="fr-FR" sz="2200"/>
+                                  <a:rPr lang="fr-FR" sz="2200">
+                                    <a:latin typeface="Cambria Math" panose="02040503050406030204" pitchFamily="18" charset="0"/>
+                                  </a:rPr>
                                   <m:t>i</m:t>
                                 </m:r>
                               </m:sub>
@@ -9020,24 +9446,32 @@
                               <m:rPr>
                                 <m:sty m:val="p"/>
                               </m:rPr>
-                              <a:rPr lang="fr-FR" sz="2200"/>
+                              <a:rPr lang="fr-FR" sz="2200">
+                                <a:latin typeface="Cambria Math" panose="02040503050406030204" pitchFamily="18" charset="0"/>
+                              </a:rPr>
                               <m:t>Δr</m:t>
                             </m:r>
                           </m:den>
                         </m:f>
                         <m:r>
-                          <a:rPr lang="fr-FR" sz="2200" i="1"/>
+                          <a:rPr lang="fr-FR" sz="2200" i="1">
+                            <a:latin typeface="Cambria Math" panose="02040503050406030204" pitchFamily="18" charset="0"/>
+                          </a:rPr>
                           <m:t>+</m:t>
                         </m:r>
                         <m:f>
                           <m:fPr>
                             <m:ctrlPr>
-                              <a:rPr lang="fr-FR" sz="2200" i="1"/>
+                              <a:rPr lang="fr-FR" sz="2200" i="1">
+                                <a:latin typeface="Cambria Math" panose="02040503050406030204" pitchFamily="18" charset="0"/>
+                              </a:rPr>
                             </m:ctrlPr>
                           </m:fPr>
                           <m:num>
                             <m:r>
-                              <a:rPr lang="fr-FR" sz="2200" i="1"/>
+                              <a:rPr lang="fr-FR" sz="2200" i="1">
+                                <a:latin typeface="Cambria Math" panose="02040503050406030204" pitchFamily="18" charset="0"/>
+                              </a:rPr>
                               <m:t>1</m:t>
                             </m:r>
                           </m:num>
@@ -9046,13 +9480,17 @@
                               <m:rPr>
                                 <m:sty m:val="p"/>
                               </m:rPr>
-                              <a:rPr lang="fr-FR" sz="2200"/>
+                              <a:rPr lang="fr-FR" sz="2200">
+                                <a:latin typeface="Cambria Math" panose="02040503050406030204" pitchFamily="18" charset="0"/>
+                              </a:rPr>
                               <m:t>Δ</m:t>
                             </m:r>
                             <m:sSup>
                               <m:sSupPr>
                                 <m:ctrlPr>
-                                  <a:rPr lang="fr-FR" sz="2200" i="1"/>
+                                  <a:rPr lang="fr-FR" sz="2200" i="1">
+                                    <a:latin typeface="Cambria Math" panose="02040503050406030204" pitchFamily="18" charset="0"/>
+                                  </a:rPr>
                                 </m:ctrlPr>
                               </m:sSupPr>
                               <m:e>
@@ -9060,13 +9498,17 @@
                                   <m:rPr>
                                     <m:sty m:val="p"/>
                                   </m:rPr>
-                                  <a:rPr lang="fr-FR" sz="2200"/>
+                                  <a:rPr lang="fr-FR" sz="2200">
+                                    <a:latin typeface="Cambria Math" panose="02040503050406030204" pitchFamily="18" charset="0"/>
+                                  </a:rPr>
                                   <m:t>r</m:t>
                                 </m:r>
                               </m:e>
                               <m:sup>
                                 <m:r>
-                                  <a:rPr lang="fr-FR" sz="2200"/>
+                                  <a:rPr lang="fr-FR" sz="2200">
+                                    <a:latin typeface="Cambria Math" panose="02040503050406030204" pitchFamily="18" charset="0"/>
+                                  </a:rPr>
                                   <m:t>2</m:t>
                                 </m:r>
                               </m:sup>
@@ -9117,7 +9559,7 @@
               <a:lstStyle/>
               <a:p>
                 <a:r>
-                  <a:rPr lang="fr-FR">
+                  <a:rPr lang="fr-CA">
                     <a:noFill/>
                   </a:rPr>
                   <a:t> </a:t>
@@ -9196,8 +9638,8 @@
           </a:p>
         </p:txBody>
       </p:sp>
-      <mc:AlternateContent xmlns:mc="http://schemas.openxmlformats.org/markup-compatibility/2006">
-        <mc:Choice xmlns:a14="http://schemas.microsoft.com/office/drawing/2010/main" Requires="a14">
+      <mc:AlternateContent xmlns:mc="http://schemas.openxmlformats.org/markup-compatibility/2006" xmlns:a14="http://schemas.microsoft.com/office/drawing/2010/main">
+        <mc:Choice Requires="a14">
           <p:sp>
             <p:nvSpPr>
               <p:cNvPr id="3" name="Espace réservé du contenu 2">
@@ -9247,14 +9689,18 @@
                     <m:f>
                       <m:fPr>
                         <m:ctrlPr>
-                          <a:rPr lang="fr-FR" sz="2200" i="1"/>
+                          <a:rPr lang="fr-FR" sz="2200" i="1">
+                            <a:latin typeface="Cambria Math" panose="02040503050406030204" pitchFamily="18" charset="0"/>
+                          </a:rPr>
                         </m:ctrlPr>
                       </m:fPr>
                       <m:num>
                         <m:sSubSup>
                           <m:sSubSupPr>
                             <m:ctrlPr>
-                              <a:rPr lang="fr-FR" sz="2200" i="1"/>
+                              <a:rPr lang="fr-FR" sz="2200" i="1">
+                                <a:latin typeface="Cambria Math" panose="02040503050406030204" pitchFamily="18" charset="0"/>
+                              </a:rPr>
                             </m:ctrlPr>
                           </m:sSubSupPr>
                           <m:e>
@@ -9262,7 +9708,9 @@
                               <m:rPr>
                                 <m:sty m:val="p"/>
                               </m:rPr>
-                              <a:rPr lang="fr-FR" sz="2200"/>
+                              <a:rPr lang="fr-FR" sz="2200">
+                                <a:latin typeface="Cambria Math" panose="02040503050406030204" pitchFamily="18" charset="0"/>
+                              </a:rPr>
                               <m:t>C</m:t>
                             </m:r>
                           </m:e>
@@ -9271,7 +9719,9 @@
                               <m:rPr>
                                 <m:sty m:val="p"/>
                               </m:rPr>
-                              <a:rPr lang="fr-FR" sz="2200"/>
+                              <a:rPr lang="fr-FR" sz="2200">
+                                <a:latin typeface="Cambria Math" panose="02040503050406030204" pitchFamily="18" charset="0"/>
+                              </a:rPr>
                               <m:t>i</m:t>
                             </m:r>
                           </m:sub>
@@ -9280,19 +9730,25 @@
                               <m:rPr>
                                 <m:sty m:val="p"/>
                               </m:rPr>
-                              <a:rPr lang="fr-FR" sz="2200"/>
+                              <a:rPr lang="fr-FR" sz="2200">
+                                <a:latin typeface="Cambria Math" panose="02040503050406030204" pitchFamily="18" charset="0"/>
+                              </a:rPr>
                               <m:t>t</m:t>
                             </m:r>
                           </m:sup>
                         </m:sSubSup>
                         <m:r>
-                          <a:rPr lang="fr-FR" sz="2200"/>
+                          <a:rPr lang="fr-FR" sz="2200">
+                            <a:latin typeface="Cambria Math" panose="02040503050406030204" pitchFamily="18" charset="0"/>
+                          </a:rPr>
                           <m:t>−</m:t>
                         </m:r>
                         <m:sSubSup>
                           <m:sSubSupPr>
                             <m:ctrlPr>
-                              <a:rPr lang="fr-FR" sz="2200" i="1"/>
+                              <a:rPr lang="fr-FR" sz="2200" i="1">
+                                <a:latin typeface="Cambria Math" panose="02040503050406030204" pitchFamily="18" charset="0"/>
+                              </a:rPr>
                             </m:ctrlPr>
                           </m:sSubSupPr>
                           <m:e>
@@ -9300,7 +9756,9 @@
                               <m:rPr>
                                 <m:sty m:val="p"/>
                               </m:rPr>
-                              <a:rPr lang="fr-FR" sz="2200"/>
+                              <a:rPr lang="fr-FR" sz="2200">
+                                <a:latin typeface="Cambria Math" panose="02040503050406030204" pitchFamily="18" charset="0"/>
+                              </a:rPr>
                               <m:t>C</m:t>
                             </m:r>
                           </m:e>
@@ -9309,7 +9767,9 @@
                               <m:rPr>
                                 <m:sty m:val="p"/>
                               </m:rPr>
-                              <a:rPr lang="fr-FR" sz="2200"/>
+                              <a:rPr lang="fr-FR" sz="2200">
+                                <a:latin typeface="Cambria Math" panose="02040503050406030204" pitchFamily="18" charset="0"/>
+                              </a:rPr>
                               <m:t>i</m:t>
                             </m:r>
                           </m:sub>
@@ -9318,11 +9778,15 @@
                               <m:rPr>
                                 <m:sty m:val="p"/>
                               </m:rPr>
-                              <a:rPr lang="fr-FR" sz="2200"/>
+                              <a:rPr lang="fr-FR" sz="2200">
+                                <a:latin typeface="Cambria Math" panose="02040503050406030204" pitchFamily="18" charset="0"/>
+                              </a:rPr>
                               <m:t>t</m:t>
                             </m:r>
                             <m:r>
-                              <a:rPr lang="fr-FR" sz="2200"/>
+                              <a:rPr lang="fr-FR" sz="2200">
+                                <a:latin typeface="Cambria Math" panose="02040503050406030204" pitchFamily="18" charset="0"/>
+                              </a:rPr>
                               <m:t>−1</m:t>
                             </m:r>
                           </m:sup>
@@ -9333,41 +9797,55 @@
                           <m:rPr>
                             <m:sty m:val="p"/>
                           </m:rPr>
-                          <a:rPr lang="fr-FR" sz="2200"/>
+                          <a:rPr lang="fr-FR" sz="2200">
+                            <a:latin typeface="Cambria Math" panose="02040503050406030204" pitchFamily="18" charset="0"/>
+                          </a:rPr>
                           <m:t>Δt</m:t>
                         </m:r>
                       </m:den>
                     </m:f>
                     <m:r>
-                      <a:rPr lang="fr-FR" sz="2200" i="1"/>
+                      <a:rPr lang="fr-FR" sz="2200" i="1">
+                        <a:latin typeface="Cambria Math" panose="02040503050406030204" pitchFamily="18" charset="0"/>
+                      </a:rPr>
                       <m:t>=</m:t>
                     </m:r>
                     <m:f>
                       <m:fPr>
                         <m:ctrlPr>
-                          <a:rPr lang="fr-FR" sz="2200" i="1"/>
+                          <a:rPr lang="fr-FR" sz="2200" i="1">
+                            <a:latin typeface="Cambria Math" panose="02040503050406030204" pitchFamily="18" charset="0"/>
+                          </a:rPr>
                         </m:ctrlPr>
                       </m:fPr>
                       <m:num>
                         <m:r>
-                          <a:rPr lang="fr-FR" sz="2200"/>
-                          <m:t>∂</m:t>
-                        </m:r>
-                        <m:r>
-                          <a:rPr lang="fr-FR" sz="2200" i="1"/>
+                          <a:rPr lang="fr-FR" sz="2200">
+                            <a:latin typeface="Cambria Math" panose="02040503050406030204" pitchFamily="18" charset="0"/>
+                          </a:rPr>
+                          <m:t>𝜕</m:t>
+                        </m:r>
+                        <m:r>
+                          <a:rPr lang="fr-FR" sz="2200" i="1">
+                            <a:latin typeface="Cambria Math" panose="02040503050406030204" pitchFamily="18" charset="0"/>
+                          </a:rPr>
                           <m:t>𝐶</m:t>
                         </m:r>
                       </m:num>
                       <m:den>
                         <m:r>
-                          <a:rPr lang="fr-FR" sz="2200"/>
-                          <m:t>∂</m:t>
+                          <a:rPr lang="fr-FR" sz="2200">
+                            <a:latin typeface="Cambria Math" panose="02040503050406030204" pitchFamily="18" charset="0"/>
+                          </a:rPr>
+                          <m:t>𝜕</m:t>
                         </m:r>
                         <m:r>
                           <m:rPr>
                             <m:sty m:val="p"/>
                           </m:rPr>
-                          <a:rPr lang="fr-FR" sz="2200"/>
+                          <a:rPr lang="fr-FR" sz="2200">
+                            <a:latin typeface="Cambria Math" panose="02040503050406030204" pitchFamily="18" charset="0"/>
+                          </a:rPr>
                           <m:t>t</m:t>
                         </m:r>
                       </m:den>
@@ -9375,7 +9853,9 @@
                     <m:sSub>
                       <m:sSubPr>
                         <m:ctrlPr>
-                          <a:rPr lang="fr-FR" sz="2200" i="1"/>
+                          <a:rPr lang="fr-FR" sz="2200" i="1">
+                            <a:latin typeface="Cambria Math" panose="02040503050406030204" pitchFamily="18" charset="0"/>
+                          </a:rPr>
                         </m:ctrlPr>
                       </m:sSubPr>
                       <m:e>
@@ -9384,12 +9864,16 @@
                             <m:begChr m:val=""/>
                             <m:endChr m:val="|"/>
                             <m:ctrlPr>
-                              <a:rPr lang="fr-FR" sz="2200" i="1"/>
+                              <a:rPr lang="fr-FR" sz="2200" i="1">
+                                <a:latin typeface="Cambria Math" panose="02040503050406030204" pitchFamily="18" charset="0"/>
+                              </a:rPr>
                             </m:ctrlPr>
                           </m:dPr>
                           <m:e>
                             <m:r>
-                              <a:rPr lang="fr-FR" sz="2200" i="1"/>
+                              <a:rPr lang="fr-FR" sz="2200" i="1">
+                                <a:latin typeface="Cambria Math" panose="02040503050406030204" pitchFamily="18" charset="0"/>
+                              </a:rPr>
                               <m:t>​</m:t>
                             </m:r>
                           </m:e>
@@ -9400,77 +9884,103 @@
                           <m:rPr>
                             <m:sty m:val="p"/>
                           </m:rPr>
-                          <a:rPr lang="fr-FR" sz="2200"/>
+                          <a:rPr lang="fr-FR" sz="2200">
+                            <a:latin typeface="Cambria Math" panose="02040503050406030204" pitchFamily="18" charset="0"/>
+                          </a:rPr>
                           <m:t>i</m:t>
                         </m:r>
                         <m:r>
-                          <a:rPr lang="fr-FR" sz="2200"/>
+                          <a:rPr lang="fr-FR" sz="2200">
+                            <a:latin typeface="Cambria Math" panose="02040503050406030204" pitchFamily="18" charset="0"/>
+                          </a:rPr>
                           <m:t>,</m:t>
                         </m:r>
                         <m:r>
                           <m:rPr>
                             <m:sty m:val="p"/>
                           </m:rPr>
-                          <a:rPr lang="fr-FR" sz="2200"/>
+                          <a:rPr lang="fr-FR" sz="2200">
+                            <a:latin typeface="Cambria Math" panose="02040503050406030204" pitchFamily="18" charset="0"/>
+                          </a:rPr>
                           <m:t>t</m:t>
                         </m:r>
                       </m:sub>
                     </m:sSub>
                     <m:r>
-                      <a:rPr lang="fr-FR" sz="2200" i="1"/>
+                      <a:rPr lang="fr-FR" sz="2200" i="1">
+                        <a:latin typeface="Cambria Math" panose="02040503050406030204" pitchFamily="18" charset="0"/>
+                      </a:rPr>
                       <m:t>+</m:t>
                     </m:r>
                     <m:f>
                       <m:fPr>
                         <m:ctrlPr>
-                          <a:rPr lang="fr-FR" sz="2200" i="1"/>
+                          <a:rPr lang="fr-FR" sz="2200" i="1">
+                            <a:latin typeface="Cambria Math" panose="02040503050406030204" pitchFamily="18" charset="0"/>
+                          </a:rPr>
                         </m:ctrlPr>
                       </m:fPr>
                       <m:num>
                         <m:sSup>
                           <m:sSupPr>
                             <m:ctrlPr>
-                              <a:rPr lang="fr-FR" sz="2200" i="1"/>
+                              <a:rPr lang="fr-FR" sz="2200" i="1">
+                                <a:latin typeface="Cambria Math" panose="02040503050406030204" pitchFamily="18" charset="0"/>
+                              </a:rPr>
                             </m:ctrlPr>
                           </m:sSupPr>
                           <m:e>
                             <m:r>
-                              <a:rPr lang="fr-FR" sz="2200" i="1"/>
+                              <a:rPr lang="fr-FR" sz="2200" i="1">
+                                <a:latin typeface="Cambria Math" panose="02040503050406030204" pitchFamily="18" charset="0"/>
+                              </a:rPr>
                               <m:t>𝜕</m:t>
                             </m:r>
                           </m:e>
                           <m:sup>
                             <m:r>
-                              <a:rPr lang="fr-FR" sz="2200" i="1"/>
+                              <a:rPr lang="fr-FR" sz="2200" i="1">
+                                <a:latin typeface="Cambria Math" panose="02040503050406030204" pitchFamily="18" charset="0"/>
+                              </a:rPr>
                               <m:t>2</m:t>
                             </m:r>
                           </m:sup>
                         </m:sSup>
                         <m:r>
-                          <a:rPr lang="fr-FR" sz="2200" i="1"/>
+                          <a:rPr lang="fr-FR" sz="2200" i="1">
+                            <a:latin typeface="Cambria Math" panose="02040503050406030204" pitchFamily="18" charset="0"/>
+                          </a:rPr>
                           <m:t>𝐶</m:t>
                         </m:r>
                       </m:num>
                       <m:den>
                         <m:r>
-                          <a:rPr lang="fr-FR" sz="2200" i="1"/>
+                          <a:rPr lang="fr-FR" sz="2200" i="1">
+                            <a:latin typeface="Cambria Math" panose="02040503050406030204" pitchFamily="18" charset="0"/>
+                          </a:rPr>
                           <m:t>𝜕</m:t>
                         </m:r>
                         <m:sSup>
                           <m:sSupPr>
                             <m:ctrlPr>
-                              <a:rPr lang="fr-FR" sz="2200" i="1"/>
+                              <a:rPr lang="fr-FR" sz="2200" i="1">
+                                <a:latin typeface="Cambria Math" panose="02040503050406030204" pitchFamily="18" charset="0"/>
+                              </a:rPr>
                             </m:ctrlPr>
                           </m:sSupPr>
                           <m:e>
                             <m:r>
-                              <a:rPr lang="fr-FR" sz="2200" i="1"/>
+                              <a:rPr lang="fr-FR" sz="2200" i="1">
+                                <a:latin typeface="Cambria Math" panose="02040503050406030204" pitchFamily="18" charset="0"/>
+                              </a:rPr>
                               <m:t>𝑡</m:t>
                             </m:r>
                           </m:e>
                           <m:sup>
                             <m:r>
-                              <a:rPr lang="fr-FR" sz="2200" i="1"/>
+                              <a:rPr lang="fr-FR" sz="2200" i="1">
+                                <a:latin typeface="Cambria Math" panose="02040503050406030204" pitchFamily="18" charset="0"/>
+                              </a:rPr>
                               <m:t>2</m:t>
                             </m:r>
                           </m:sup>
@@ -9480,7 +9990,9 @@
                     <m:sSub>
                       <m:sSubPr>
                         <m:ctrlPr>
-                          <a:rPr lang="fr-FR" sz="2200" i="1"/>
+                          <a:rPr lang="fr-FR" sz="2200" i="1">
+                            <a:latin typeface="Cambria Math" panose="02040503050406030204" pitchFamily="18" charset="0"/>
+                          </a:rPr>
                         </m:ctrlPr>
                       </m:sSubPr>
                       <m:e>
@@ -9489,12 +10001,16 @@
                             <m:begChr m:val=""/>
                             <m:endChr m:val="|"/>
                             <m:ctrlPr>
-                              <a:rPr lang="fr-FR" sz="2200" i="1"/>
+                              <a:rPr lang="fr-FR" sz="2200" i="1">
+                                <a:latin typeface="Cambria Math" panose="02040503050406030204" pitchFamily="18" charset="0"/>
+                              </a:rPr>
                             </m:ctrlPr>
                           </m:dPr>
                           <m:e>
                             <m:r>
-                              <a:rPr lang="fr-FR" sz="2200" i="1"/>
+                              <a:rPr lang="fr-FR" sz="2200" i="1">
+                                <a:latin typeface="Cambria Math" panose="02040503050406030204" pitchFamily="18" charset="0"/>
+                              </a:rPr>
                               <m:t>​</m:t>
                             </m:r>
                           </m:e>
@@ -9502,15 +10018,21 @@
                       </m:e>
                       <m:sub>
                         <m:r>
-                          <a:rPr lang="fr-FR" sz="2200" i="1"/>
+                          <a:rPr lang="fr-FR" sz="2200" i="1">
+                            <a:latin typeface="Cambria Math" panose="02040503050406030204" pitchFamily="18" charset="0"/>
+                          </a:rPr>
                           <m:t>𝑖</m:t>
                         </m:r>
                         <m:r>
-                          <a:rPr lang="fr-FR" sz="2200" i="1"/>
+                          <a:rPr lang="fr-FR" sz="2200" i="1">
+                            <a:latin typeface="Cambria Math" panose="02040503050406030204" pitchFamily="18" charset="0"/>
+                          </a:rPr>
                           <m:t>,</m:t>
                         </m:r>
                         <m:r>
-                          <a:rPr lang="fr-FR" sz="2200" i="1"/>
+                          <a:rPr lang="fr-FR" sz="2200" i="1">
+                            <a:latin typeface="Cambria Math" panose="02040503050406030204" pitchFamily="18" charset="0"/>
+                          </a:rPr>
                           <m:t>𝑡</m:t>
                         </m:r>
                       </m:sub>
@@ -9518,38 +10040,52 @@
                     <m:f>
                       <m:fPr>
                         <m:ctrlPr>
-                          <a:rPr lang="fr-FR" sz="2200" i="1"/>
+                          <a:rPr lang="fr-FR" sz="2200" i="1">
+                            <a:latin typeface="Cambria Math" panose="02040503050406030204" pitchFamily="18" charset="0"/>
+                          </a:rPr>
                         </m:ctrlPr>
                       </m:fPr>
                       <m:num>
                         <m:r>
-                          <a:rPr lang="fr-FR" sz="2200" i="1"/>
+                          <a:rPr lang="fr-FR" sz="2200" i="1">
+                            <a:latin typeface="Cambria Math" panose="02040503050406030204" pitchFamily="18" charset="0"/>
+                          </a:rPr>
                           <m:t>𝛥</m:t>
                         </m:r>
                         <m:r>
-                          <a:rPr lang="fr-FR" sz="2200" i="1"/>
+                          <a:rPr lang="fr-FR" sz="2200" i="1">
+                            <a:latin typeface="Cambria Math" panose="02040503050406030204" pitchFamily="18" charset="0"/>
+                          </a:rPr>
                           <m:t>𝑡</m:t>
                         </m:r>
                       </m:num>
                       <m:den>
                         <m:r>
-                          <a:rPr lang="fr-FR" sz="2200" i="1"/>
+                          <a:rPr lang="fr-FR" sz="2200" i="1">
+                            <a:latin typeface="Cambria Math" panose="02040503050406030204" pitchFamily="18" charset="0"/>
+                          </a:rPr>
                           <m:t>2!</m:t>
                         </m:r>
                       </m:den>
                     </m:f>
                     <m:r>
-                      <a:rPr lang="fr-FR" sz="2200" i="1"/>
+                      <a:rPr lang="fr-FR" sz="2200" i="1">
+                        <a:latin typeface="Cambria Math" panose="02040503050406030204" pitchFamily="18" charset="0"/>
+                      </a:rPr>
                       <m:t>+</m:t>
                     </m:r>
                     <m:r>
-                      <a:rPr lang="fr-FR" sz="2200" i="1"/>
+                      <a:rPr lang="fr-FR" sz="2200" i="1">
+                        <a:latin typeface="Cambria Math" panose="02040503050406030204" pitchFamily="18" charset="0"/>
+                      </a:rPr>
                       <m:t>𝑜</m:t>
                     </m:r>
                     <m:d>
                       <m:dPr>
                         <m:ctrlPr>
-                          <a:rPr lang="fr-FR" sz="2200" i="1"/>
+                          <a:rPr lang="fr-FR" sz="2200" i="1">
+                            <a:latin typeface="Cambria Math" panose="02040503050406030204" pitchFamily="18" charset="0"/>
+                          </a:rPr>
                         </m:ctrlPr>
                       </m:dPr>
                       <m:e>
@@ -9557,11 +10093,15 @@
                           <m:rPr>
                             <m:sty m:val="p"/>
                           </m:rPr>
-                          <a:rPr lang="fr-FR" sz="2200"/>
+                          <a:rPr lang="fr-FR" sz="2200">
+                            <a:latin typeface="Cambria Math" panose="02040503050406030204" pitchFamily="18" charset="0"/>
+                          </a:rPr>
                           <m:t>Δ</m:t>
                         </m:r>
                         <m:r>
-                          <a:rPr lang="fr-FR" sz="2200" i="1"/>
+                          <a:rPr lang="fr-FR" sz="2200" i="1">
+                            <a:latin typeface="Cambria Math" panose="02040503050406030204" pitchFamily="18" charset="0"/>
+                          </a:rPr>
                           <m:t>𝑡</m:t>
                         </m:r>
                       </m:e>
@@ -9583,14 +10123,18 @@
                     <m:f>
                       <m:fPr>
                         <m:ctrlPr>
-                          <a:rPr lang="fr-FR" sz="2200" i="1"/>
+                          <a:rPr lang="fr-FR" sz="2200" i="1">
+                            <a:latin typeface="Cambria Math" panose="02040503050406030204" pitchFamily="18" charset="0"/>
+                          </a:rPr>
                         </m:ctrlPr>
                       </m:fPr>
                       <m:num>
                         <m:sSubSup>
                           <m:sSubSupPr>
                             <m:ctrlPr>
-                              <a:rPr lang="fr-FR" sz="2200" i="1"/>
+                              <a:rPr lang="fr-FR" sz="2200" i="1">
+                                <a:latin typeface="Cambria Math" panose="02040503050406030204" pitchFamily="18" charset="0"/>
+                              </a:rPr>
                             </m:ctrlPr>
                           </m:sSubSupPr>
                           <m:e>
@@ -9598,7 +10142,9 @@
                               <m:rPr>
                                 <m:sty m:val="p"/>
                               </m:rPr>
-                              <a:rPr lang="fr-FR" sz="2200"/>
+                              <a:rPr lang="fr-FR" sz="2200">
+                                <a:latin typeface="Cambria Math" panose="02040503050406030204" pitchFamily="18" charset="0"/>
+                              </a:rPr>
                               <m:t>C</m:t>
                             </m:r>
                           </m:e>
@@ -9607,11 +10153,15 @@
                               <m:rPr>
                                 <m:sty m:val="p"/>
                               </m:rPr>
-                              <a:rPr lang="fr-FR" sz="2200"/>
+                              <a:rPr lang="fr-FR" sz="2200">
+                                <a:latin typeface="Cambria Math" panose="02040503050406030204" pitchFamily="18" charset="0"/>
+                              </a:rPr>
                               <m:t>i</m:t>
                             </m:r>
                             <m:r>
-                              <a:rPr lang="fr-FR" sz="2200"/>
+                              <a:rPr lang="fr-FR" sz="2200">
+                                <a:latin typeface="Cambria Math" panose="02040503050406030204" pitchFamily="18" charset="0"/>
+                              </a:rPr>
                               <m:t>+1</m:t>
                             </m:r>
                           </m:sub>
@@ -9620,19 +10170,25 @@
                               <m:rPr>
                                 <m:sty m:val="p"/>
                               </m:rPr>
-                              <a:rPr lang="fr-FR" sz="2200"/>
+                              <a:rPr lang="fr-FR" sz="2200">
+                                <a:latin typeface="Cambria Math" panose="02040503050406030204" pitchFamily="18" charset="0"/>
+                              </a:rPr>
                               <m:t>t</m:t>
                             </m:r>
                           </m:sup>
                         </m:sSubSup>
                         <m:r>
-                          <a:rPr lang="fr-FR" sz="2200"/>
+                          <a:rPr lang="fr-FR" sz="2200">
+                            <a:latin typeface="Cambria Math" panose="02040503050406030204" pitchFamily="18" charset="0"/>
+                          </a:rPr>
                           <m:t>−</m:t>
                         </m:r>
                         <m:sSubSup>
                           <m:sSubSupPr>
                             <m:ctrlPr>
-                              <a:rPr lang="fr-FR" sz="2200" i="1"/>
+                              <a:rPr lang="fr-FR" sz="2200" i="1">
+                                <a:latin typeface="Cambria Math" panose="02040503050406030204" pitchFamily="18" charset="0"/>
+                              </a:rPr>
                             </m:ctrlPr>
                           </m:sSubSupPr>
                           <m:e>
@@ -9640,7 +10196,9 @@
                               <m:rPr>
                                 <m:sty m:val="p"/>
                               </m:rPr>
-                              <a:rPr lang="fr-FR" sz="2200"/>
+                              <a:rPr lang="fr-FR" sz="2200">
+                                <a:latin typeface="Cambria Math" panose="02040503050406030204" pitchFamily="18" charset="0"/>
+                              </a:rPr>
                               <m:t>C</m:t>
                             </m:r>
                           </m:e>
@@ -9649,11 +10207,15 @@
                               <m:rPr>
                                 <m:sty m:val="p"/>
                               </m:rPr>
-                              <a:rPr lang="fr-FR" sz="2200"/>
+                              <a:rPr lang="fr-FR" sz="2200">
+                                <a:latin typeface="Cambria Math" panose="02040503050406030204" pitchFamily="18" charset="0"/>
+                              </a:rPr>
                               <m:t>i</m:t>
                             </m:r>
                             <m:r>
-                              <a:rPr lang="fr-FR" sz="2200"/>
+                              <a:rPr lang="fr-FR" sz="2200">
+                                <a:latin typeface="Cambria Math" panose="02040503050406030204" pitchFamily="18" charset="0"/>
+                              </a:rPr>
                               <m:t>−1</m:t>
                             </m:r>
                           </m:sub>
@@ -9662,11 +10224,15 @@
                               <m:rPr>
                                 <m:sty m:val="p"/>
                               </m:rPr>
-                              <a:rPr lang="fr-FR" sz="2200"/>
+                              <a:rPr lang="fr-FR" sz="2200">
+                                <a:latin typeface="Cambria Math" panose="02040503050406030204" pitchFamily="18" charset="0"/>
+                              </a:rPr>
                               <m:t>t</m:t>
                             </m:r>
                             <m:r>
-                              <a:rPr lang="fr-FR" sz="2200"/>
+                              <a:rPr lang="fr-FR" sz="2200">
+                                <a:latin typeface="Cambria Math" panose="02040503050406030204" pitchFamily="18" charset="0"/>
+                              </a:rPr>
                               <m:t>−1</m:t>
                             </m:r>
                           </m:sup>
@@ -9677,41 +10243,55 @@
                           <m:rPr>
                             <m:sty m:val="p"/>
                           </m:rPr>
-                          <a:rPr lang="fr-FR" sz="2200"/>
+                          <a:rPr lang="fr-FR" sz="2200">
+                            <a:latin typeface="Cambria Math" panose="02040503050406030204" pitchFamily="18" charset="0"/>
+                          </a:rPr>
                           <m:t>Δr</m:t>
                         </m:r>
                       </m:den>
                     </m:f>
                     <m:r>
-                      <a:rPr lang="fr-FR" sz="2200" i="1"/>
+                      <a:rPr lang="fr-FR" sz="2200" i="1">
+                        <a:latin typeface="Cambria Math" panose="02040503050406030204" pitchFamily="18" charset="0"/>
+                      </a:rPr>
                       <m:t>=</m:t>
                     </m:r>
                     <m:f>
                       <m:fPr>
                         <m:ctrlPr>
-                          <a:rPr lang="fr-FR" sz="2200" i="1"/>
+                          <a:rPr lang="fr-FR" sz="2200" i="1">
+                            <a:latin typeface="Cambria Math" panose="02040503050406030204" pitchFamily="18" charset="0"/>
+                          </a:rPr>
                         </m:ctrlPr>
                       </m:fPr>
                       <m:num>
                         <m:r>
-                          <a:rPr lang="fr-FR" sz="2200"/>
-                          <m:t>∂</m:t>
-                        </m:r>
-                        <m:r>
-                          <a:rPr lang="fr-FR" sz="2200" i="1"/>
+                          <a:rPr lang="fr-FR" sz="2200">
+                            <a:latin typeface="Cambria Math" panose="02040503050406030204" pitchFamily="18" charset="0"/>
+                          </a:rPr>
+                          <m:t>𝜕</m:t>
+                        </m:r>
+                        <m:r>
+                          <a:rPr lang="fr-FR" sz="2200" i="1">
+                            <a:latin typeface="Cambria Math" panose="02040503050406030204" pitchFamily="18" charset="0"/>
+                          </a:rPr>
                           <m:t>𝐶</m:t>
                         </m:r>
                       </m:num>
                       <m:den>
                         <m:r>
-                          <a:rPr lang="fr-FR" sz="2200"/>
-                          <m:t>∂</m:t>
+                          <a:rPr lang="fr-FR" sz="2200">
+                            <a:latin typeface="Cambria Math" panose="02040503050406030204" pitchFamily="18" charset="0"/>
+                          </a:rPr>
+                          <m:t>𝜕</m:t>
                         </m:r>
                         <m:r>
                           <m:rPr>
                             <m:sty m:val="p"/>
                           </m:rPr>
-                          <a:rPr lang="fr-FR" sz="2200"/>
+                          <a:rPr lang="fr-FR" sz="2200">
+                            <a:latin typeface="Cambria Math" panose="02040503050406030204" pitchFamily="18" charset="0"/>
+                          </a:rPr>
                           <m:t>r</m:t>
                         </m:r>
                       </m:den>
@@ -9719,7 +10299,9 @@
                     <m:sSub>
                       <m:sSubPr>
                         <m:ctrlPr>
-                          <a:rPr lang="fr-FR" sz="2200" i="1"/>
+                          <a:rPr lang="fr-FR" sz="2200" i="1">
+                            <a:latin typeface="Cambria Math" panose="02040503050406030204" pitchFamily="18" charset="0"/>
+                          </a:rPr>
                         </m:ctrlPr>
                       </m:sSubPr>
                       <m:e>
@@ -9728,12 +10310,16 @@
                             <m:begChr m:val=""/>
                             <m:endChr m:val="|"/>
                             <m:ctrlPr>
-                              <a:rPr lang="fr-FR" sz="2200" i="1"/>
+                              <a:rPr lang="fr-FR" sz="2200" i="1">
+                                <a:latin typeface="Cambria Math" panose="02040503050406030204" pitchFamily="18" charset="0"/>
+                              </a:rPr>
                             </m:ctrlPr>
                           </m:dPr>
                           <m:e>
                             <m:r>
-                              <a:rPr lang="fr-FR" sz="2200" i="1"/>
+                              <a:rPr lang="fr-FR" sz="2200" i="1">
+                                <a:latin typeface="Cambria Math" panose="02040503050406030204" pitchFamily="18" charset="0"/>
+                              </a:rPr>
                               <m:t>​</m:t>
                             </m:r>
                           </m:e>
@@ -9744,34 +10330,46 @@
                           <m:rPr>
                             <m:sty m:val="p"/>
                           </m:rPr>
-                          <a:rPr lang="fr-FR" sz="2200"/>
+                          <a:rPr lang="fr-FR" sz="2200">
+                            <a:latin typeface="Cambria Math" panose="02040503050406030204" pitchFamily="18" charset="0"/>
+                          </a:rPr>
                           <m:t>i</m:t>
                         </m:r>
                         <m:r>
-                          <a:rPr lang="fr-FR" sz="2200"/>
+                          <a:rPr lang="fr-FR" sz="2200">
+                            <a:latin typeface="Cambria Math" panose="02040503050406030204" pitchFamily="18" charset="0"/>
+                          </a:rPr>
                           <m:t>,</m:t>
                         </m:r>
                         <m:r>
                           <m:rPr>
                             <m:sty m:val="p"/>
                           </m:rPr>
-                          <a:rPr lang="fr-FR" sz="2200"/>
+                          <a:rPr lang="fr-FR" sz="2200">
+                            <a:latin typeface="Cambria Math" panose="02040503050406030204" pitchFamily="18" charset="0"/>
+                          </a:rPr>
                           <m:t>t</m:t>
                         </m:r>
                       </m:sub>
                     </m:sSub>
                     <m:r>
-                      <a:rPr lang="fr-FR" sz="2200" i="1"/>
+                      <a:rPr lang="fr-FR" sz="2200" i="1">
+                        <a:latin typeface="Cambria Math" panose="02040503050406030204" pitchFamily="18" charset="0"/>
+                      </a:rPr>
                       <m:t>+</m:t>
                     </m:r>
                     <m:r>
-                      <a:rPr lang="fr-FR" sz="2200" i="1"/>
+                      <a:rPr lang="fr-FR" sz="2200" i="1">
+                        <a:latin typeface="Cambria Math" panose="02040503050406030204" pitchFamily="18" charset="0"/>
+                      </a:rPr>
                       <m:t>𝑜</m:t>
                     </m:r>
                     <m:d>
                       <m:dPr>
                         <m:ctrlPr>
-                          <a:rPr lang="fr-FR" sz="2200" i="1"/>
+                          <a:rPr lang="fr-FR" sz="2200" i="1">
+                            <a:latin typeface="Cambria Math" panose="02040503050406030204" pitchFamily="18" charset="0"/>
+                          </a:rPr>
                         </m:ctrlPr>
                       </m:dPr>
                       <m:e>
@@ -9779,24 +10377,32 @@
                           <m:rPr>
                             <m:sty m:val="p"/>
                           </m:rPr>
-                          <a:rPr lang="fr-FR" sz="2200"/>
+                          <a:rPr lang="fr-FR" sz="2200">
+                            <a:latin typeface="Cambria Math" panose="02040503050406030204" pitchFamily="18" charset="0"/>
+                          </a:rPr>
                           <m:t>Δ</m:t>
                         </m:r>
                         <m:sSup>
                           <m:sSupPr>
                             <m:ctrlPr>
-                              <a:rPr lang="fr-FR" sz="2200" i="1"/>
+                              <a:rPr lang="fr-FR" sz="2200" i="1">
+                                <a:latin typeface="Cambria Math" panose="02040503050406030204" pitchFamily="18" charset="0"/>
+                              </a:rPr>
                             </m:ctrlPr>
                           </m:sSupPr>
                           <m:e>
                             <m:r>
-                              <a:rPr lang="fr-FR" sz="2200" i="1"/>
+                              <a:rPr lang="fr-FR" sz="2200" i="1">
+                                <a:latin typeface="Cambria Math" panose="02040503050406030204" pitchFamily="18" charset="0"/>
+                              </a:rPr>
                               <m:t>𝑟</m:t>
                             </m:r>
                           </m:e>
                           <m:sup>
                             <m:r>
-                              <a:rPr lang="fr-FR" sz="2200" i="1"/>
+                              <a:rPr lang="fr-FR" sz="2200" i="1">
+                                <a:latin typeface="Cambria Math" panose="02040503050406030204" pitchFamily="18" charset="0"/>
+                              </a:rPr>
                               <m:t>2</m:t>
                             </m:r>
                           </m:sup>
@@ -9820,14 +10426,18 @@
                     <m:f>
                       <m:fPr>
                         <m:ctrlPr>
-                          <a:rPr lang="fr-FR" sz="2200" i="1"/>
+                          <a:rPr lang="fr-FR" sz="2200" i="1">
+                            <a:latin typeface="Cambria Math" panose="02040503050406030204" pitchFamily="18" charset="0"/>
+                          </a:rPr>
                         </m:ctrlPr>
                       </m:fPr>
                       <m:num>
                         <m:sSubSup>
                           <m:sSubSupPr>
                             <m:ctrlPr>
-                              <a:rPr lang="fr-FR" sz="2200" i="1"/>
+                              <a:rPr lang="fr-FR" sz="2200" i="1">
+                                <a:latin typeface="Cambria Math" panose="02040503050406030204" pitchFamily="18" charset="0"/>
+                              </a:rPr>
                             </m:ctrlPr>
                           </m:sSubSupPr>
                           <m:e>
@@ -9835,7 +10445,9 @@
                               <m:rPr>
                                 <m:sty m:val="p"/>
                               </m:rPr>
-                              <a:rPr lang="fr-FR" sz="2200"/>
+                              <a:rPr lang="fr-FR" sz="2200">
+                                <a:latin typeface="Cambria Math" panose="02040503050406030204" pitchFamily="18" charset="0"/>
+                              </a:rPr>
                               <m:t>C</m:t>
                             </m:r>
                           </m:e>
@@ -9844,11 +10456,15 @@
                               <m:rPr>
                                 <m:sty m:val="p"/>
                               </m:rPr>
-                              <a:rPr lang="fr-FR" sz="2200"/>
+                              <a:rPr lang="fr-FR" sz="2200">
+                                <a:latin typeface="Cambria Math" panose="02040503050406030204" pitchFamily="18" charset="0"/>
+                              </a:rPr>
                               <m:t>i</m:t>
                             </m:r>
                             <m:r>
-                              <a:rPr lang="fr-FR" sz="2200"/>
+                              <a:rPr lang="fr-FR" sz="2200">
+                                <a:latin typeface="Cambria Math" panose="02040503050406030204" pitchFamily="18" charset="0"/>
+                              </a:rPr>
                               <m:t>+1</m:t>
                             </m:r>
                           </m:sub>
@@ -9857,31 +10473,41 @@
                               <m:rPr>
                                 <m:sty m:val="p"/>
                               </m:rPr>
-                              <a:rPr lang="fr-FR" sz="2200"/>
+                              <a:rPr lang="fr-FR" sz="2200">
+                                <a:latin typeface="Cambria Math" panose="02040503050406030204" pitchFamily="18" charset="0"/>
+                              </a:rPr>
                               <m:t>t</m:t>
                             </m:r>
                           </m:sup>
                         </m:sSubSup>
                         <m:r>
-                          <a:rPr lang="fr-FR" sz="2200"/>
+                          <a:rPr lang="fr-FR" sz="2200">
+                            <a:latin typeface="Cambria Math" panose="02040503050406030204" pitchFamily="18" charset="0"/>
+                          </a:rPr>
                           <m:t>−</m:t>
                         </m:r>
                         <m:sSubSup>
                           <m:sSubSupPr>
                             <m:ctrlPr>
-                              <a:rPr lang="fr-FR" sz="2200" i="1"/>
+                              <a:rPr lang="fr-FR" sz="2200" i="1">
+                                <a:latin typeface="Cambria Math" panose="02040503050406030204" pitchFamily="18" charset="0"/>
+                              </a:rPr>
                             </m:ctrlPr>
                           </m:sSubSupPr>
                           <m:e>
                             <m:r>
-                              <a:rPr lang="fr-FR" sz="2200"/>
+                              <a:rPr lang="fr-FR" sz="2200">
+                                <a:latin typeface="Cambria Math" panose="02040503050406030204" pitchFamily="18" charset="0"/>
+                              </a:rPr>
                               <m:t>2</m:t>
                             </m:r>
                             <m:r>
                               <m:rPr>
                                 <m:sty m:val="p"/>
                               </m:rPr>
-                              <a:rPr lang="fr-FR" sz="2200"/>
+                              <a:rPr lang="fr-FR" sz="2200">
+                                <a:latin typeface="Cambria Math" panose="02040503050406030204" pitchFamily="18" charset="0"/>
+                              </a:rPr>
                               <m:t>C</m:t>
                             </m:r>
                           </m:e>
@@ -9890,7 +10516,9 @@
                               <m:rPr>
                                 <m:sty m:val="p"/>
                               </m:rPr>
-                              <a:rPr lang="fr-FR" sz="2200"/>
+                              <a:rPr lang="fr-FR" sz="2200">
+                                <a:latin typeface="Cambria Math" panose="02040503050406030204" pitchFamily="18" charset="0"/>
+                              </a:rPr>
                               <m:t>i</m:t>
                             </m:r>
                           </m:sub>
@@ -9899,40 +10527,54 @@
                               <m:rPr>
                                 <m:sty m:val="p"/>
                               </m:rPr>
-                              <a:rPr lang="fr-FR" sz="2200"/>
+                              <a:rPr lang="fr-FR" sz="2200">
+                                <a:latin typeface="Cambria Math" panose="02040503050406030204" pitchFamily="18" charset="0"/>
+                              </a:rPr>
                               <m:t>t</m:t>
                             </m:r>
                           </m:sup>
                         </m:sSubSup>
                         <m:r>
-                          <a:rPr lang="fr-FR" sz="2200" i="1"/>
+                          <a:rPr lang="fr-FR" sz="2200" i="1">
+                            <a:latin typeface="Cambria Math" panose="02040503050406030204" pitchFamily="18" charset="0"/>
+                          </a:rPr>
                           <m:t>+</m:t>
                         </m:r>
                         <m:sSubSup>
                           <m:sSubSupPr>
                             <m:ctrlPr>
-                              <a:rPr lang="fr-FR" sz="2200" i="1"/>
+                              <a:rPr lang="fr-FR" sz="2200" i="1">
+                                <a:latin typeface="Cambria Math" panose="02040503050406030204" pitchFamily="18" charset="0"/>
+                              </a:rPr>
                             </m:ctrlPr>
                           </m:sSubSupPr>
                           <m:e>
                             <m:r>
-                              <a:rPr lang="fr-FR" sz="2200" i="1"/>
+                              <a:rPr lang="fr-FR" sz="2200" i="1">
+                                <a:latin typeface="Cambria Math" panose="02040503050406030204" pitchFamily="18" charset="0"/>
+                              </a:rPr>
                               <m:t>𝐶</m:t>
                             </m:r>
                           </m:e>
                           <m:sub>
                             <m:r>
-                              <a:rPr lang="fr-FR" sz="2200" i="1"/>
+                              <a:rPr lang="fr-FR" sz="2200" i="1">
+                                <a:latin typeface="Cambria Math" panose="02040503050406030204" pitchFamily="18" charset="0"/>
+                              </a:rPr>
                               <m:t>𝑖</m:t>
                             </m:r>
                             <m:r>
-                              <a:rPr lang="fr-FR" sz="2200" i="1"/>
+                              <a:rPr lang="fr-FR" sz="2200" i="1">
+                                <a:latin typeface="Cambria Math" panose="02040503050406030204" pitchFamily="18" charset="0"/>
+                              </a:rPr>
                               <m:t>−1</m:t>
                             </m:r>
                           </m:sub>
                           <m:sup>
                             <m:r>
-                              <a:rPr lang="fr-FR" sz="2200" i="1"/>
+                              <a:rPr lang="fr-FR" sz="2200" i="1">
+                                <a:latin typeface="Cambria Math" panose="02040503050406030204" pitchFamily="18" charset="0"/>
+                              </a:rPr>
                               <m:t>𝑡</m:t>
                             </m:r>
                           </m:sup>
@@ -9943,13 +10585,17 @@
                           <m:rPr>
                             <m:sty m:val="p"/>
                           </m:rPr>
-                          <a:rPr lang="fr-FR" sz="2200"/>
+                          <a:rPr lang="fr-FR" sz="2200">
+                            <a:latin typeface="Cambria Math" panose="02040503050406030204" pitchFamily="18" charset="0"/>
+                          </a:rPr>
                           <m:t>Δ</m:t>
                         </m:r>
                         <m:sSup>
                           <m:sSupPr>
                             <m:ctrlPr>
-                              <a:rPr lang="fr-FR" sz="2200" i="1"/>
+                              <a:rPr lang="fr-FR" sz="2200" i="1">
+                                <a:latin typeface="Cambria Math" panose="02040503050406030204" pitchFamily="18" charset="0"/>
+                              </a:rPr>
                             </m:ctrlPr>
                           </m:sSupPr>
                           <m:e>
@@ -9957,13 +10603,17 @@
                               <m:rPr>
                                 <m:sty m:val="p"/>
                               </m:rPr>
-                              <a:rPr lang="fr-FR" sz="2200"/>
+                              <a:rPr lang="fr-FR" sz="2200">
+                                <a:latin typeface="Cambria Math" panose="02040503050406030204" pitchFamily="18" charset="0"/>
+                              </a:rPr>
                               <m:t>r</m:t>
                             </m:r>
                           </m:e>
                           <m:sup>
                             <m:r>
-                              <a:rPr lang="fr-FR" sz="2200"/>
+                              <a:rPr lang="fr-FR" sz="2200">
+                                <a:latin typeface="Cambria Math" panose="02040503050406030204" pitchFamily="18" charset="0"/>
+                              </a:rPr>
                               <m:t>2</m:t>
                             </m:r>
                           </m:sup>
@@ -9971,60 +10621,80 @@
                       </m:den>
                     </m:f>
                     <m:r>
-                      <a:rPr lang="fr-FR" sz="2200" i="1"/>
+                      <a:rPr lang="fr-FR" sz="2200" i="1">
+                        <a:latin typeface="Cambria Math" panose="02040503050406030204" pitchFamily="18" charset="0"/>
+                      </a:rPr>
                       <m:t>=</m:t>
                     </m:r>
                     <m:f>
                       <m:fPr>
                         <m:ctrlPr>
-                          <a:rPr lang="fr-FR" sz="2200" i="1"/>
+                          <a:rPr lang="fr-FR" sz="2200" i="1">
+                            <a:latin typeface="Cambria Math" panose="02040503050406030204" pitchFamily="18" charset="0"/>
+                          </a:rPr>
                         </m:ctrlPr>
                       </m:fPr>
                       <m:num>
                         <m:sSup>
                           <m:sSupPr>
                             <m:ctrlPr>
-                              <a:rPr lang="fr-FR" sz="2200" i="1"/>
+                              <a:rPr lang="fr-FR" sz="2200" i="1">
+                                <a:latin typeface="Cambria Math" panose="02040503050406030204" pitchFamily="18" charset="0"/>
+                              </a:rPr>
                             </m:ctrlPr>
                           </m:sSupPr>
                           <m:e>
                             <m:r>
-                              <a:rPr lang="fr-FR" sz="2200" i="1"/>
+                              <a:rPr lang="fr-FR" sz="2200" i="1">
+                                <a:latin typeface="Cambria Math" panose="02040503050406030204" pitchFamily="18" charset="0"/>
+                              </a:rPr>
                               <m:t>𝜕</m:t>
                             </m:r>
                           </m:e>
                           <m:sup>
                             <m:r>
-                              <a:rPr lang="fr-FR" sz="2200" i="1"/>
+                              <a:rPr lang="fr-FR" sz="2200" i="1">
+                                <a:latin typeface="Cambria Math" panose="02040503050406030204" pitchFamily="18" charset="0"/>
+                              </a:rPr>
                               <m:t>2</m:t>
                             </m:r>
                           </m:sup>
                         </m:sSup>
                         <m:r>
-                          <a:rPr lang="fr-FR" sz="2200" i="1"/>
+                          <a:rPr lang="fr-FR" sz="2200" i="1">
+                            <a:latin typeface="Cambria Math" panose="02040503050406030204" pitchFamily="18" charset="0"/>
+                          </a:rPr>
                           <m:t>𝐶</m:t>
                         </m:r>
                       </m:num>
                       <m:den>
                         <m:r>
-                          <a:rPr lang="fr-FR" sz="2200" i="1"/>
+                          <a:rPr lang="fr-FR" sz="2200" i="1">
+                            <a:latin typeface="Cambria Math" panose="02040503050406030204" pitchFamily="18" charset="0"/>
+                          </a:rPr>
                           <m:t>𝜕</m:t>
                         </m:r>
                         <m:sSup>
                           <m:sSupPr>
                             <m:ctrlPr>
-                              <a:rPr lang="fr-FR" sz="2200" i="1"/>
+                              <a:rPr lang="fr-FR" sz="2200" i="1">
+                                <a:latin typeface="Cambria Math" panose="02040503050406030204" pitchFamily="18" charset="0"/>
+                              </a:rPr>
                             </m:ctrlPr>
                           </m:sSupPr>
                           <m:e>
                             <m:r>
-                              <a:rPr lang="fr-FR" sz="2200" i="1"/>
+                              <a:rPr lang="fr-FR" sz="2200" i="1">
+                                <a:latin typeface="Cambria Math" panose="02040503050406030204" pitchFamily="18" charset="0"/>
+                              </a:rPr>
                               <m:t>𝑟</m:t>
                             </m:r>
                           </m:e>
                           <m:sup>
                             <m:r>
-                              <a:rPr lang="fr-FR" sz="2200" i="1"/>
+                              <a:rPr lang="fr-FR" sz="2200" i="1">
+                                <a:latin typeface="Cambria Math" panose="02040503050406030204" pitchFamily="18" charset="0"/>
+                              </a:rPr>
                               <m:t>2</m:t>
                             </m:r>
                           </m:sup>
@@ -10034,7 +10704,9 @@
                     <m:sSub>
                       <m:sSubPr>
                         <m:ctrlPr>
-                          <a:rPr lang="fr-FR" sz="2200" i="1"/>
+                          <a:rPr lang="fr-FR" sz="2200" i="1">
+                            <a:latin typeface="Cambria Math" panose="02040503050406030204" pitchFamily="18" charset="0"/>
+                          </a:rPr>
                         </m:ctrlPr>
                       </m:sSubPr>
                       <m:e>
@@ -10043,12 +10715,16 @@
                             <m:begChr m:val=""/>
                             <m:endChr m:val="|"/>
                             <m:ctrlPr>
-                              <a:rPr lang="fr-FR" sz="2200" i="1"/>
+                              <a:rPr lang="fr-FR" sz="2200" i="1">
+                                <a:latin typeface="Cambria Math" panose="02040503050406030204" pitchFamily="18" charset="0"/>
+                              </a:rPr>
                             </m:ctrlPr>
                           </m:dPr>
                           <m:e>
                             <m:r>
-                              <a:rPr lang="fr-FR" sz="2200" i="1"/>
+                              <a:rPr lang="fr-FR" sz="2200" i="1">
+                                <a:latin typeface="Cambria Math" panose="02040503050406030204" pitchFamily="18" charset="0"/>
+                              </a:rPr>
                               <m:t>​</m:t>
                             </m:r>
                           </m:e>
@@ -10056,53 +10732,73 @@
                       </m:e>
                       <m:sub>
                         <m:r>
-                          <a:rPr lang="fr-FR" sz="2200" i="1"/>
+                          <a:rPr lang="fr-FR" sz="2200" i="1">
+                            <a:latin typeface="Cambria Math" panose="02040503050406030204" pitchFamily="18" charset="0"/>
+                          </a:rPr>
                           <m:t>𝑖</m:t>
                         </m:r>
                         <m:r>
-                          <a:rPr lang="fr-FR" sz="2200" i="1"/>
+                          <a:rPr lang="fr-FR" sz="2200" i="1">
+                            <a:latin typeface="Cambria Math" panose="02040503050406030204" pitchFamily="18" charset="0"/>
+                          </a:rPr>
                           <m:t>,</m:t>
                         </m:r>
                         <m:r>
-                          <a:rPr lang="fr-FR" sz="2200" i="1"/>
+                          <a:rPr lang="fr-FR" sz="2200" i="1">
+                            <a:latin typeface="Cambria Math" panose="02040503050406030204" pitchFamily="18" charset="0"/>
+                          </a:rPr>
                           <m:t>𝑡</m:t>
                         </m:r>
                       </m:sub>
                     </m:sSub>
                     <m:r>
-                      <a:rPr lang="fr-FR" sz="2200" i="1"/>
+                      <a:rPr lang="fr-FR" sz="2200" i="1">
+                        <a:latin typeface="Cambria Math" panose="02040503050406030204" pitchFamily="18" charset="0"/>
+                      </a:rPr>
                       <m:t>+</m:t>
                     </m:r>
                     <m:r>
-                      <a:rPr lang="fr-FR" sz="2200" i="1"/>
+                      <a:rPr lang="fr-FR" sz="2200" i="1">
+                        <a:latin typeface="Cambria Math" panose="02040503050406030204" pitchFamily="18" charset="0"/>
+                      </a:rPr>
                       <m:t>𝑜</m:t>
                     </m:r>
                     <m:d>
                       <m:dPr>
                         <m:ctrlPr>
-                          <a:rPr lang="fr-FR" sz="2200" i="1"/>
+                          <a:rPr lang="fr-FR" sz="2200" i="1">
+                            <a:latin typeface="Cambria Math" panose="02040503050406030204" pitchFamily="18" charset="0"/>
+                          </a:rPr>
                         </m:ctrlPr>
                       </m:dPr>
                       <m:e>
                         <m:r>
-                          <a:rPr lang="fr-FR" sz="2200" i="1"/>
+                          <a:rPr lang="fr-FR" sz="2200" i="1">
+                            <a:latin typeface="Cambria Math" panose="02040503050406030204" pitchFamily="18" charset="0"/>
+                          </a:rPr>
                           <m:t>𝛥</m:t>
                         </m:r>
                         <m:sSup>
                           <m:sSupPr>
                             <m:ctrlPr>
-                              <a:rPr lang="fr-FR" sz="2200" i="1"/>
+                              <a:rPr lang="fr-FR" sz="2200" i="1">
+                                <a:latin typeface="Cambria Math" panose="02040503050406030204" pitchFamily="18" charset="0"/>
+                              </a:rPr>
                             </m:ctrlPr>
                           </m:sSupPr>
                           <m:e>
                             <m:r>
-                              <a:rPr lang="fr-FR" sz="2200" i="1"/>
+                              <a:rPr lang="fr-FR" sz="2200" i="1">
+                                <a:latin typeface="Cambria Math" panose="02040503050406030204" pitchFamily="18" charset="0"/>
+                              </a:rPr>
                               <m:t>𝑟</m:t>
                             </m:r>
                           </m:e>
                           <m:sup>
                             <m:r>
-                              <a:rPr lang="fr-CA" sz="2200" i="1"/>
+                              <a:rPr lang="fr-CA" sz="2200" i="1">
+                                <a:latin typeface="Cambria Math" panose="02040503050406030204" pitchFamily="18" charset="0"/>
+                              </a:rPr>
                               <m:t>2</m:t>
                             </m:r>
                           </m:sup>
@@ -11418,7 +12114,7 @@
             </p:txBody>
           </p:sp>
         </mc:Choice>
-        <mc:Fallback>
+        <mc:Fallback xmlns="">
           <p:sp>
             <p:nvSpPr>
               <p:cNvPr id="3" name="Espace réservé du contenu 2">

</xml_diff>

<commit_message>
Ajout des diapos B, C, D, F dans le powerpoint
</commit_message>
<xml_diff>
--- a/MEC8211-Devoir2.pptx
+++ b/MEC8211-Devoir2.pptx
@@ -5,7 +5,7 @@
     <p:sldMasterId id="2147483648" r:id="rId1"/>
   </p:sldMasterIdLst>
   <p:notesMasterIdLst>
-    <p:notesMasterId r:id="rId7"/>
+    <p:notesMasterId r:id="rId13"/>
   </p:notesMasterIdLst>
   <p:sldIdLst>
     <p:sldId id="256" r:id="rId2"/>
@@ -13,6 +13,12 @@
     <p:sldId id="258" r:id="rId4"/>
     <p:sldId id="259" r:id="rId5"/>
     <p:sldId id="260" r:id="rId6"/>
+    <p:sldId id="262" r:id="rId7"/>
+    <p:sldId id="263" r:id="rId8"/>
+    <p:sldId id="264" r:id="rId9"/>
+    <p:sldId id="265" r:id="rId10"/>
+    <p:sldId id="266" r:id="rId11"/>
+    <p:sldId id="267" r:id="rId12"/>
   </p:sldIdLst>
   <p:sldSz cx="12192000" cy="6858000"/>
   <p:notesSz cx="6858000" cy="9144000"/>
@@ -201,7 +207,7 @@
           <a:p>
             <a:fld id="{BB0B2023-C595-443A-8D8C-AB9DF5A28D48}" type="datetimeFigureOut">
               <a:rPr lang="fr-FR" smtClean="0"/>
-              <a:t>02/03/2026</a:t>
+              <a:t>03/03/2026</a:t>
             </a:fld>
             <a:endParaRPr lang="fr-FR"/>
           </a:p>
@@ -552,6 +558,114 @@
 </p:notes>
 </file>
 
+<file path=ppt/notesSlides/notesSlide10.xml><?xml version="1.0" encoding="utf-8"?>
+<p:notes xmlns:a="http://schemas.openxmlformats.org/drawingml/2006/main" xmlns:r="http://schemas.openxmlformats.org/officeDocument/2006/relationships" xmlns:p="http://schemas.openxmlformats.org/presentationml/2006/main">
+  <p:cSld>
+    <p:spTree>
+      <p:nvGrpSpPr>
+        <p:cNvPr id="1" name="">
+          <a:extLst>
+            <a:ext uri="{FF2B5EF4-FFF2-40B4-BE49-F238E27FC236}">
+              <a16:creationId xmlns:a16="http://schemas.microsoft.com/office/drawing/2014/main" id="{46902BA6-35E4-E2E0-913C-F6DCD1E875DB}"/>
+            </a:ext>
+          </a:extLst>
+        </p:cNvPr>
+        <p:cNvGrpSpPr/>
+        <p:nvPr/>
+      </p:nvGrpSpPr>
+      <p:grpSpPr>
+        <a:xfrm>
+          <a:off x="0" y="0"/>
+          <a:ext cx="0" cy="0"/>
+          <a:chOff x="0" y="0"/>
+          <a:chExt cx="0" cy="0"/>
+        </a:xfrm>
+      </p:grpSpPr>
+      <p:sp>
+        <p:nvSpPr>
+          <p:cNvPr id="2" name="Espace réservé de l'image des diapositives 1">
+            <a:extLst>
+              <a:ext uri="{FF2B5EF4-FFF2-40B4-BE49-F238E27FC236}">
+                <a16:creationId xmlns:a16="http://schemas.microsoft.com/office/drawing/2014/main" id="{BE5BC6DB-3F10-0908-26C1-E9A08A3AB3B0}"/>
+              </a:ext>
+            </a:extLst>
+          </p:cNvPr>
+          <p:cNvSpPr>
+            <a:spLocks noGrp="1" noRot="1" noChangeAspect="1"/>
+          </p:cNvSpPr>
+          <p:nvPr>
+            <p:ph type="sldImg"/>
+          </p:nvPr>
+        </p:nvSpPr>
+        <p:spPr/>
+      </p:sp>
+      <p:sp>
+        <p:nvSpPr>
+          <p:cNvPr id="3" name="Espace réservé des notes 2">
+            <a:extLst>
+              <a:ext uri="{FF2B5EF4-FFF2-40B4-BE49-F238E27FC236}">
+                <a16:creationId xmlns:a16="http://schemas.microsoft.com/office/drawing/2014/main" id="{0157C37D-7AF6-47A7-FBC8-C5A712B73E51}"/>
+              </a:ext>
+            </a:extLst>
+          </p:cNvPr>
+          <p:cNvSpPr>
+            <a:spLocks noGrp="1"/>
+          </p:cNvSpPr>
+          <p:nvPr>
+            <p:ph type="body" idx="1"/>
+          </p:nvPr>
+        </p:nvSpPr>
+        <p:spPr/>
+        <p:txBody>
+          <a:bodyPr/>
+          <a:lstStyle/>
+          <a:p>
+            <a:endParaRPr lang="fr-FR" dirty="0"/>
+          </a:p>
+        </p:txBody>
+      </p:sp>
+      <p:sp>
+        <p:nvSpPr>
+          <p:cNvPr id="4" name="Espace réservé du numéro de diapositive 3">
+            <a:extLst>
+              <a:ext uri="{FF2B5EF4-FFF2-40B4-BE49-F238E27FC236}">
+                <a16:creationId xmlns:a16="http://schemas.microsoft.com/office/drawing/2014/main" id="{D5CCC47F-30F2-4E4C-9C5B-FD066A6231D8}"/>
+              </a:ext>
+            </a:extLst>
+          </p:cNvPr>
+          <p:cNvSpPr>
+            <a:spLocks noGrp="1"/>
+          </p:cNvSpPr>
+          <p:nvPr>
+            <p:ph type="sldNum" sz="quarter" idx="5"/>
+          </p:nvPr>
+        </p:nvSpPr>
+        <p:spPr/>
+        <p:txBody>
+          <a:bodyPr/>
+          <a:lstStyle/>
+          <a:p>
+            <a:fld id="{F6105186-0725-443C-BC59-E521425E81CD}" type="slidenum">
+              <a:rPr lang="fr-FR" smtClean="0"/>
+              <a:t>11</a:t>
+            </a:fld>
+            <a:endParaRPr lang="fr-FR"/>
+          </a:p>
+        </p:txBody>
+      </p:sp>
+    </p:spTree>
+    <p:extLst>
+      <p:ext uri="{BB962C8B-B14F-4D97-AF65-F5344CB8AC3E}">
+        <p14:creationId xmlns:p14="http://schemas.microsoft.com/office/powerpoint/2010/main" val="3301587317"/>
+      </p:ext>
+    </p:extLst>
+  </p:cSld>
+  <p:clrMapOvr>
+    <a:masterClrMapping/>
+  </p:clrMapOvr>
+</p:notes>
+</file>
+
 <file path=ppt/notesSlides/notesSlide2.xml><?xml version="1.0" encoding="utf-8"?>
 <p:notes xmlns:a="http://schemas.openxmlformats.org/drawingml/2006/main" xmlns:r="http://schemas.openxmlformats.org/officeDocument/2006/relationships" xmlns:p="http://schemas.openxmlformats.org/presentationml/2006/main">
   <p:cSld>
@@ -876,6 +990,546 @@
 </p:notes>
 </file>
 
+<file path=ppt/notesSlides/notesSlide5.xml><?xml version="1.0" encoding="utf-8"?>
+<p:notes xmlns:a="http://schemas.openxmlformats.org/drawingml/2006/main" xmlns:r="http://schemas.openxmlformats.org/officeDocument/2006/relationships" xmlns:p="http://schemas.openxmlformats.org/presentationml/2006/main">
+  <p:cSld>
+    <p:spTree>
+      <p:nvGrpSpPr>
+        <p:cNvPr id="1" name="">
+          <a:extLst>
+            <a:ext uri="{FF2B5EF4-FFF2-40B4-BE49-F238E27FC236}">
+              <a16:creationId xmlns:a16="http://schemas.microsoft.com/office/drawing/2014/main" id="{B1793FE8-5604-E83F-486A-4E56DE1C699A}"/>
+            </a:ext>
+          </a:extLst>
+        </p:cNvPr>
+        <p:cNvGrpSpPr/>
+        <p:nvPr/>
+      </p:nvGrpSpPr>
+      <p:grpSpPr>
+        <a:xfrm>
+          <a:off x="0" y="0"/>
+          <a:ext cx="0" cy="0"/>
+          <a:chOff x="0" y="0"/>
+          <a:chExt cx="0" cy="0"/>
+        </a:xfrm>
+      </p:grpSpPr>
+      <p:sp>
+        <p:nvSpPr>
+          <p:cNvPr id="2" name="Espace réservé de l'image des diapositives 1">
+            <a:extLst>
+              <a:ext uri="{FF2B5EF4-FFF2-40B4-BE49-F238E27FC236}">
+                <a16:creationId xmlns:a16="http://schemas.microsoft.com/office/drawing/2014/main" id="{152958B0-9B5E-3C6A-6A34-E32FDF1E53D0}"/>
+              </a:ext>
+            </a:extLst>
+          </p:cNvPr>
+          <p:cNvSpPr>
+            <a:spLocks noGrp="1" noRot="1" noChangeAspect="1"/>
+          </p:cNvSpPr>
+          <p:nvPr>
+            <p:ph type="sldImg"/>
+          </p:nvPr>
+        </p:nvSpPr>
+        <p:spPr/>
+      </p:sp>
+      <p:sp>
+        <p:nvSpPr>
+          <p:cNvPr id="3" name="Espace réservé des notes 2">
+            <a:extLst>
+              <a:ext uri="{FF2B5EF4-FFF2-40B4-BE49-F238E27FC236}">
+                <a16:creationId xmlns:a16="http://schemas.microsoft.com/office/drawing/2014/main" id="{103625AD-36A9-EF9D-2A12-E41ED86DCD93}"/>
+              </a:ext>
+            </a:extLst>
+          </p:cNvPr>
+          <p:cNvSpPr>
+            <a:spLocks noGrp="1"/>
+          </p:cNvSpPr>
+          <p:nvPr>
+            <p:ph type="body" idx="1"/>
+          </p:nvPr>
+        </p:nvSpPr>
+        <p:spPr/>
+        <p:txBody>
+          <a:bodyPr/>
+          <a:lstStyle/>
+          <a:p>
+            <a:endParaRPr lang="fr-FR" dirty="0"/>
+          </a:p>
+        </p:txBody>
+      </p:sp>
+      <p:sp>
+        <p:nvSpPr>
+          <p:cNvPr id="4" name="Espace réservé du numéro de diapositive 3">
+            <a:extLst>
+              <a:ext uri="{FF2B5EF4-FFF2-40B4-BE49-F238E27FC236}">
+                <a16:creationId xmlns:a16="http://schemas.microsoft.com/office/drawing/2014/main" id="{3681F226-F793-F32A-2753-92C64F62AB8A}"/>
+              </a:ext>
+            </a:extLst>
+          </p:cNvPr>
+          <p:cNvSpPr>
+            <a:spLocks noGrp="1"/>
+          </p:cNvSpPr>
+          <p:nvPr>
+            <p:ph type="sldNum" sz="quarter" idx="5"/>
+          </p:nvPr>
+        </p:nvSpPr>
+        <p:spPr/>
+        <p:txBody>
+          <a:bodyPr/>
+          <a:lstStyle/>
+          <a:p>
+            <a:fld id="{F6105186-0725-443C-BC59-E521425E81CD}" type="slidenum">
+              <a:rPr lang="fr-FR" smtClean="0"/>
+              <a:t>6</a:t>
+            </a:fld>
+            <a:endParaRPr lang="fr-FR"/>
+          </a:p>
+        </p:txBody>
+      </p:sp>
+    </p:spTree>
+    <p:extLst>
+      <p:ext uri="{BB962C8B-B14F-4D97-AF65-F5344CB8AC3E}">
+        <p14:creationId xmlns:p14="http://schemas.microsoft.com/office/powerpoint/2010/main" val="302156910"/>
+      </p:ext>
+    </p:extLst>
+  </p:cSld>
+  <p:clrMapOvr>
+    <a:masterClrMapping/>
+  </p:clrMapOvr>
+</p:notes>
+</file>
+
+<file path=ppt/notesSlides/notesSlide6.xml><?xml version="1.0" encoding="utf-8"?>
+<p:notes xmlns:a="http://schemas.openxmlformats.org/drawingml/2006/main" xmlns:r="http://schemas.openxmlformats.org/officeDocument/2006/relationships" xmlns:p="http://schemas.openxmlformats.org/presentationml/2006/main">
+  <p:cSld>
+    <p:spTree>
+      <p:nvGrpSpPr>
+        <p:cNvPr id="1" name="">
+          <a:extLst>
+            <a:ext uri="{FF2B5EF4-FFF2-40B4-BE49-F238E27FC236}">
+              <a16:creationId xmlns:a16="http://schemas.microsoft.com/office/drawing/2014/main" id="{D440E1A3-FD76-F000-A100-2DB684065E6F}"/>
+            </a:ext>
+          </a:extLst>
+        </p:cNvPr>
+        <p:cNvGrpSpPr/>
+        <p:nvPr/>
+      </p:nvGrpSpPr>
+      <p:grpSpPr>
+        <a:xfrm>
+          <a:off x="0" y="0"/>
+          <a:ext cx="0" cy="0"/>
+          <a:chOff x="0" y="0"/>
+          <a:chExt cx="0" cy="0"/>
+        </a:xfrm>
+      </p:grpSpPr>
+      <p:sp>
+        <p:nvSpPr>
+          <p:cNvPr id="2" name="Espace réservé de l'image des diapositives 1">
+            <a:extLst>
+              <a:ext uri="{FF2B5EF4-FFF2-40B4-BE49-F238E27FC236}">
+                <a16:creationId xmlns:a16="http://schemas.microsoft.com/office/drawing/2014/main" id="{577E1A4E-4381-260C-B1C7-DDB9D0BECA67}"/>
+              </a:ext>
+            </a:extLst>
+          </p:cNvPr>
+          <p:cNvSpPr>
+            <a:spLocks noGrp="1" noRot="1" noChangeAspect="1"/>
+          </p:cNvSpPr>
+          <p:nvPr>
+            <p:ph type="sldImg"/>
+          </p:nvPr>
+        </p:nvSpPr>
+        <p:spPr/>
+      </p:sp>
+      <p:sp>
+        <p:nvSpPr>
+          <p:cNvPr id="3" name="Espace réservé des notes 2">
+            <a:extLst>
+              <a:ext uri="{FF2B5EF4-FFF2-40B4-BE49-F238E27FC236}">
+                <a16:creationId xmlns:a16="http://schemas.microsoft.com/office/drawing/2014/main" id="{0671271E-8665-F78E-E114-99C8A5788A36}"/>
+              </a:ext>
+            </a:extLst>
+          </p:cNvPr>
+          <p:cNvSpPr>
+            <a:spLocks noGrp="1"/>
+          </p:cNvSpPr>
+          <p:nvPr>
+            <p:ph type="body" idx="1"/>
+          </p:nvPr>
+        </p:nvSpPr>
+        <p:spPr/>
+        <p:txBody>
+          <a:bodyPr/>
+          <a:lstStyle/>
+          <a:p>
+            <a:endParaRPr lang="fr-FR" dirty="0"/>
+          </a:p>
+        </p:txBody>
+      </p:sp>
+      <p:sp>
+        <p:nvSpPr>
+          <p:cNvPr id="4" name="Espace réservé du numéro de diapositive 3">
+            <a:extLst>
+              <a:ext uri="{FF2B5EF4-FFF2-40B4-BE49-F238E27FC236}">
+                <a16:creationId xmlns:a16="http://schemas.microsoft.com/office/drawing/2014/main" id="{72E35661-87BB-08E3-248A-C88090C0FD3B}"/>
+              </a:ext>
+            </a:extLst>
+          </p:cNvPr>
+          <p:cNvSpPr>
+            <a:spLocks noGrp="1"/>
+          </p:cNvSpPr>
+          <p:nvPr>
+            <p:ph type="sldNum" sz="quarter" idx="5"/>
+          </p:nvPr>
+        </p:nvSpPr>
+        <p:spPr/>
+        <p:txBody>
+          <a:bodyPr/>
+          <a:lstStyle/>
+          <a:p>
+            <a:fld id="{F6105186-0725-443C-BC59-E521425E81CD}" type="slidenum">
+              <a:rPr lang="fr-FR" smtClean="0"/>
+              <a:t>7</a:t>
+            </a:fld>
+            <a:endParaRPr lang="fr-FR"/>
+          </a:p>
+        </p:txBody>
+      </p:sp>
+    </p:spTree>
+    <p:extLst>
+      <p:ext uri="{BB962C8B-B14F-4D97-AF65-F5344CB8AC3E}">
+        <p14:creationId xmlns:p14="http://schemas.microsoft.com/office/powerpoint/2010/main" val="1407631619"/>
+      </p:ext>
+    </p:extLst>
+  </p:cSld>
+  <p:clrMapOvr>
+    <a:masterClrMapping/>
+  </p:clrMapOvr>
+</p:notes>
+</file>
+
+<file path=ppt/notesSlides/notesSlide7.xml><?xml version="1.0" encoding="utf-8"?>
+<p:notes xmlns:a="http://schemas.openxmlformats.org/drawingml/2006/main" xmlns:r="http://schemas.openxmlformats.org/officeDocument/2006/relationships" xmlns:p="http://schemas.openxmlformats.org/presentationml/2006/main">
+  <p:cSld>
+    <p:spTree>
+      <p:nvGrpSpPr>
+        <p:cNvPr id="1" name="">
+          <a:extLst>
+            <a:ext uri="{FF2B5EF4-FFF2-40B4-BE49-F238E27FC236}">
+              <a16:creationId xmlns:a16="http://schemas.microsoft.com/office/drawing/2014/main" id="{72897529-EDF2-68BE-D218-BAC32F88B1EC}"/>
+            </a:ext>
+          </a:extLst>
+        </p:cNvPr>
+        <p:cNvGrpSpPr/>
+        <p:nvPr/>
+      </p:nvGrpSpPr>
+      <p:grpSpPr>
+        <a:xfrm>
+          <a:off x="0" y="0"/>
+          <a:ext cx="0" cy="0"/>
+          <a:chOff x="0" y="0"/>
+          <a:chExt cx="0" cy="0"/>
+        </a:xfrm>
+      </p:grpSpPr>
+      <p:sp>
+        <p:nvSpPr>
+          <p:cNvPr id="2" name="Espace réservé de l'image des diapositives 1">
+            <a:extLst>
+              <a:ext uri="{FF2B5EF4-FFF2-40B4-BE49-F238E27FC236}">
+                <a16:creationId xmlns:a16="http://schemas.microsoft.com/office/drawing/2014/main" id="{2AC71125-CE66-1F00-AA4E-42D2FFEAED5A}"/>
+              </a:ext>
+            </a:extLst>
+          </p:cNvPr>
+          <p:cNvSpPr>
+            <a:spLocks noGrp="1" noRot="1" noChangeAspect="1"/>
+          </p:cNvSpPr>
+          <p:nvPr>
+            <p:ph type="sldImg"/>
+          </p:nvPr>
+        </p:nvSpPr>
+        <p:spPr/>
+      </p:sp>
+      <p:sp>
+        <p:nvSpPr>
+          <p:cNvPr id="3" name="Espace réservé des notes 2">
+            <a:extLst>
+              <a:ext uri="{FF2B5EF4-FFF2-40B4-BE49-F238E27FC236}">
+                <a16:creationId xmlns:a16="http://schemas.microsoft.com/office/drawing/2014/main" id="{3D7298D0-1075-CFA2-B9E4-F65719E19809}"/>
+              </a:ext>
+            </a:extLst>
+          </p:cNvPr>
+          <p:cNvSpPr>
+            <a:spLocks noGrp="1"/>
+          </p:cNvSpPr>
+          <p:nvPr>
+            <p:ph type="body" idx="1"/>
+          </p:nvPr>
+        </p:nvSpPr>
+        <p:spPr/>
+        <p:txBody>
+          <a:bodyPr/>
+          <a:lstStyle/>
+          <a:p>
+            <a:endParaRPr lang="fr-FR" dirty="0"/>
+          </a:p>
+        </p:txBody>
+      </p:sp>
+      <p:sp>
+        <p:nvSpPr>
+          <p:cNvPr id="4" name="Espace réservé du numéro de diapositive 3">
+            <a:extLst>
+              <a:ext uri="{FF2B5EF4-FFF2-40B4-BE49-F238E27FC236}">
+                <a16:creationId xmlns:a16="http://schemas.microsoft.com/office/drawing/2014/main" id="{3B74665C-DB20-2C44-A4AB-ECCF45EFC0F3}"/>
+              </a:ext>
+            </a:extLst>
+          </p:cNvPr>
+          <p:cNvSpPr>
+            <a:spLocks noGrp="1"/>
+          </p:cNvSpPr>
+          <p:nvPr>
+            <p:ph type="sldNum" sz="quarter" idx="5"/>
+          </p:nvPr>
+        </p:nvSpPr>
+        <p:spPr/>
+        <p:txBody>
+          <a:bodyPr/>
+          <a:lstStyle/>
+          <a:p>
+            <a:fld id="{F6105186-0725-443C-BC59-E521425E81CD}" type="slidenum">
+              <a:rPr lang="fr-FR" smtClean="0"/>
+              <a:t>8</a:t>
+            </a:fld>
+            <a:endParaRPr lang="fr-FR"/>
+          </a:p>
+        </p:txBody>
+      </p:sp>
+    </p:spTree>
+    <p:extLst>
+      <p:ext uri="{BB962C8B-B14F-4D97-AF65-F5344CB8AC3E}">
+        <p14:creationId xmlns:p14="http://schemas.microsoft.com/office/powerpoint/2010/main" val="3547418018"/>
+      </p:ext>
+    </p:extLst>
+  </p:cSld>
+  <p:clrMapOvr>
+    <a:masterClrMapping/>
+  </p:clrMapOvr>
+</p:notes>
+</file>
+
+<file path=ppt/notesSlides/notesSlide8.xml><?xml version="1.0" encoding="utf-8"?>
+<p:notes xmlns:a="http://schemas.openxmlformats.org/drawingml/2006/main" xmlns:r="http://schemas.openxmlformats.org/officeDocument/2006/relationships" xmlns:p="http://schemas.openxmlformats.org/presentationml/2006/main">
+  <p:cSld>
+    <p:spTree>
+      <p:nvGrpSpPr>
+        <p:cNvPr id="1" name="">
+          <a:extLst>
+            <a:ext uri="{FF2B5EF4-FFF2-40B4-BE49-F238E27FC236}">
+              <a16:creationId xmlns:a16="http://schemas.microsoft.com/office/drawing/2014/main" id="{86B50A9E-1874-65E6-04F2-916CE1E613FA}"/>
+            </a:ext>
+          </a:extLst>
+        </p:cNvPr>
+        <p:cNvGrpSpPr/>
+        <p:nvPr/>
+      </p:nvGrpSpPr>
+      <p:grpSpPr>
+        <a:xfrm>
+          <a:off x="0" y="0"/>
+          <a:ext cx="0" cy="0"/>
+          <a:chOff x="0" y="0"/>
+          <a:chExt cx="0" cy="0"/>
+        </a:xfrm>
+      </p:grpSpPr>
+      <p:sp>
+        <p:nvSpPr>
+          <p:cNvPr id="2" name="Espace réservé de l'image des diapositives 1">
+            <a:extLst>
+              <a:ext uri="{FF2B5EF4-FFF2-40B4-BE49-F238E27FC236}">
+                <a16:creationId xmlns:a16="http://schemas.microsoft.com/office/drawing/2014/main" id="{70B3DEEB-0369-7BA2-323D-3E6B857D9108}"/>
+              </a:ext>
+            </a:extLst>
+          </p:cNvPr>
+          <p:cNvSpPr>
+            <a:spLocks noGrp="1" noRot="1" noChangeAspect="1"/>
+          </p:cNvSpPr>
+          <p:nvPr>
+            <p:ph type="sldImg"/>
+          </p:nvPr>
+        </p:nvSpPr>
+        <p:spPr/>
+      </p:sp>
+      <p:sp>
+        <p:nvSpPr>
+          <p:cNvPr id="3" name="Espace réservé des notes 2">
+            <a:extLst>
+              <a:ext uri="{FF2B5EF4-FFF2-40B4-BE49-F238E27FC236}">
+                <a16:creationId xmlns:a16="http://schemas.microsoft.com/office/drawing/2014/main" id="{294A4C0A-ECE6-BDF3-3B3D-5A7EE7EAE93D}"/>
+              </a:ext>
+            </a:extLst>
+          </p:cNvPr>
+          <p:cNvSpPr>
+            <a:spLocks noGrp="1"/>
+          </p:cNvSpPr>
+          <p:nvPr>
+            <p:ph type="body" idx="1"/>
+          </p:nvPr>
+        </p:nvSpPr>
+        <p:spPr/>
+        <p:txBody>
+          <a:bodyPr/>
+          <a:lstStyle/>
+          <a:p>
+            <a:endParaRPr lang="fr-FR" dirty="0"/>
+          </a:p>
+        </p:txBody>
+      </p:sp>
+      <p:sp>
+        <p:nvSpPr>
+          <p:cNvPr id="4" name="Espace réservé du numéro de diapositive 3">
+            <a:extLst>
+              <a:ext uri="{FF2B5EF4-FFF2-40B4-BE49-F238E27FC236}">
+                <a16:creationId xmlns:a16="http://schemas.microsoft.com/office/drawing/2014/main" id="{36997EC5-9BDA-B269-C3FC-735E6A0F67DB}"/>
+              </a:ext>
+            </a:extLst>
+          </p:cNvPr>
+          <p:cNvSpPr>
+            <a:spLocks noGrp="1"/>
+          </p:cNvSpPr>
+          <p:nvPr>
+            <p:ph type="sldNum" sz="quarter" idx="5"/>
+          </p:nvPr>
+        </p:nvSpPr>
+        <p:spPr/>
+        <p:txBody>
+          <a:bodyPr/>
+          <a:lstStyle/>
+          <a:p>
+            <a:fld id="{F6105186-0725-443C-BC59-E521425E81CD}" type="slidenum">
+              <a:rPr lang="fr-FR" smtClean="0"/>
+              <a:t>9</a:t>
+            </a:fld>
+            <a:endParaRPr lang="fr-FR"/>
+          </a:p>
+        </p:txBody>
+      </p:sp>
+    </p:spTree>
+    <p:extLst>
+      <p:ext uri="{BB962C8B-B14F-4D97-AF65-F5344CB8AC3E}">
+        <p14:creationId xmlns:p14="http://schemas.microsoft.com/office/powerpoint/2010/main" val="3878790321"/>
+      </p:ext>
+    </p:extLst>
+  </p:cSld>
+  <p:clrMapOvr>
+    <a:masterClrMapping/>
+  </p:clrMapOvr>
+</p:notes>
+</file>
+
+<file path=ppt/notesSlides/notesSlide9.xml><?xml version="1.0" encoding="utf-8"?>
+<p:notes xmlns:a="http://schemas.openxmlformats.org/drawingml/2006/main" xmlns:r="http://schemas.openxmlformats.org/officeDocument/2006/relationships" xmlns:p="http://schemas.openxmlformats.org/presentationml/2006/main">
+  <p:cSld>
+    <p:spTree>
+      <p:nvGrpSpPr>
+        <p:cNvPr id="1" name="">
+          <a:extLst>
+            <a:ext uri="{FF2B5EF4-FFF2-40B4-BE49-F238E27FC236}">
+              <a16:creationId xmlns:a16="http://schemas.microsoft.com/office/drawing/2014/main" id="{0409AC75-274F-4FB2-E63B-5C6E2067BAC7}"/>
+            </a:ext>
+          </a:extLst>
+        </p:cNvPr>
+        <p:cNvGrpSpPr/>
+        <p:nvPr/>
+      </p:nvGrpSpPr>
+      <p:grpSpPr>
+        <a:xfrm>
+          <a:off x="0" y="0"/>
+          <a:ext cx="0" cy="0"/>
+          <a:chOff x="0" y="0"/>
+          <a:chExt cx="0" cy="0"/>
+        </a:xfrm>
+      </p:grpSpPr>
+      <p:sp>
+        <p:nvSpPr>
+          <p:cNvPr id="2" name="Espace réservé de l'image des diapositives 1">
+            <a:extLst>
+              <a:ext uri="{FF2B5EF4-FFF2-40B4-BE49-F238E27FC236}">
+                <a16:creationId xmlns:a16="http://schemas.microsoft.com/office/drawing/2014/main" id="{CB4865C5-1C52-D5F2-2F92-F925CAB6EA38}"/>
+              </a:ext>
+            </a:extLst>
+          </p:cNvPr>
+          <p:cNvSpPr>
+            <a:spLocks noGrp="1" noRot="1" noChangeAspect="1"/>
+          </p:cNvSpPr>
+          <p:nvPr>
+            <p:ph type="sldImg"/>
+          </p:nvPr>
+        </p:nvSpPr>
+        <p:spPr/>
+      </p:sp>
+      <p:sp>
+        <p:nvSpPr>
+          <p:cNvPr id="3" name="Espace réservé des notes 2">
+            <a:extLst>
+              <a:ext uri="{FF2B5EF4-FFF2-40B4-BE49-F238E27FC236}">
+                <a16:creationId xmlns:a16="http://schemas.microsoft.com/office/drawing/2014/main" id="{1C86E280-FB59-7D3C-4EF6-FAEF4ABC0263}"/>
+              </a:ext>
+            </a:extLst>
+          </p:cNvPr>
+          <p:cNvSpPr>
+            <a:spLocks noGrp="1"/>
+          </p:cNvSpPr>
+          <p:nvPr>
+            <p:ph type="body" idx="1"/>
+          </p:nvPr>
+        </p:nvSpPr>
+        <p:spPr/>
+        <p:txBody>
+          <a:bodyPr/>
+          <a:lstStyle/>
+          <a:p>
+            <a:endParaRPr lang="fr-FR" dirty="0"/>
+          </a:p>
+        </p:txBody>
+      </p:sp>
+      <p:sp>
+        <p:nvSpPr>
+          <p:cNvPr id="4" name="Espace réservé du numéro de diapositive 3">
+            <a:extLst>
+              <a:ext uri="{FF2B5EF4-FFF2-40B4-BE49-F238E27FC236}">
+                <a16:creationId xmlns:a16="http://schemas.microsoft.com/office/drawing/2014/main" id="{A71DD530-E890-CC6D-410E-2B45EAF4DB59}"/>
+              </a:ext>
+            </a:extLst>
+          </p:cNvPr>
+          <p:cNvSpPr>
+            <a:spLocks noGrp="1"/>
+          </p:cNvSpPr>
+          <p:nvPr>
+            <p:ph type="sldNum" sz="quarter" idx="5"/>
+          </p:nvPr>
+        </p:nvSpPr>
+        <p:spPr/>
+        <p:txBody>
+          <a:bodyPr/>
+          <a:lstStyle/>
+          <a:p>
+            <a:fld id="{F6105186-0725-443C-BC59-E521425E81CD}" type="slidenum">
+              <a:rPr lang="fr-FR" smtClean="0"/>
+              <a:t>10</a:t>
+            </a:fld>
+            <a:endParaRPr lang="fr-FR"/>
+          </a:p>
+        </p:txBody>
+      </p:sp>
+    </p:spTree>
+    <p:extLst>
+      <p:ext uri="{BB962C8B-B14F-4D97-AF65-F5344CB8AC3E}">
+        <p14:creationId xmlns:p14="http://schemas.microsoft.com/office/powerpoint/2010/main" val="2364212323"/>
+      </p:ext>
+    </p:extLst>
+  </p:cSld>
+  <p:clrMapOvr>
+    <a:masterClrMapping/>
+  </p:clrMapOvr>
+</p:notes>
+</file>
+
 <file path=ppt/slideLayouts/slideLayout1.xml><?xml version="1.0" encoding="utf-8"?>
 <p:sldLayout xmlns:a="http://schemas.openxmlformats.org/drawingml/2006/main" xmlns:r="http://schemas.openxmlformats.org/officeDocument/2006/relationships" xmlns:p="http://schemas.openxmlformats.org/presentationml/2006/main" type="title" preserve="1">
   <p:cSld name="Diapositive de titre">
@@ -1023,7 +1677,7 @@
           <a:p>
             <a:fld id="{4E51AFDA-D128-4B68-A211-269E2451E5DE}" type="datetimeFigureOut">
               <a:rPr lang="fr-FR" smtClean="0"/>
-              <a:t>02/03/2026</a:t>
+              <a:t>03/03/2026</a:t>
             </a:fld>
             <a:endParaRPr lang="fr-FR"/>
           </a:p>
@@ -1221,7 +1875,7 @@
           <a:p>
             <a:fld id="{4E51AFDA-D128-4B68-A211-269E2451E5DE}" type="datetimeFigureOut">
               <a:rPr lang="fr-FR" smtClean="0"/>
-              <a:t>02/03/2026</a:t>
+              <a:t>03/03/2026</a:t>
             </a:fld>
             <a:endParaRPr lang="fr-FR"/>
           </a:p>
@@ -1429,7 +2083,7 @@
           <a:p>
             <a:fld id="{4E51AFDA-D128-4B68-A211-269E2451E5DE}" type="datetimeFigureOut">
               <a:rPr lang="fr-FR" smtClean="0"/>
-              <a:t>02/03/2026</a:t>
+              <a:t>03/03/2026</a:t>
             </a:fld>
             <a:endParaRPr lang="fr-FR"/>
           </a:p>
@@ -1627,7 +2281,7 @@
           <a:p>
             <a:fld id="{4E51AFDA-D128-4B68-A211-269E2451E5DE}" type="datetimeFigureOut">
               <a:rPr lang="fr-FR" smtClean="0"/>
-              <a:t>02/03/2026</a:t>
+              <a:t>03/03/2026</a:t>
             </a:fld>
             <a:endParaRPr lang="fr-FR"/>
           </a:p>
@@ -1902,7 +2556,7 @@
           <a:p>
             <a:fld id="{4E51AFDA-D128-4B68-A211-269E2451E5DE}" type="datetimeFigureOut">
               <a:rPr lang="fr-FR" smtClean="0"/>
-              <a:t>02/03/2026</a:t>
+              <a:t>03/03/2026</a:t>
             </a:fld>
             <a:endParaRPr lang="fr-FR"/>
           </a:p>
@@ -2167,7 +2821,7 @@
           <a:p>
             <a:fld id="{4E51AFDA-D128-4B68-A211-269E2451E5DE}" type="datetimeFigureOut">
               <a:rPr lang="fr-FR" smtClean="0"/>
-              <a:t>02/03/2026</a:t>
+              <a:t>03/03/2026</a:t>
             </a:fld>
             <a:endParaRPr lang="fr-FR"/>
           </a:p>
@@ -2579,7 +3233,7 @@
           <a:p>
             <a:fld id="{4E51AFDA-D128-4B68-A211-269E2451E5DE}" type="datetimeFigureOut">
               <a:rPr lang="fr-FR" smtClean="0"/>
-              <a:t>02/03/2026</a:t>
+              <a:t>03/03/2026</a:t>
             </a:fld>
             <a:endParaRPr lang="fr-FR"/>
           </a:p>
@@ -2720,7 +3374,7 @@
           <a:p>
             <a:fld id="{4E51AFDA-D128-4B68-A211-269E2451E5DE}" type="datetimeFigureOut">
               <a:rPr lang="fr-FR" smtClean="0"/>
-              <a:t>02/03/2026</a:t>
+              <a:t>03/03/2026</a:t>
             </a:fld>
             <a:endParaRPr lang="fr-FR"/>
           </a:p>
@@ -2833,7 +3487,7 @@
           <a:p>
             <a:fld id="{4E51AFDA-D128-4B68-A211-269E2451E5DE}" type="datetimeFigureOut">
               <a:rPr lang="fr-FR" smtClean="0"/>
-              <a:t>02/03/2026</a:t>
+              <a:t>03/03/2026</a:t>
             </a:fld>
             <a:endParaRPr lang="fr-FR"/>
           </a:p>
@@ -3144,7 +3798,7 @@
           <a:p>
             <a:fld id="{4E51AFDA-D128-4B68-A211-269E2451E5DE}" type="datetimeFigureOut">
               <a:rPr lang="fr-FR" smtClean="0"/>
-              <a:t>02/03/2026</a:t>
+              <a:t>03/03/2026</a:t>
             </a:fld>
             <a:endParaRPr lang="fr-FR"/>
           </a:p>
@@ -3432,7 +4086,7 @@
           <a:p>
             <a:fld id="{4E51AFDA-D128-4B68-A211-269E2451E5DE}" type="datetimeFigureOut">
               <a:rPr lang="fr-FR" smtClean="0"/>
-              <a:t>02/03/2026</a:t>
+              <a:t>03/03/2026</a:t>
             </a:fld>
             <a:endParaRPr lang="fr-FR"/>
           </a:p>
@@ -3673,7 +4327,7 @@
           <a:p>
             <a:fld id="{4E51AFDA-D128-4B68-A211-269E2451E5DE}" type="datetimeFigureOut">
               <a:rPr lang="fr-FR" smtClean="0"/>
-              <a:t>02/03/2026</a:t>
+              <a:t>03/03/2026</a:t>
             </a:fld>
             <a:endParaRPr lang="fr-FR"/>
           </a:p>
@@ -4237,6 +4891,328 @@
 </p:sld>
 </file>
 
+<file path=ppt/slides/slide10.xml><?xml version="1.0" encoding="utf-8"?>
+<p:sld xmlns:a="http://schemas.openxmlformats.org/drawingml/2006/main" xmlns:r="http://schemas.openxmlformats.org/officeDocument/2006/relationships" xmlns:p="http://schemas.openxmlformats.org/presentationml/2006/main">
+  <p:cSld>
+    <p:spTree>
+      <p:nvGrpSpPr>
+        <p:cNvPr id="1" name="">
+          <a:extLst>
+            <a:ext uri="{FF2B5EF4-FFF2-40B4-BE49-F238E27FC236}">
+              <a16:creationId xmlns:a16="http://schemas.microsoft.com/office/drawing/2014/main" id="{647998A4-448F-107D-A678-DB3E2F8084E3}"/>
+            </a:ext>
+          </a:extLst>
+        </p:cNvPr>
+        <p:cNvGrpSpPr/>
+        <p:nvPr/>
+      </p:nvGrpSpPr>
+      <p:grpSpPr>
+        <a:xfrm>
+          <a:off x="0" y="0"/>
+          <a:ext cx="0" cy="0"/>
+          <a:chOff x="0" y="0"/>
+          <a:chExt cx="0" cy="0"/>
+        </a:xfrm>
+      </p:grpSpPr>
+      <p:sp>
+        <p:nvSpPr>
+          <p:cNvPr id="2" name="Titre 1">
+            <a:extLst>
+              <a:ext uri="{FF2B5EF4-FFF2-40B4-BE49-F238E27FC236}">
+                <a16:creationId xmlns:a16="http://schemas.microsoft.com/office/drawing/2014/main" id="{740F5659-B12B-C92B-98DF-B72B0BE9ED86}"/>
+              </a:ext>
+            </a:extLst>
+          </p:cNvPr>
+          <p:cNvSpPr>
+            <a:spLocks noGrp="1"/>
+          </p:cNvSpPr>
+          <p:nvPr>
+            <p:ph type="title"/>
+          </p:nvPr>
+        </p:nvSpPr>
+        <p:spPr>
+          <a:xfrm>
+            <a:off x="838200" y="118237"/>
+            <a:ext cx="10515600" cy="1325563"/>
+          </a:xfrm>
+        </p:spPr>
+        <p:txBody>
+          <a:bodyPr/>
+          <a:lstStyle/>
+          <a:p>
+            <a:r>
+              <a:rPr lang="fr-FR" dirty="0"/>
+              <a:t>D) Graphiques de convergence : Temps</a:t>
+            </a:r>
+          </a:p>
+        </p:txBody>
+      </p:sp>
+      <p:sp>
+        <p:nvSpPr>
+          <p:cNvPr id="10" name="ZoneTexte 9">
+            <a:extLst>
+              <a:ext uri="{FF2B5EF4-FFF2-40B4-BE49-F238E27FC236}">
+                <a16:creationId xmlns:a16="http://schemas.microsoft.com/office/drawing/2014/main" id="{2C8B477F-8FA4-A391-5690-7C59D866F1C3}"/>
+              </a:ext>
+            </a:extLst>
+          </p:cNvPr>
+          <p:cNvSpPr txBox="1"/>
+          <p:nvPr/>
+        </p:nvSpPr>
+        <p:spPr>
+          <a:xfrm>
+            <a:off x="2154455" y="5086407"/>
+            <a:ext cx="8654716" cy="1384995"/>
+          </a:xfrm>
+          <a:prstGeom prst="rect">
+            <a:avLst/>
+          </a:prstGeom>
+          <a:noFill/>
+        </p:spPr>
+        <p:txBody>
+          <a:bodyPr wrap="square" rtlCol="0">
+            <a:spAutoFit/>
+          </a:bodyPr>
+          <a:lstStyle/>
+          <a:p>
+            <a:pPr algn="just"/>
+            <a:r>
+              <a:rPr lang="fr-CA" sz="1200" dirty="0"/>
+              <a:t>On peut voir que la convergence en espace est environ d’ordre 1 pour les trois types d’erreur. Cela est attendu avec les développements du terme de troncature montrés en A. Les écarts s’expliquent aussi par les données prise en compte dans la convergence asymptotiques ; certaines erreurs sont aberrantes et ne devraient pas être prises en compte dans le calcul. Plus de pas de résolution pourraient aider à améliorer l’estimation de l’ordre de convergence asymptotique.</a:t>
+            </a:r>
+          </a:p>
+          <a:p>
+            <a:pPr algn="just"/>
+            <a:endParaRPr lang="fr-CA" sz="1200" dirty="0"/>
+          </a:p>
+          <a:p>
+            <a:pPr algn="just"/>
+            <a:r>
+              <a:rPr lang="fr-CA" sz="1200" dirty="0"/>
+              <a:t>On voit ici que le pas de discrétisation en espace a été bien choisi puisqu’il ne semble pas affecter (faire atteindre un plateau) l’erreur de discrétisation en temps, malgré le raffinement.</a:t>
+            </a:r>
+          </a:p>
+        </p:txBody>
+      </p:sp>
+      <p:pic>
+        <p:nvPicPr>
+          <p:cNvPr id="5" name="Image 4">
+            <a:extLst>
+              <a:ext uri="{FF2B5EF4-FFF2-40B4-BE49-F238E27FC236}">
+                <a16:creationId xmlns:a16="http://schemas.microsoft.com/office/drawing/2014/main" id="{6AD7C5DB-1F1F-B6A8-1FBD-4E77BE27347F}"/>
+              </a:ext>
+            </a:extLst>
+          </p:cNvPr>
+          <p:cNvPicPr>
+            <a:picLocks noChangeAspect="1"/>
+          </p:cNvPicPr>
+          <p:nvPr/>
+        </p:nvPicPr>
+        <p:blipFill>
+          <a:blip r:embed="rId3"/>
+          <a:stretch>
+            <a:fillRect/>
+          </a:stretch>
+        </p:blipFill>
+        <p:spPr>
+          <a:xfrm>
+            <a:off x="3436938" y="1238637"/>
+            <a:ext cx="5735938" cy="3734663"/>
+          </a:xfrm>
+          <a:prstGeom prst="rect">
+            <a:avLst/>
+          </a:prstGeom>
+        </p:spPr>
+      </p:pic>
+      <p:sp>
+        <p:nvSpPr>
+          <p:cNvPr id="6" name="ZoneTexte 5">
+            <a:extLst>
+              <a:ext uri="{FF2B5EF4-FFF2-40B4-BE49-F238E27FC236}">
+                <a16:creationId xmlns:a16="http://schemas.microsoft.com/office/drawing/2014/main" id="{0866BF2C-0970-5AC0-D3F7-91E5592C8E01}"/>
+              </a:ext>
+            </a:extLst>
+          </p:cNvPr>
+          <p:cNvSpPr txBox="1"/>
+          <p:nvPr/>
+        </p:nvSpPr>
+        <p:spPr>
+          <a:xfrm>
+            <a:off x="9954150" y="1665838"/>
+            <a:ext cx="1710042" cy="923330"/>
+          </a:xfrm>
+          <a:prstGeom prst="rect">
+            <a:avLst/>
+          </a:prstGeom>
+          <a:noFill/>
+          <a:ln>
+            <a:solidFill>
+              <a:schemeClr val="accent6"/>
+            </a:solidFill>
+          </a:ln>
+        </p:spPr>
+        <p:txBody>
+          <a:bodyPr wrap="square" rtlCol="0">
+            <a:spAutoFit/>
+          </a:bodyPr>
+          <a:lstStyle/>
+          <a:p>
+            <a:r>
+              <a:rPr lang="fr-CA" dirty="0"/>
+              <a:t>*Résultats obtenus avec un script Bash</a:t>
+            </a:r>
+          </a:p>
+        </p:txBody>
+      </p:sp>
+    </p:spTree>
+    <p:extLst>
+      <p:ext uri="{BB962C8B-B14F-4D97-AF65-F5344CB8AC3E}">
+        <p14:creationId xmlns:p14="http://schemas.microsoft.com/office/powerpoint/2010/main" val="1009329588"/>
+      </p:ext>
+    </p:extLst>
+  </p:cSld>
+  <p:clrMapOvr>
+    <a:masterClrMapping/>
+  </p:clrMapOvr>
+</p:sld>
+</file>
+
+<file path=ppt/slides/slide11.xml><?xml version="1.0" encoding="utf-8"?>
+<p:sld xmlns:a="http://schemas.openxmlformats.org/drawingml/2006/main" xmlns:r="http://schemas.openxmlformats.org/officeDocument/2006/relationships" xmlns:p="http://schemas.openxmlformats.org/presentationml/2006/main">
+  <p:cSld>
+    <p:spTree>
+      <p:nvGrpSpPr>
+        <p:cNvPr id="1" name="">
+          <a:extLst>
+            <a:ext uri="{FF2B5EF4-FFF2-40B4-BE49-F238E27FC236}">
+              <a16:creationId xmlns:a16="http://schemas.microsoft.com/office/drawing/2014/main" id="{5CE1FD4F-689A-DD1F-99B3-4F9E32181D71}"/>
+            </a:ext>
+          </a:extLst>
+        </p:cNvPr>
+        <p:cNvGrpSpPr/>
+        <p:nvPr/>
+      </p:nvGrpSpPr>
+      <p:grpSpPr>
+        <a:xfrm>
+          <a:off x="0" y="0"/>
+          <a:ext cx="0" cy="0"/>
+          <a:chOff x="0" y="0"/>
+          <a:chExt cx="0" cy="0"/>
+        </a:xfrm>
+      </p:grpSpPr>
+      <p:sp>
+        <p:nvSpPr>
+          <p:cNvPr id="2" name="Titre 1">
+            <a:extLst>
+              <a:ext uri="{FF2B5EF4-FFF2-40B4-BE49-F238E27FC236}">
+                <a16:creationId xmlns:a16="http://schemas.microsoft.com/office/drawing/2014/main" id="{24CC7E58-E30E-357C-5056-9D8B86DEB5B0}"/>
+              </a:ext>
+            </a:extLst>
+          </p:cNvPr>
+          <p:cNvSpPr>
+            <a:spLocks noGrp="1"/>
+          </p:cNvSpPr>
+          <p:nvPr>
+            <p:ph type="title"/>
+          </p:nvPr>
+        </p:nvSpPr>
+        <p:spPr>
+          <a:xfrm>
+            <a:off x="838200" y="118237"/>
+            <a:ext cx="10515600" cy="1325563"/>
+          </a:xfrm>
+        </p:spPr>
+        <p:txBody>
+          <a:bodyPr/>
+          <a:lstStyle/>
+          <a:p>
+            <a:r>
+              <a:rPr lang="fr-FR" dirty="0"/>
+              <a:t>F) Concentration en Sel dans le Cylindre après </a:t>
+            </a:r>
+          </a:p>
+        </p:txBody>
+      </p:sp>
+      <p:sp>
+        <p:nvSpPr>
+          <p:cNvPr id="10" name="ZoneTexte 9">
+            <a:extLst>
+              <a:ext uri="{FF2B5EF4-FFF2-40B4-BE49-F238E27FC236}">
+                <a16:creationId xmlns:a16="http://schemas.microsoft.com/office/drawing/2014/main" id="{4F1222AD-43E4-CCAE-4799-14DD32D34060}"/>
+              </a:ext>
+            </a:extLst>
+          </p:cNvPr>
+          <p:cNvSpPr txBox="1"/>
+          <p:nvPr/>
+        </p:nvSpPr>
+        <p:spPr>
+          <a:xfrm>
+            <a:off x="3250932" y="6154988"/>
+            <a:ext cx="5690135" cy="584775"/>
+          </a:xfrm>
+          <a:prstGeom prst="rect">
+            <a:avLst/>
+          </a:prstGeom>
+          <a:noFill/>
+        </p:spPr>
+        <p:txBody>
+          <a:bodyPr wrap="square" rtlCol="0">
+            <a:spAutoFit/>
+          </a:bodyPr>
+          <a:lstStyle/>
+          <a:p>
+            <a:pPr algn="ctr"/>
+            <a:r>
+              <a:rPr lang="fr-CA" sz="1600" dirty="0"/>
+              <a:t>Tracé de la solution qui serait autrement analytiquement très difficile à trouver.</a:t>
+            </a:r>
+          </a:p>
+        </p:txBody>
+      </p:sp>
+      <p:pic>
+        <p:nvPicPr>
+          <p:cNvPr id="4" name="Image 3">
+            <a:extLst>
+              <a:ext uri="{FF2B5EF4-FFF2-40B4-BE49-F238E27FC236}">
+                <a16:creationId xmlns:a16="http://schemas.microsoft.com/office/drawing/2014/main" id="{6B6DFE22-7DED-654E-D97F-92F00AC47F11}"/>
+              </a:ext>
+            </a:extLst>
+          </p:cNvPr>
+          <p:cNvPicPr>
+            <a:picLocks noChangeAspect="1"/>
+          </p:cNvPicPr>
+          <p:nvPr/>
+        </p:nvPicPr>
+        <p:blipFill>
+          <a:blip r:embed="rId3"/>
+          <a:srcRect b="1552"/>
+          <a:stretch>
+            <a:fillRect/>
+          </a:stretch>
+        </p:blipFill>
+        <p:spPr>
+          <a:xfrm>
+            <a:off x="1222122" y="1292215"/>
+            <a:ext cx="9193943" cy="4936569"/>
+          </a:xfrm>
+          <a:prstGeom prst="rect">
+            <a:avLst/>
+          </a:prstGeom>
+        </p:spPr>
+      </p:pic>
+    </p:spTree>
+    <p:extLst>
+      <p:ext uri="{BB962C8B-B14F-4D97-AF65-F5344CB8AC3E}">
+        <p14:creationId xmlns:p14="http://schemas.microsoft.com/office/powerpoint/2010/main" val="271766363"/>
+      </p:ext>
+    </p:extLst>
+  </p:cSld>
+  <p:clrMapOvr>
+    <a:masterClrMapping/>
+  </p:clrMapOvr>
+</p:sld>
+</file>
+
 <file path=ppt/slides/slide2.xml><?xml version="1.0" encoding="utf-8"?>
 <p:sld xmlns:a="http://schemas.openxmlformats.org/drawingml/2006/main" xmlns:r="http://schemas.openxmlformats.org/officeDocument/2006/relationships" xmlns:p="http://schemas.openxmlformats.org/presentationml/2006/main">
   <p:cSld>
@@ -8929,8 +9905,8 @@
           </a:prstGeom>
         </p:spPr>
       </p:pic>
-      <mc:AlternateContent xmlns:mc="http://schemas.openxmlformats.org/markup-compatibility/2006">
-        <mc:Choice xmlns:a14="http://schemas.microsoft.com/office/drawing/2010/main" Requires="a14">
+      <mc:AlternateContent xmlns:mc="http://schemas.openxmlformats.org/markup-compatibility/2006" xmlns:a14="http://schemas.microsoft.com/office/drawing/2010/main">
+        <mc:Choice Requires="a14">
           <p:sp>
             <p:nvSpPr>
               <p:cNvPr id="6" name="ZoneTexte 5">
@@ -9524,7 +10500,7 @@
             </p:txBody>
           </p:sp>
         </mc:Choice>
-        <mc:Fallback>
+        <mc:Fallback xmlns="">
           <p:sp>
             <p:nvSpPr>
               <p:cNvPr id="6" name="ZoneTexte 5">
@@ -12171,6 +13147,2271 @@
 </p:sld>
 </file>
 
+<file path=ppt/slides/slide6.xml><?xml version="1.0" encoding="utf-8"?>
+<p:sld xmlns:a="http://schemas.openxmlformats.org/drawingml/2006/main" xmlns:r="http://schemas.openxmlformats.org/officeDocument/2006/relationships" xmlns:p="http://schemas.openxmlformats.org/presentationml/2006/main">
+  <p:cSld>
+    <p:spTree>
+      <p:nvGrpSpPr>
+        <p:cNvPr id="1" name="">
+          <a:extLst>
+            <a:ext uri="{FF2B5EF4-FFF2-40B4-BE49-F238E27FC236}">
+              <a16:creationId xmlns:a16="http://schemas.microsoft.com/office/drawing/2014/main" id="{030FAE7B-4A1E-DE0B-CDE7-406888289E8B}"/>
+            </a:ext>
+          </a:extLst>
+        </p:cNvPr>
+        <p:cNvGrpSpPr/>
+        <p:nvPr/>
+      </p:nvGrpSpPr>
+      <p:grpSpPr>
+        <a:xfrm>
+          <a:off x="0" y="0"/>
+          <a:ext cx="0" cy="0"/>
+          <a:chOff x="0" y="0"/>
+          <a:chExt cx="0" cy="0"/>
+        </a:xfrm>
+      </p:grpSpPr>
+      <p:sp>
+        <p:nvSpPr>
+          <p:cNvPr id="2" name="Titre 1">
+            <a:extLst>
+              <a:ext uri="{FF2B5EF4-FFF2-40B4-BE49-F238E27FC236}">
+                <a16:creationId xmlns:a16="http://schemas.microsoft.com/office/drawing/2014/main" id="{21004852-1D96-75BB-5269-125CBC420C3C}"/>
+              </a:ext>
+            </a:extLst>
+          </p:cNvPr>
+          <p:cNvSpPr>
+            <a:spLocks noGrp="1"/>
+          </p:cNvSpPr>
+          <p:nvPr>
+            <p:ph type="title"/>
+          </p:nvPr>
+        </p:nvSpPr>
+        <p:spPr>
+          <a:xfrm>
+            <a:off x="838200" y="118237"/>
+            <a:ext cx="10515600" cy="1325563"/>
+          </a:xfrm>
+        </p:spPr>
+        <p:txBody>
+          <a:bodyPr/>
+          <a:lstStyle/>
+          <a:p>
+            <a:r>
+              <a:rPr lang="fr-FR" dirty="0"/>
+              <a:t>B) Solution Manufacturée</a:t>
+            </a:r>
+          </a:p>
+        </p:txBody>
+      </p:sp>
+      <mc:AlternateContent xmlns:mc="http://schemas.openxmlformats.org/markup-compatibility/2006" xmlns:a14="http://schemas.microsoft.com/office/drawing/2010/main">
+        <mc:Choice Requires="a14">
+          <p:sp>
+            <p:nvSpPr>
+              <p:cNvPr id="5" name="Espace réservé du contenu 4">
+                <a:extLst>
+                  <a:ext uri="{FF2B5EF4-FFF2-40B4-BE49-F238E27FC236}">
+                    <a16:creationId xmlns:a16="http://schemas.microsoft.com/office/drawing/2014/main" id="{E4A42691-9CFE-45C6-A49C-301D0207827F}"/>
+                  </a:ext>
+                </a:extLst>
+              </p:cNvPr>
+              <p:cNvSpPr>
+                <a:spLocks noGrp="1"/>
+              </p:cNvSpPr>
+              <p:nvPr>
+                <p:ph idx="1"/>
+              </p:nvPr>
+            </p:nvSpPr>
+            <p:spPr/>
+            <p:txBody>
+              <a:bodyPr/>
+              <a:lstStyle/>
+              <a:p>
+                <a:pPr marL="0" indent="0">
+                  <a:buNone/>
+                </a:pPr>
+                <a:r>
+                  <a:rPr lang="fr-CA" dirty="0"/>
+                  <a:t>Équation : </a:t>
+                </a:r>
+                <a14:m>
+                  <m:oMath xmlns:m="http://schemas.openxmlformats.org/officeDocument/2006/math">
+                    <m:sSub>
+                      <m:sSubPr>
+                        <m:ctrlPr>
+                          <a:rPr lang="fr-CA" b="0" i="1" smtClean="0">
+                            <a:latin typeface="Cambria Math" panose="02040503050406030204" pitchFamily="18" charset="0"/>
+                          </a:rPr>
+                        </m:ctrlPr>
+                      </m:sSubPr>
+                      <m:e>
+                        <m:r>
+                          <a:rPr lang="fr-CA" b="0" i="1" smtClean="0">
+                            <a:latin typeface="Cambria Math" panose="02040503050406030204" pitchFamily="18" charset="0"/>
+                          </a:rPr>
+                          <m:t>𝐶</m:t>
+                        </m:r>
+                      </m:e>
+                      <m:sub>
+                        <m:r>
+                          <a:rPr lang="fr-CA" b="0" i="1" smtClean="0">
+                            <a:latin typeface="Cambria Math" panose="02040503050406030204" pitchFamily="18" charset="0"/>
+                          </a:rPr>
+                          <m:t>𝑚𝑚𝑠</m:t>
+                        </m:r>
+                      </m:sub>
+                    </m:sSub>
+                    <m:r>
+                      <a:rPr lang="fr-CA" b="0" i="1" smtClean="0">
+                        <a:latin typeface="Cambria Math" panose="02040503050406030204" pitchFamily="18" charset="0"/>
+                      </a:rPr>
+                      <m:t>=1+</m:t>
+                    </m:r>
+                    <m:func>
+                      <m:funcPr>
+                        <m:ctrlPr>
+                          <a:rPr lang="fr-CA" b="0" i="1" smtClean="0">
+                            <a:latin typeface="Cambria Math" panose="02040503050406030204" pitchFamily="18" charset="0"/>
+                          </a:rPr>
+                        </m:ctrlPr>
+                      </m:funcPr>
+                      <m:fName>
+                        <m:r>
+                          <m:rPr>
+                            <m:sty m:val="p"/>
+                          </m:rPr>
+                          <a:rPr lang="fr-CA" b="0" i="0" smtClean="0">
+                            <a:latin typeface="Cambria Math" panose="02040503050406030204" pitchFamily="18" charset="0"/>
+                          </a:rPr>
+                          <m:t>cos</m:t>
+                        </m:r>
+                      </m:fName>
+                      <m:e>
+                        <m:d>
+                          <m:dPr>
+                            <m:ctrlPr>
+                              <a:rPr lang="fr-CA" b="0" i="1" smtClean="0">
+                                <a:latin typeface="Cambria Math" panose="02040503050406030204" pitchFamily="18" charset="0"/>
+                              </a:rPr>
+                            </m:ctrlPr>
+                          </m:dPr>
+                          <m:e>
+                            <m:r>
+                              <a:rPr lang="fr-CA" b="0" i="1" smtClean="0">
+                                <a:latin typeface="Cambria Math" panose="02040503050406030204" pitchFamily="18" charset="0"/>
+                              </a:rPr>
+                              <m:t>2 ∗</m:t>
+                            </m:r>
+                            <m:r>
+                              <a:rPr lang="fr-CA" b="0" i="1" smtClean="0">
+                                <a:latin typeface="Cambria Math" panose="02040503050406030204" pitchFamily="18" charset="0"/>
+                              </a:rPr>
+                              <m:t>𝜋</m:t>
+                            </m:r>
+                            <m:r>
+                              <a:rPr lang="fr-CA" b="0" i="1" smtClean="0">
+                                <a:latin typeface="Cambria Math" panose="02040503050406030204" pitchFamily="18" charset="0"/>
+                              </a:rPr>
+                              <m:t>∗</m:t>
+                            </m:r>
+                            <m:f>
+                              <m:fPr>
+                                <m:ctrlPr>
+                                  <a:rPr lang="fr-CA" b="0" i="1" smtClean="0">
+                                    <a:latin typeface="Cambria Math" panose="02040503050406030204" pitchFamily="18" charset="0"/>
+                                  </a:rPr>
+                                </m:ctrlPr>
+                              </m:fPr>
+                              <m:num>
+                                <m:r>
+                                  <a:rPr lang="fr-CA" b="0" i="1" smtClean="0">
+                                    <a:latin typeface="Cambria Math" panose="02040503050406030204" pitchFamily="18" charset="0"/>
+                                  </a:rPr>
+                                  <m:t>𝑟</m:t>
+                                </m:r>
+                              </m:num>
+                              <m:den>
+                                <m:r>
+                                  <a:rPr lang="fr-CA" b="0" i="1" smtClean="0">
+                                    <a:latin typeface="Cambria Math" panose="02040503050406030204" pitchFamily="18" charset="0"/>
+                                  </a:rPr>
+                                  <m:t>𝑅</m:t>
+                                </m:r>
+                              </m:den>
+                            </m:f>
+                          </m:e>
+                        </m:d>
+                      </m:e>
+                    </m:func>
+                    <m:r>
+                      <a:rPr lang="fr-CA" b="0" i="1" smtClean="0">
+                        <a:latin typeface="Cambria Math" panose="02040503050406030204" pitchFamily="18" charset="0"/>
+                      </a:rPr>
+                      <m:t>∗</m:t>
+                    </m:r>
+                    <m:r>
+                      <m:rPr>
+                        <m:sty m:val="p"/>
+                      </m:rPr>
+                      <a:rPr lang="fr-CA" b="0" i="0" smtClean="0">
+                        <a:latin typeface="Cambria Math" panose="02040503050406030204" pitchFamily="18" charset="0"/>
+                      </a:rPr>
+                      <m:t>cos</m:t>
+                    </m:r>
+                    <m:r>
+                      <a:rPr lang="fr-CA" b="0" i="1" smtClean="0">
+                        <a:latin typeface="Cambria Math" panose="02040503050406030204" pitchFamily="18" charset="0"/>
+                      </a:rPr>
+                      <m:t>⁡(2 ∗</m:t>
+                    </m:r>
+                    <m:r>
+                      <a:rPr lang="fr-CA" b="0" i="1" smtClean="0">
+                        <a:latin typeface="Cambria Math" panose="02040503050406030204" pitchFamily="18" charset="0"/>
+                      </a:rPr>
+                      <m:t>𝜋</m:t>
+                    </m:r>
+                    <m:r>
+                      <a:rPr lang="fr-CA" b="0" i="1" smtClean="0">
+                        <a:latin typeface="Cambria Math" panose="02040503050406030204" pitchFamily="18" charset="0"/>
+                      </a:rPr>
+                      <m:t>∗</m:t>
+                    </m:r>
+                    <m:f>
+                      <m:fPr>
+                        <m:ctrlPr>
+                          <a:rPr lang="fr-CA" b="0" i="1" smtClean="0">
+                            <a:latin typeface="Cambria Math" panose="02040503050406030204" pitchFamily="18" charset="0"/>
+                          </a:rPr>
+                        </m:ctrlPr>
+                      </m:fPr>
+                      <m:num>
+                        <m:r>
+                          <a:rPr lang="fr-CA" b="0" i="1" smtClean="0">
+                            <a:latin typeface="Cambria Math" panose="02040503050406030204" pitchFamily="18" charset="0"/>
+                          </a:rPr>
+                          <m:t>𝑡</m:t>
+                        </m:r>
+                      </m:num>
+                      <m:den>
+                        <m:r>
+                          <a:rPr lang="fr-CA" b="0" i="1" smtClean="0">
+                            <a:latin typeface="Cambria Math" panose="02040503050406030204" pitchFamily="18" charset="0"/>
+                          </a:rPr>
+                          <m:t>𝑡𝑒𝑚𝑝</m:t>
+                        </m:r>
+                        <m:sSub>
+                          <m:sSubPr>
+                            <m:ctrlPr>
+                              <a:rPr lang="fr-CA" b="0" i="1" smtClean="0">
+                                <a:latin typeface="Cambria Math" panose="02040503050406030204" pitchFamily="18" charset="0"/>
+                              </a:rPr>
+                            </m:ctrlPr>
+                          </m:sSubPr>
+                          <m:e>
+                            <m:r>
+                              <a:rPr lang="fr-CA" b="0" i="1" smtClean="0">
+                                <a:latin typeface="Cambria Math" panose="02040503050406030204" pitchFamily="18" charset="0"/>
+                              </a:rPr>
+                              <m:t>𝑠</m:t>
+                            </m:r>
+                          </m:e>
+                          <m:sub>
+                            <m:r>
+                              <a:rPr lang="fr-CA" b="0" i="1" smtClean="0">
+                                <a:latin typeface="Cambria Math" panose="02040503050406030204" pitchFamily="18" charset="0"/>
+                              </a:rPr>
+                              <m:t>𝑓𝑖𝑛𝑎𝑙</m:t>
+                            </m:r>
+                          </m:sub>
+                        </m:sSub>
+                      </m:den>
+                    </m:f>
+                    <m:r>
+                      <a:rPr lang="fr-CA" b="0" i="1" smtClean="0">
+                        <a:latin typeface="Cambria Math" panose="02040503050406030204" pitchFamily="18" charset="0"/>
+                      </a:rPr>
+                      <m:t>)</m:t>
+                    </m:r>
+                  </m:oMath>
+                </a14:m>
+                <a:endParaRPr lang="fr-CA" dirty="0"/>
+              </a:p>
+            </p:txBody>
+          </p:sp>
+        </mc:Choice>
+        <mc:Fallback xmlns="">
+          <p:sp>
+            <p:nvSpPr>
+              <p:cNvPr id="5" name="Espace réservé du contenu 4">
+                <a:extLst>
+                  <a:ext uri="{FF2B5EF4-FFF2-40B4-BE49-F238E27FC236}">
+                    <a16:creationId xmlns:a16="http://schemas.microsoft.com/office/drawing/2014/main" id="{E4A42691-9CFE-45C6-A49C-301D0207827F}"/>
+                  </a:ext>
+                </a:extLst>
+              </p:cNvPr>
+              <p:cNvSpPr>
+                <a:spLocks noGrp="1" noRot="1" noChangeAspect="1" noMove="1" noResize="1" noEditPoints="1" noAdjustHandles="1" noChangeArrowheads="1" noChangeShapeType="1" noTextEdit="1"/>
+              </p:cNvSpPr>
+              <p:nvPr>
+                <p:ph idx="1"/>
+              </p:nvPr>
+            </p:nvSpPr>
+            <p:spPr>
+              <a:blipFill>
+                <a:blip r:embed="rId3"/>
+                <a:stretch>
+                  <a:fillRect l="-1217"/>
+                </a:stretch>
+              </a:blipFill>
+            </p:spPr>
+            <p:txBody>
+              <a:bodyPr/>
+              <a:lstStyle/>
+              <a:p>
+                <a:r>
+                  <a:rPr lang="fr-CA">
+                    <a:noFill/>
+                  </a:rPr>
+                  <a:t> </a:t>
+                </a:r>
+              </a:p>
+            </p:txBody>
+          </p:sp>
+        </mc:Fallback>
+      </mc:AlternateContent>
+      <p:pic>
+        <p:nvPicPr>
+          <p:cNvPr id="7" name="Image 6">
+            <a:extLst>
+              <a:ext uri="{FF2B5EF4-FFF2-40B4-BE49-F238E27FC236}">
+                <a16:creationId xmlns:a16="http://schemas.microsoft.com/office/drawing/2014/main" id="{F8DB5998-468A-EB74-1774-818AD3325F5B}"/>
+              </a:ext>
+            </a:extLst>
+          </p:cNvPr>
+          <p:cNvPicPr>
+            <a:picLocks noChangeAspect="1"/>
+          </p:cNvPicPr>
+          <p:nvPr/>
+        </p:nvPicPr>
+        <p:blipFill>
+          <a:blip r:embed="rId4">
+            <a:extLst>
+              <a:ext uri="{28A0092B-C50C-407E-A947-70E740481C1C}">
+                <a14:useLocalDpi xmlns:a14="http://schemas.microsoft.com/office/drawing/2010/main" val="0"/>
+              </a:ext>
+            </a:extLst>
+          </a:blip>
+          <a:srcRect t="7602"/>
+          <a:stretch>
+            <a:fillRect/>
+          </a:stretch>
+        </p:blipFill>
+        <p:spPr>
+          <a:xfrm>
+            <a:off x="1502875" y="2688879"/>
+            <a:ext cx="8247707" cy="3869909"/>
+          </a:xfrm>
+          <a:prstGeom prst="rect">
+            <a:avLst/>
+          </a:prstGeom>
+        </p:spPr>
+      </p:pic>
+    </p:spTree>
+    <p:extLst>
+      <p:ext uri="{BB962C8B-B14F-4D97-AF65-F5344CB8AC3E}">
+        <p14:creationId xmlns:p14="http://schemas.microsoft.com/office/powerpoint/2010/main" val="2035793993"/>
+      </p:ext>
+    </p:extLst>
+  </p:cSld>
+  <p:clrMapOvr>
+    <a:masterClrMapping/>
+  </p:clrMapOvr>
+</p:sld>
+</file>
+
+<file path=ppt/slides/slide7.xml><?xml version="1.0" encoding="utf-8"?>
+<p:sld xmlns:a="http://schemas.openxmlformats.org/drawingml/2006/main" xmlns:r="http://schemas.openxmlformats.org/officeDocument/2006/relationships" xmlns:p="http://schemas.openxmlformats.org/presentationml/2006/main">
+  <p:cSld>
+    <p:spTree>
+      <p:nvGrpSpPr>
+        <p:cNvPr id="1" name="">
+          <a:extLst>
+            <a:ext uri="{FF2B5EF4-FFF2-40B4-BE49-F238E27FC236}">
+              <a16:creationId xmlns:a16="http://schemas.microsoft.com/office/drawing/2014/main" id="{AB1CA7BF-CEB7-BAE5-A73C-68062335176C}"/>
+            </a:ext>
+          </a:extLst>
+        </p:cNvPr>
+        <p:cNvGrpSpPr/>
+        <p:nvPr/>
+      </p:nvGrpSpPr>
+      <p:grpSpPr>
+        <a:xfrm>
+          <a:off x="0" y="0"/>
+          <a:ext cx="0" cy="0"/>
+          <a:chOff x="0" y="0"/>
+          <a:chExt cx="0" cy="0"/>
+        </a:xfrm>
+      </p:grpSpPr>
+      <p:sp>
+        <p:nvSpPr>
+          <p:cNvPr id="2" name="Titre 1">
+            <a:extLst>
+              <a:ext uri="{FF2B5EF4-FFF2-40B4-BE49-F238E27FC236}">
+                <a16:creationId xmlns:a16="http://schemas.microsoft.com/office/drawing/2014/main" id="{77281168-C061-00D6-4A15-7844EEA74F8C}"/>
+              </a:ext>
+            </a:extLst>
+          </p:cNvPr>
+          <p:cNvSpPr>
+            <a:spLocks noGrp="1"/>
+          </p:cNvSpPr>
+          <p:nvPr>
+            <p:ph type="title"/>
+          </p:nvPr>
+        </p:nvSpPr>
+        <p:spPr>
+          <a:xfrm>
+            <a:off x="838200" y="118237"/>
+            <a:ext cx="10515600" cy="1325563"/>
+          </a:xfrm>
+        </p:spPr>
+        <p:txBody>
+          <a:bodyPr/>
+          <a:lstStyle/>
+          <a:p>
+            <a:r>
+              <a:rPr lang="fr-FR" dirty="0"/>
+              <a:t>C) Terme source : Développements</a:t>
+            </a:r>
+          </a:p>
+        </p:txBody>
+      </p:sp>
+      <mc:AlternateContent xmlns:mc="http://schemas.openxmlformats.org/markup-compatibility/2006" xmlns:a14="http://schemas.microsoft.com/office/drawing/2010/main">
+        <mc:Choice Requires="a14">
+          <p:sp>
+            <p:nvSpPr>
+              <p:cNvPr id="5" name="Espace réservé du contenu 4">
+                <a:extLst>
+                  <a:ext uri="{FF2B5EF4-FFF2-40B4-BE49-F238E27FC236}">
+                    <a16:creationId xmlns:a16="http://schemas.microsoft.com/office/drawing/2014/main" id="{02C72247-3DAB-DC54-91E4-C3BF5F0C7A40}"/>
+                  </a:ext>
+                </a:extLst>
+              </p:cNvPr>
+              <p:cNvSpPr>
+                <a:spLocks noGrp="1"/>
+              </p:cNvSpPr>
+              <p:nvPr>
+                <p:ph idx="1"/>
+              </p:nvPr>
+            </p:nvSpPr>
+            <p:spPr>
+              <a:xfrm>
+                <a:off x="774824" y="1113576"/>
+                <a:ext cx="10949414" cy="3576119"/>
+              </a:xfrm>
+              <a:ln w="28575">
+                <a:solidFill>
+                  <a:schemeClr val="accent5"/>
+                </a:solidFill>
+              </a:ln>
+            </p:spPr>
+            <p:txBody>
+              <a:bodyPr>
+                <a:normAutofit fontScale="92500" lnSpcReduction="10000"/>
+              </a:bodyPr>
+              <a:lstStyle/>
+              <a:p>
+                <a:pPr marL="0" indent="0" algn="ctr">
+                  <a:buNone/>
+                </a:pPr>
+                <a14:m>
+                  <m:oMath xmlns:m="http://schemas.openxmlformats.org/officeDocument/2006/math">
+                    <m:r>
+                      <a:rPr lang="fr-CA" b="0" i="1" smtClean="0">
+                        <a:latin typeface="Cambria Math" panose="02040503050406030204" pitchFamily="18" charset="0"/>
+                      </a:rPr>
+                      <m:t>𝐿</m:t>
+                    </m:r>
+                    <m:d>
+                      <m:dPr>
+                        <m:ctrlPr>
+                          <a:rPr lang="fr-CA" b="0" i="1" smtClean="0">
+                            <a:latin typeface="Cambria Math" panose="02040503050406030204" pitchFamily="18" charset="0"/>
+                          </a:rPr>
+                        </m:ctrlPr>
+                      </m:dPr>
+                      <m:e>
+                        <m:r>
+                          <a:rPr lang="fr-CA" b="0" i="1" smtClean="0">
+                            <a:latin typeface="Cambria Math" panose="02040503050406030204" pitchFamily="18" charset="0"/>
+                          </a:rPr>
+                          <m:t>Ĉ</m:t>
+                        </m:r>
+                      </m:e>
+                    </m:d>
+                    <m:r>
+                      <a:rPr lang="fr-CA" b="0" i="1" smtClean="0">
+                        <a:latin typeface="Cambria Math" panose="02040503050406030204" pitchFamily="18" charset="0"/>
+                      </a:rPr>
+                      <m:t>=0= </m:t>
+                    </m:r>
+                    <m:f>
+                      <m:fPr>
+                        <m:ctrlPr>
+                          <a:rPr lang="fr-CA" b="0" i="1" smtClean="0">
+                            <a:latin typeface="Cambria Math" panose="02040503050406030204" pitchFamily="18" charset="0"/>
+                          </a:rPr>
+                        </m:ctrlPr>
+                      </m:fPr>
+                      <m:num>
+                        <m:r>
+                          <a:rPr lang="fr-CA" i="1">
+                            <a:latin typeface="Cambria Math" panose="02040503050406030204" pitchFamily="18" charset="0"/>
+                          </a:rPr>
+                          <m:t>𝜕</m:t>
+                        </m:r>
+                        <m:r>
+                          <a:rPr lang="fr-CA" i="1">
+                            <a:latin typeface="Cambria Math" panose="02040503050406030204" pitchFamily="18" charset="0"/>
+                          </a:rPr>
+                          <m:t>Ĉ</m:t>
+                        </m:r>
+                      </m:num>
+                      <m:den>
+                        <m:r>
+                          <a:rPr lang="fr-CA" b="0" i="1" smtClean="0">
+                            <a:latin typeface="Cambria Math" panose="02040503050406030204" pitchFamily="18" charset="0"/>
+                          </a:rPr>
+                          <m:t>𝜕</m:t>
+                        </m:r>
+                        <m:r>
+                          <a:rPr lang="fr-CA" b="0" i="1" smtClean="0">
+                            <a:latin typeface="Cambria Math" panose="02040503050406030204" pitchFamily="18" charset="0"/>
+                          </a:rPr>
+                          <m:t>𝑡</m:t>
+                        </m:r>
+                      </m:den>
+                    </m:f>
+                    <m:r>
+                      <a:rPr lang="fr-CA" b="0" i="1" smtClean="0">
+                        <a:latin typeface="Cambria Math" panose="02040503050406030204" pitchFamily="18" charset="0"/>
+                      </a:rPr>
+                      <m:t> −</m:t>
+                    </m:r>
+                    <m:sSub>
+                      <m:sSubPr>
+                        <m:ctrlPr>
+                          <a:rPr lang="fr-CA" b="0" i="1" smtClean="0">
+                            <a:latin typeface="Cambria Math" panose="02040503050406030204" pitchFamily="18" charset="0"/>
+                          </a:rPr>
+                        </m:ctrlPr>
+                      </m:sSubPr>
+                      <m:e>
+                        <m:r>
+                          <a:rPr lang="fr-CA" b="0" i="1" smtClean="0">
+                            <a:latin typeface="Cambria Math" panose="02040503050406030204" pitchFamily="18" charset="0"/>
+                          </a:rPr>
+                          <m:t>𝐷</m:t>
+                        </m:r>
+                      </m:e>
+                      <m:sub>
+                        <m:r>
+                          <a:rPr lang="fr-CA" b="0" i="1" smtClean="0">
+                            <a:latin typeface="Cambria Math" panose="02040503050406030204" pitchFamily="18" charset="0"/>
+                          </a:rPr>
+                          <m:t>𝑒𝑓𝑓</m:t>
+                        </m:r>
+                      </m:sub>
+                    </m:sSub>
+                    <m:d>
+                      <m:dPr>
+                        <m:ctrlPr>
+                          <a:rPr lang="fr-CA" b="0" i="1" smtClean="0">
+                            <a:latin typeface="Cambria Math" panose="02040503050406030204" pitchFamily="18" charset="0"/>
+                          </a:rPr>
+                        </m:ctrlPr>
+                      </m:dPr>
+                      <m:e>
+                        <m:f>
+                          <m:fPr>
+                            <m:ctrlPr>
+                              <a:rPr lang="fr-CA" i="1">
+                                <a:latin typeface="Cambria Math" panose="02040503050406030204" pitchFamily="18" charset="0"/>
+                              </a:rPr>
+                            </m:ctrlPr>
+                          </m:fPr>
+                          <m:num>
+                            <m:r>
+                              <a:rPr lang="fr-CA" i="1">
+                                <a:latin typeface="Cambria Math" panose="02040503050406030204" pitchFamily="18" charset="0"/>
+                              </a:rPr>
+                              <m:t>1</m:t>
+                            </m:r>
+                          </m:num>
+                          <m:den>
+                            <m:r>
+                              <a:rPr lang="fr-CA" i="1">
+                                <a:latin typeface="Cambria Math" panose="02040503050406030204" pitchFamily="18" charset="0"/>
+                              </a:rPr>
+                              <m:t>𝑟</m:t>
+                            </m:r>
+                          </m:den>
+                        </m:f>
+                        <m:r>
+                          <a:rPr lang="fr-CA" b="0" i="1" smtClean="0">
+                            <a:latin typeface="Cambria Math" panose="02040503050406030204" pitchFamily="18" charset="0"/>
+                          </a:rPr>
+                          <m:t> </m:t>
+                        </m:r>
+                        <m:f>
+                          <m:fPr>
+                            <m:ctrlPr>
+                              <a:rPr lang="fr-CA" b="0" i="1" smtClean="0">
+                                <a:latin typeface="Cambria Math" panose="02040503050406030204" pitchFamily="18" charset="0"/>
+                              </a:rPr>
+                            </m:ctrlPr>
+                          </m:fPr>
+                          <m:num>
+                            <m:r>
+                              <a:rPr lang="fr-CA" b="0" i="1" smtClean="0">
+                                <a:latin typeface="Cambria Math" panose="02040503050406030204" pitchFamily="18" charset="0"/>
+                              </a:rPr>
+                              <m:t>𝜕</m:t>
+                            </m:r>
+                            <m:r>
+                              <a:rPr lang="fr-CA" i="1">
+                                <a:latin typeface="Cambria Math" panose="02040503050406030204" pitchFamily="18" charset="0"/>
+                              </a:rPr>
+                              <m:t>Ĉ</m:t>
+                            </m:r>
+                          </m:num>
+                          <m:den>
+                            <m:r>
+                              <a:rPr lang="fr-CA" b="0" i="1" smtClean="0">
+                                <a:latin typeface="Cambria Math" panose="02040503050406030204" pitchFamily="18" charset="0"/>
+                              </a:rPr>
+                              <m:t>𝜕</m:t>
+                            </m:r>
+                            <m:r>
+                              <a:rPr lang="fr-CA" b="0" i="1" smtClean="0">
+                                <a:latin typeface="Cambria Math" panose="02040503050406030204" pitchFamily="18" charset="0"/>
+                              </a:rPr>
+                              <m:t>𝑟</m:t>
+                            </m:r>
+                          </m:den>
+                        </m:f>
+                        <m:r>
+                          <a:rPr lang="fr-CA" b="0" i="1" smtClean="0">
+                            <a:latin typeface="Cambria Math" panose="02040503050406030204" pitchFamily="18" charset="0"/>
+                          </a:rPr>
+                          <m:t>+ </m:t>
+                        </m:r>
+                        <m:f>
+                          <m:fPr>
+                            <m:ctrlPr>
+                              <a:rPr lang="fr-CA" b="0" i="1" smtClean="0">
+                                <a:latin typeface="Cambria Math" panose="02040503050406030204" pitchFamily="18" charset="0"/>
+                              </a:rPr>
+                            </m:ctrlPr>
+                          </m:fPr>
+                          <m:num>
+                            <m:sSup>
+                              <m:sSupPr>
+                                <m:ctrlPr>
+                                  <a:rPr lang="fr-CA" b="0" i="1" smtClean="0">
+                                    <a:latin typeface="Cambria Math" panose="02040503050406030204" pitchFamily="18" charset="0"/>
+                                  </a:rPr>
+                                </m:ctrlPr>
+                              </m:sSupPr>
+                              <m:e>
+                                <m:r>
+                                  <a:rPr lang="fr-CA" b="0" i="1" smtClean="0">
+                                    <a:latin typeface="Cambria Math" panose="02040503050406030204" pitchFamily="18" charset="0"/>
+                                  </a:rPr>
+                                  <m:t>𝜕</m:t>
+                                </m:r>
+                              </m:e>
+                              <m:sup>
+                                <m:r>
+                                  <a:rPr lang="fr-CA" b="0" i="1" smtClean="0">
+                                    <a:latin typeface="Cambria Math" panose="02040503050406030204" pitchFamily="18" charset="0"/>
+                                  </a:rPr>
+                                  <m:t>2</m:t>
+                                </m:r>
+                              </m:sup>
+                            </m:sSup>
+                            <m:r>
+                              <a:rPr lang="fr-CA" b="0" i="1" smtClean="0">
+                                <a:latin typeface="Cambria Math" panose="02040503050406030204" pitchFamily="18" charset="0"/>
+                              </a:rPr>
+                              <m:t>Ĉ</m:t>
+                            </m:r>
+                          </m:num>
+                          <m:den>
+                            <m:r>
+                              <a:rPr lang="fr-CA" b="0" i="1" smtClean="0">
+                                <a:latin typeface="Cambria Math" panose="02040503050406030204" pitchFamily="18" charset="0"/>
+                              </a:rPr>
+                              <m:t>𝜕</m:t>
+                            </m:r>
+                            <m:sSup>
+                              <m:sSupPr>
+                                <m:ctrlPr>
+                                  <a:rPr lang="fr-CA" b="0" i="1" smtClean="0">
+                                    <a:latin typeface="Cambria Math" panose="02040503050406030204" pitchFamily="18" charset="0"/>
+                                  </a:rPr>
+                                </m:ctrlPr>
+                              </m:sSupPr>
+                              <m:e>
+                                <m:r>
+                                  <a:rPr lang="fr-CA" b="0" i="1" smtClean="0">
+                                    <a:latin typeface="Cambria Math" panose="02040503050406030204" pitchFamily="18" charset="0"/>
+                                  </a:rPr>
+                                  <m:t>𝑟</m:t>
+                                </m:r>
+                              </m:e>
+                              <m:sup>
+                                <m:r>
+                                  <a:rPr lang="fr-CA" b="0" i="1" smtClean="0">
+                                    <a:latin typeface="Cambria Math" panose="02040503050406030204" pitchFamily="18" charset="0"/>
+                                  </a:rPr>
+                                  <m:t>2</m:t>
+                                </m:r>
+                              </m:sup>
+                            </m:sSup>
+                          </m:den>
+                        </m:f>
+                      </m:e>
+                    </m:d>
+                    <m:r>
+                      <a:rPr lang="fr-CA" b="0" i="1" smtClean="0">
+                        <a:latin typeface="Cambria Math" panose="02040503050406030204" pitchFamily="18" charset="0"/>
+                      </a:rPr>
+                      <m:t>+</m:t>
+                    </m:r>
+                    <m:r>
+                      <a:rPr lang="fr-CA" b="0" i="1" smtClean="0">
+                        <a:latin typeface="Cambria Math" panose="02040503050406030204" pitchFamily="18" charset="0"/>
+                      </a:rPr>
+                      <m:t>𝑘</m:t>
+                    </m:r>
+                    <m:r>
+                      <a:rPr lang="fr-CA" b="0" i="1" smtClean="0">
+                        <a:latin typeface="Cambria Math" panose="02040503050406030204" pitchFamily="18" charset="0"/>
+                      </a:rPr>
+                      <m:t>Ĉ</m:t>
+                    </m:r>
+                  </m:oMath>
+                </a14:m>
+                <a:r>
+                  <a:rPr lang="fr-CA" b="0" dirty="0"/>
+                  <a:t>,</a:t>
+                </a:r>
+              </a:p>
+              <a:p>
+                <a:pPr marL="0" indent="0" algn="ctr">
+                  <a:buNone/>
+                </a:pPr>
+                <a:r>
+                  <a:rPr lang="fr-CA" dirty="0"/>
+                  <a:t>où </a:t>
+                </a:r>
+                <a14:m>
+                  <m:oMath xmlns:m="http://schemas.openxmlformats.org/officeDocument/2006/math">
+                    <m:r>
+                      <a:rPr lang="fr-CA" b="0" i="1" smtClean="0">
+                        <a:latin typeface="Cambria Math" panose="02040503050406030204" pitchFamily="18" charset="0"/>
+                      </a:rPr>
+                      <m:t>Ĉ= </m:t>
+                    </m:r>
+                    <m:sSub>
+                      <m:sSubPr>
+                        <m:ctrlPr>
+                          <a:rPr lang="fr-CA" i="1">
+                            <a:latin typeface="Cambria Math" panose="02040503050406030204" pitchFamily="18" charset="0"/>
+                          </a:rPr>
+                        </m:ctrlPr>
+                      </m:sSubPr>
+                      <m:e>
+                        <m:r>
+                          <a:rPr lang="fr-CA" i="1">
+                            <a:latin typeface="Cambria Math" panose="02040503050406030204" pitchFamily="18" charset="0"/>
+                          </a:rPr>
+                          <m:t>𝐶</m:t>
+                        </m:r>
+                      </m:e>
+                      <m:sub>
+                        <m:r>
+                          <a:rPr lang="fr-CA" i="1">
+                            <a:latin typeface="Cambria Math" panose="02040503050406030204" pitchFamily="18" charset="0"/>
+                          </a:rPr>
+                          <m:t>𝑚𝑚𝑠</m:t>
+                        </m:r>
+                      </m:sub>
+                    </m:sSub>
+                    <m:r>
+                      <a:rPr lang="fr-CA" i="1">
+                        <a:latin typeface="Cambria Math" panose="02040503050406030204" pitchFamily="18" charset="0"/>
+                      </a:rPr>
+                      <m:t>=1+</m:t>
+                    </m:r>
+                    <m:func>
+                      <m:funcPr>
+                        <m:ctrlPr>
+                          <a:rPr lang="fr-CA" i="1">
+                            <a:latin typeface="Cambria Math" panose="02040503050406030204" pitchFamily="18" charset="0"/>
+                          </a:rPr>
+                        </m:ctrlPr>
+                      </m:funcPr>
+                      <m:fName>
+                        <m:r>
+                          <m:rPr>
+                            <m:sty m:val="p"/>
+                          </m:rPr>
+                          <a:rPr lang="fr-CA">
+                            <a:latin typeface="Cambria Math" panose="02040503050406030204" pitchFamily="18" charset="0"/>
+                          </a:rPr>
+                          <m:t>cos</m:t>
+                        </m:r>
+                      </m:fName>
+                      <m:e>
+                        <m:d>
+                          <m:dPr>
+                            <m:ctrlPr>
+                              <a:rPr lang="fr-CA" i="1">
+                                <a:latin typeface="Cambria Math" panose="02040503050406030204" pitchFamily="18" charset="0"/>
+                              </a:rPr>
+                            </m:ctrlPr>
+                          </m:dPr>
+                          <m:e>
+                            <m:r>
+                              <a:rPr lang="fr-CA" i="1">
+                                <a:latin typeface="Cambria Math" panose="02040503050406030204" pitchFamily="18" charset="0"/>
+                              </a:rPr>
+                              <m:t>2 ∗</m:t>
+                            </m:r>
+                            <m:r>
+                              <a:rPr lang="fr-CA" i="1">
+                                <a:latin typeface="Cambria Math" panose="02040503050406030204" pitchFamily="18" charset="0"/>
+                              </a:rPr>
+                              <m:t>𝜋</m:t>
+                            </m:r>
+                            <m:r>
+                              <a:rPr lang="fr-CA" i="1">
+                                <a:latin typeface="Cambria Math" panose="02040503050406030204" pitchFamily="18" charset="0"/>
+                              </a:rPr>
+                              <m:t>∗</m:t>
+                            </m:r>
+                            <m:f>
+                              <m:fPr>
+                                <m:ctrlPr>
+                                  <a:rPr lang="fr-CA" i="1">
+                                    <a:latin typeface="Cambria Math" panose="02040503050406030204" pitchFamily="18" charset="0"/>
+                                  </a:rPr>
+                                </m:ctrlPr>
+                              </m:fPr>
+                              <m:num>
+                                <m:r>
+                                  <a:rPr lang="fr-CA" i="1">
+                                    <a:latin typeface="Cambria Math" panose="02040503050406030204" pitchFamily="18" charset="0"/>
+                                  </a:rPr>
+                                  <m:t>𝑟</m:t>
+                                </m:r>
+                              </m:num>
+                              <m:den>
+                                <m:r>
+                                  <a:rPr lang="fr-CA" i="1">
+                                    <a:latin typeface="Cambria Math" panose="02040503050406030204" pitchFamily="18" charset="0"/>
+                                  </a:rPr>
+                                  <m:t>𝑅</m:t>
+                                </m:r>
+                              </m:den>
+                            </m:f>
+                          </m:e>
+                        </m:d>
+                      </m:e>
+                    </m:func>
+                    <m:r>
+                      <a:rPr lang="fr-CA" i="1">
+                        <a:latin typeface="Cambria Math" panose="02040503050406030204" pitchFamily="18" charset="0"/>
+                      </a:rPr>
+                      <m:t>∗</m:t>
+                    </m:r>
+                    <m:r>
+                      <m:rPr>
+                        <m:sty m:val="p"/>
+                      </m:rPr>
+                      <a:rPr lang="fr-CA">
+                        <a:latin typeface="Cambria Math" panose="02040503050406030204" pitchFamily="18" charset="0"/>
+                      </a:rPr>
+                      <m:t>cos</m:t>
+                    </m:r>
+                    <m:r>
+                      <a:rPr lang="fr-CA" i="1">
+                        <a:latin typeface="Cambria Math" panose="02040503050406030204" pitchFamily="18" charset="0"/>
+                      </a:rPr>
+                      <m:t>⁡(2 ∗</m:t>
+                    </m:r>
+                    <m:r>
+                      <a:rPr lang="fr-CA" i="1">
+                        <a:latin typeface="Cambria Math" panose="02040503050406030204" pitchFamily="18" charset="0"/>
+                      </a:rPr>
+                      <m:t>𝜋</m:t>
+                    </m:r>
+                    <m:r>
+                      <a:rPr lang="fr-CA" i="1">
+                        <a:latin typeface="Cambria Math" panose="02040503050406030204" pitchFamily="18" charset="0"/>
+                      </a:rPr>
+                      <m:t>∗</m:t>
+                    </m:r>
+                    <m:f>
+                      <m:fPr>
+                        <m:ctrlPr>
+                          <a:rPr lang="fr-CA" i="1">
+                            <a:latin typeface="Cambria Math" panose="02040503050406030204" pitchFamily="18" charset="0"/>
+                          </a:rPr>
+                        </m:ctrlPr>
+                      </m:fPr>
+                      <m:num>
+                        <m:r>
+                          <a:rPr lang="fr-CA" i="1">
+                            <a:latin typeface="Cambria Math" panose="02040503050406030204" pitchFamily="18" charset="0"/>
+                          </a:rPr>
+                          <m:t>𝑡</m:t>
+                        </m:r>
+                      </m:num>
+                      <m:den>
+                        <m:r>
+                          <a:rPr lang="fr-CA" i="1">
+                            <a:latin typeface="Cambria Math" panose="02040503050406030204" pitchFamily="18" charset="0"/>
+                          </a:rPr>
+                          <m:t>𝑡𝑒𝑚𝑝</m:t>
+                        </m:r>
+                        <m:sSub>
+                          <m:sSubPr>
+                            <m:ctrlPr>
+                              <a:rPr lang="fr-CA" i="1">
+                                <a:latin typeface="Cambria Math" panose="02040503050406030204" pitchFamily="18" charset="0"/>
+                              </a:rPr>
+                            </m:ctrlPr>
+                          </m:sSubPr>
+                          <m:e>
+                            <m:r>
+                              <a:rPr lang="fr-CA" i="1">
+                                <a:latin typeface="Cambria Math" panose="02040503050406030204" pitchFamily="18" charset="0"/>
+                              </a:rPr>
+                              <m:t>𝑠</m:t>
+                            </m:r>
+                          </m:e>
+                          <m:sub>
+                            <m:r>
+                              <a:rPr lang="fr-CA" i="1">
+                                <a:latin typeface="Cambria Math" panose="02040503050406030204" pitchFamily="18" charset="0"/>
+                              </a:rPr>
+                              <m:t>𝑓𝑖𝑛𝑎𝑙</m:t>
+                            </m:r>
+                          </m:sub>
+                        </m:sSub>
+                      </m:den>
+                    </m:f>
+                    <m:r>
+                      <a:rPr lang="fr-CA" i="1">
+                        <a:latin typeface="Cambria Math" panose="02040503050406030204" pitchFamily="18" charset="0"/>
+                      </a:rPr>
+                      <m:t>)</m:t>
+                    </m:r>
+                  </m:oMath>
+                </a14:m>
+                <a:r>
+                  <a:rPr lang="fr-CA" dirty="0"/>
+                  <a:t>,</a:t>
+                </a:r>
+              </a:p>
+              <a:p>
+                <a:pPr marL="0" indent="0" algn="ctr">
+                  <a:buNone/>
+                </a:pPr>
+                <a14:m>
+                  <m:oMath xmlns:m="http://schemas.openxmlformats.org/officeDocument/2006/math">
+                    <m:f>
+                      <m:fPr>
+                        <m:ctrlPr>
+                          <a:rPr lang="fr-CA" i="1">
+                            <a:latin typeface="Cambria Math" panose="02040503050406030204" pitchFamily="18" charset="0"/>
+                          </a:rPr>
+                        </m:ctrlPr>
+                      </m:fPr>
+                      <m:num>
+                        <m:r>
+                          <a:rPr lang="fr-CA" i="1">
+                            <a:latin typeface="Cambria Math" panose="02040503050406030204" pitchFamily="18" charset="0"/>
+                          </a:rPr>
+                          <m:t>𝜕</m:t>
+                        </m:r>
+                        <m:r>
+                          <a:rPr lang="fr-CA" i="1">
+                            <a:latin typeface="Cambria Math" panose="02040503050406030204" pitchFamily="18" charset="0"/>
+                          </a:rPr>
+                          <m:t>Ĉ</m:t>
+                        </m:r>
+                      </m:num>
+                      <m:den>
+                        <m:r>
+                          <a:rPr lang="fr-CA" i="1">
+                            <a:latin typeface="Cambria Math" panose="02040503050406030204" pitchFamily="18" charset="0"/>
+                          </a:rPr>
+                          <m:t>𝜕</m:t>
+                        </m:r>
+                        <m:r>
+                          <a:rPr lang="fr-CA" i="1">
+                            <a:latin typeface="Cambria Math" panose="02040503050406030204" pitchFamily="18" charset="0"/>
+                          </a:rPr>
+                          <m:t>𝑟</m:t>
+                        </m:r>
+                      </m:den>
+                    </m:f>
+                    <m:r>
+                      <a:rPr lang="fr-CA" i="1">
+                        <a:latin typeface="Cambria Math" panose="02040503050406030204" pitchFamily="18" charset="0"/>
+                      </a:rPr>
+                      <m:t>= </m:t>
+                    </m:r>
+                    <m:f>
+                      <m:fPr>
+                        <m:ctrlPr>
+                          <a:rPr lang="fr-CA" i="1">
+                            <a:latin typeface="Cambria Math" panose="02040503050406030204" pitchFamily="18" charset="0"/>
+                          </a:rPr>
+                        </m:ctrlPr>
+                      </m:fPr>
+                      <m:num>
+                        <m:r>
+                          <a:rPr lang="fr-CA" i="1">
+                            <a:latin typeface="Cambria Math" panose="02040503050406030204" pitchFamily="18" charset="0"/>
+                          </a:rPr>
+                          <m:t>−2∗</m:t>
+                        </m:r>
+                        <m:r>
+                          <a:rPr lang="fr-CA" b="0" i="1" smtClean="0">
+                            <a:latin typeface="Cambria Math" panose="02040503050406030204" pitchFamily="18" charset="0"/>
+                          </a:rPr>
+                          <m:t>𝜋</m:t>
+                        </m:r>
+                      </m:num>
+                      <m:den>
+                        <m:r>
+                          <a:rPr lang="fr-CA" b="0" i="1" smtClean="0">
+                            <a:latin typeface="Cambria Math" panose="02040503050406030204" pitchFamily="18" charset="0"/>
+                          </a:rPr>
+                          <m:t>𝑡𝑒𝑚𝑝</m:t>
+                        </m:r>
+                        <m:sSub>
+                          <m:sSubPr>
+                            <m:ctrlPr>
+                              <a:rPr lang="fr-CA" b="0" i="1" smtClean="0">
+                                <a:latin typeface="Cambria Math" panose="02040503050406030204" pitchFamily="18" charset="0"/>
+                              </a:rPr>
+                            </m:ctrlPr>
+                          </m:sSubPr>
+                          <m:e>
+                            <m:r>
+                              <a:rPr lang="fr-CA" b="0" i="1" smtClean="0">
+                                <a:latin typeface="Cambria Math" panose="02040503050406030204" pitchFamily="18" charset="0"/>
+                              </a:rPr>
+                              <m:t>𝑠</m:t>
+                            </m:r>
+                          </m:e>
+                          <m:sub>
+                            <m:r>
+                              <a:rPr lang="fr-CA" b="0" i="1" smtClean="0">
+                                <a:latin typeface="Cambria Math" panose="02040503050406030204" pitchFamily="18" charset="0"/>
+                              </a:rPr>
+                              <m:t>𝑓𝑖𝑛𝑎𝑙</m:t>
+                            </m:r>
+                          </m:sub>
+                        </m:sSub>
+                      </m:den>
+                    </m:f>
+                    <m:r>
+                      <a:rPr lang="fr-CA" b="0" i="1" smtClean="0">
+                        <a:latin typeface="Cambria Math" panose="02040503050406030204" pitchFamily="18" charset="0"/>
+                      </a:rPr>
+                      <m:t>𝑐𝑜𝑠</m:t>
+                    </m:r>
+                    <m:d>
+                      <m:dPr>
+                        <m:ctrlPr>
+                          <a:rPr lang="fr-CA" i="1">
+                            <a:latin typeface="Cambria Math" panose="02040503050406030204" pitchFamily="18" charset="0"/>
+                          </a:rPr>
+                        </m:ctrlPr>
+                      </m:dPr>
+                      <m:e>
+                        <m:r>
+                          <a:rPr lang="fr-CA" i="1">
+                            <a:latin typeface="Cambria Math" panose="02040503050406030204" pitchFamily="18" charset="0"/>
+                          </a:rPr>
+                          <m:t>2 ∗</m:t>
+                        </m:r>
+                        <m:r>
+                          <a:rPr lang="fr-CA" i="1">
+                            <a:latin typeface="Cambria Math" panose="02040503050406030204" pitchFamily="18" charset="0"/>
+                          </a:rPr>
+                          <m:t>𝜋</m:t>
+                        </m:r>
+                        <m:r>
+                          <a:rPr lang="fr-CA" i="1">
+                            <a:latin typeface="Cambria Math" panose="02040503050406030204" pitchFamily="18" charset="0"/>
+                          </a:rPr>
+                          <m:t>∗</m:t>
+                        </m:r>
+                        <m:f>
+                          <m:fPr>
+                            <m:ctrlPr>
+                              <a:rPr lang="fr-CA" i="1">
+                                <a:latin typeface="Cambria Math" panose="02040503050406030204" pitchFamily="18" charset="0"/>
+                              </a:rPr>
+                            </m:ctrlPr>
+                          </m:fPr>
+                          <m:num>
+                            <m:r>
+                              <a:rPr lang="fr-CA" i="1">
+                                <a:latin typeface="Cambria Math" panose="02040503050406030204" pitchFamily="18" charset="0"/>
+                              </a:rPr>
+                              <m:t>𝑟</m:t>
+                            </m:r>
+                          </m:num>
+                          <m:den>
+                            <m:r>
+                              <a:rPr lang="fr-CA" i="1">
+                                <a:latin typeface="Cambria Math" panose="02040503050406030204" pitchFamily="18" charset="0"/>
+                              </a:rPr>
+                              <m:t>𝑅</m:t>
+                            </m:r>
+                          </m:den>
+                        </m:f>
+                      </m:e>
+                    </m:d>
+                    <m:r>
+                      <a:rPr lang="fr-CA" i="1">
+                        <a:latin typeface="Cambria Math" panose="02040503050406030204" pitchFamily="18" charset="0"/>
+                      </a:rPr>
+                      <m:t>∗</m:t>
+                    </m:r>
+                    <m:r>
+                      <m:rPr>
+                        <m:sty m:val="p"/>
+                      </m:rPr>
+                      <a:rPr lang="fr-CA" b="0" i="0" smtClean="0">
+                        <a:latin typeface="Cambria Math" panose="02040503050406030204" pitchFamily="18" charset="0"/>
+                      </a:rPr>
+                      <m:t>sin</m:t>
+                    </m:r>
+                    <m:r>
+                      <a:rPr lang="fr-CA" i="1">
+                        <a:latin typeface="Cambria Math" panose="02040503050406030204" pitchFamily="18" charset="0"/>
+                      </a:rPr>
+                      <m:t>⁡(2 ∗</m:t>
+                    </m:r>
+                    <m:r>
+                      <a:rPr lang="fr-CA" i="1">
+                        <a:latin typeface="Cambria Math" panose="02040503050406030204" pitchFamily="18" charset="0"/>
+                      </a:rPr>
+                      <m:t>𝜋</m:t>
+                    </m:r>
+                    <m:r>
+                      <a:rPr lang="fr-CA" i="1">
+                        <a:latin typeface="Cambria Math" panose="02040503050406030204" pitchFamily="18" charset="0"/>
+                      </a:rPr>
+                      <m:t>∗</m:t>
+                    </m:r>
+                    <m:f>
+                      <m:fPr>
+                        <m:ctrlPr>
+                          <a:rPr lang="fr-CA" i="1">
+                            <a:latin typeface="Cambria Math" panose="02040503050406030204" pitchFamily="18" charset="0"/>
+                          </a:rPr>
+                        </m:ctrlPr>
+                      </m:fPr>
+                      <m:num>
+                        <m:r>
+                          <a:rPr lang="fr-CA" i="1">
+                            <a:latin typeface="Cambria Math" panose="02040503050406030204" pitchFamily="18" charset="0"/>
+                          </a:rPr>
+                          <m:t>𝑡</m:t>
+                        </m:r>
+                      </m:num>
+                      <m:den>
+                        <m:r>
+                          <a:rPr lang="fr-CA" i="1">
+                            <a:latin typeface="Cambria Math" panose="02040503050406030204" pitchFamily="18" charset="0"/>
+                          </a:rPr>
+                          <m:t>𝑡𝑒𝑚𝑝</m:t>
+                        </m:r>
+                        <m:sSub>
+                          <m:sSubPr>
+                            <m:ctrlPr>
+                              <a:rPr lang="fr-CA" i="1">
+                                <a:latin typeface="Cambria Math" panose="02040503050406030204" pitchFamily="18" charset="0"/>
+                              </a:rPr>
+                            </m:ctrlPr>
+                          </m:sSubPr>
+                          <m:e>
+                            <m:r>
+                              <a:rPr lang="fr-CA" i="1">
+                                <a:latin typeface="Cambria Math" panose="02040503050406030204" pitchFamily="18" charset="0"/>
+                              </a:rPr>
+                              <m:t>𝑠</m:t>
+                            </m:r>
+                          </m:e>
+                          <m:sub>
+                            <m:r>
+                              <a:rPr lang="fr-CA" i="1">
+                                <a:latin typeface="Cambria Math" panose="02040503050406030204" pitchFamily="18" charset="0"/>
+                              </a:rPr>
+                              <m:t>𝑓𝑖𝑛𝑎𝑙</m:t>
+                            </m:r>
+                          </m:sub>
+                        </m:sSub>
+                      </m:den>
+                    </m:f>
+                    <m:r>
+                      <a:rPr lang="fr-CA" i="1">
+                        <a:latin typeface="Cambria Math" panose="02040503050406030204" pitchFamily="18" charset="0"/>
+                      </a:rPr>
+                      <m:t>)</m:t>
+                    </m:r>
+                  </m:oMath>
+                </a14:m>
+                <a:r>
+                  <a:rPr lang="fr-CA" dirty="0"/>
+                  <a:t>,</a:t>
+                </a:r>
+              </a:p>
+              <a:p>
+                <a:pPr marL="0" indent="0" algn="ctr">
+                  <a:buNone/>
+                </a:pPr>
+                <a14:m>
+                  <m:oMath xmlns:m="http://schemas.openxmlformats.org/officeDocument/2006/math">
+                    <m:f>
+                      <m:fPr>
+                        <m:ctrlPr>
+                          <a:rPr lang="fr-CA" i="1">
+                            <a:latin typeface="Cambria Math" panose="02040503050406030204" pitchFamily="18" charset="0"/>
+                          </a:rPr>
+                        </m:ctrlPr>
+                      </m:fPr>
+                      <m:num>
+                        <m:r>
+                          <a:rPr lang="fr-CA" i="1">
+                            <a:latin typeface="Cambria Math" panose="02040503050406030204" pitchFamily="18" charset="0"/>
+                          </a:rPr>
+                          <m:t>𝜕</m:t>
+                        </m:r>
+                        <m:r>
+                          <a:rPr lang="fr-CA" i="1">
+                            <a:latin typeface="Cambria Math" panose="02040503050406030204" pitchFamily="18" charset="0"/>
+                          </a:rPr>
+                          <m:t>Ĉ</m:t>
+                        </m:r>
+                      </m:num>
+                      <m:den>
+                        <m:r>
+                          <a:rPr lang="fr-CA" i="1">
+                            <a:latin typeface="Cambria Math" panose="02040503050406030204" pitchFamily="18" charset="0"/>
+                          </a:rPr>
+                          <m:t>𝜕</m:t>
+                        </m:r>
+                        <m:r>
+                          <a:rPr lang="fr-CA" i="1">
+                            <a:latin typeface="Cambria Math" panose="02040503050406030204" pitchFamily="18" charset="0"/>
+                          </a:rPr>
+                          <m:t>𝑟</m:t>
+                        </m:r>
+                      </m:den>
+                    </m:f>
+                    <m:r>
+                      <a:rPr lang="fr-CA" b="0" i="1" smtClean="0">
+                        <a:latin typeface="Cambria Math" panose="02040503050406030204" pitchFamily="18" charset="0"/>
+                      </a:rPr>
+                      <m:t>= </m:t>
+                    </m:r>
+                    <m:f>
+                      <m:fPr>
+                        <m:ctrlPr>
+                          <a:rPr lang="fr-CA" b="0" i="1" smtClean="0">
+                            <a:latin typeface="Cambria Math" panose="02040503050406030204" pitchFamily="18" charset="0"/>
+                          </a:rPr>
+                        </m:ctrlPr>
+                      </m:fPr>
+                      <m:num>
+                        <m:r>
+                          <a:rPr lang="fr-CA" b="0" i="1" smtClean="0">
+                            <a:latin typeface="Cambria Math" panose="02040503050406030204" pitchFamily="18" charset="0"/>
+                          </a:rPr>
+                          <m:t>−2∗</m:t>
+                        </m:r>
+                        <m:r>
+                          <a:rPr lang="fr-CA" b="0" i="1" smtClean="0">
+                            <a:latin typeface="Cambria Math" panose="02040503050406030204" pitchFamily="18" charset="0"/>
+                          </a:rPr>
+                          <m:t>𝜋</m:t>
+                        </m:r>
+                      </m:num>
+                      <m:den>
+                        <m:r>
+                          <a:rPr lang="fr-CA" b="0" i="1" smtClean="0">
+                            <a:latin typeface="Cambria Math" panose="02040503050406030204" pitchFamily="18" charset="0"/>
+                          </a:rPr>
+                          <m:t>𝑅</m:t>
+                        </m:r>
+                      </m:den>
+                    </m:f>
+                    <m:r>
+                      <a:rPr lang="fr-CA" b="0" i="1" smtClean="0">
+                        <a:latin typeface="Cambria Math" panose="02040503050406030204" pitchFamily="18" charset="0"/>
+                      </a:rPr>
+                      <m:t>𝑠𝑖𝑛</m:t>
+                    </m:r>
+                    <m:d>
+                      <m:dPr>
+                        <m:ctrlPr>
+                          <a:rPr lang="fr-CA" i="1">
+                            <a:latin typeface="Cambria Math" panose="02040503050406030204" pitchFamily="18" charset="0"/>
+                          </a:rPr>
+                        </m:ctrlPr>
+                      </m:dPr>
+                      <m:e>
+                        <m:r>
+                          <a:rPr lang="fr-CA" i="1">
+                            <a:latin typeface="Cambria Math" panose="02040503050406030204" pitchFamily="18" charset="0"/>
+                          </a:rPr>
+                          <m:t>2 ∗</m:t>
+                        </m:r>
+                        <m:r>
+                          <a:rPr lang="fr-CA" i="1">
+                            <a:latin typeface="Cambria Math" panose="02040503050406030204" pitchFamily="18" charset="0"/>
+                          </a:rPr>
+                          <m:t>𝜋</m:t>
+                        </m:r>
+                        <m:r>
+                          <a:rPr lang="fr-CA" i="1">
+                            <a:latin typeface="Cambria Math" panose="02040503050406030204" pitchFamily="18" charset="0"/>
+                          </a:rPr>
+                          <m:t>∗</m:t>
+                        </m:r>
+                        <m:f>
+                          <m:fPr>
+                            <m:ctrlPr>
+                              <a:rPr lang="fr-CA" i="1">
+                                <a:latin typeface="Cambria Math" panose="02040503050406030204" pitchFamily="18" charset="0"/>
+                              </a:rPr>
+                            </m:ctrlPr>
+                          </m:fPr>
+                          <m:num>
+                            <m:r>
+                              <a:rPr lang="fr-CA" i="1">
+                                <a:latin typeface="Cambria Math" panose="02040503050406030204" pitchFamily="18" charset="0"/>
+                              </a:rPr>
+                              <m:t>𝑟</m:t>
+                            </m:r>
+                          </m:num>
+                          <m:den>
+                            <m:r>
+                              <a:rPr lang="fr-CA" i="1">
+                                <a:latin typeface="Cambria Math" panose="02040503050406030204" pitchFamily="18" charset="0"/>
+                              </a:rPr>
+                              <m:t>𝑅</m:t>
+                            </m:r>
+                          </m:den>
+                        </m:f>
+                      </m:e>
+                    </m:d>
+                    <m:r>
+                      <a:rPr lang="fr-CA" i="1">
+                        <a:latin typeface="Cambria Math" panose="02040503050406030204" pitchFamily="18" charset="0"/>
+                      </a:rPr>
+                      <m:t>∗</m:t>
+                    </m:r>
+                    <m:r>
+                      <m:rPr>
+                        <m:sty m:val="p"/>
+                      </m:rPr>
+                      <a:rPr lang="fr-CA">
+                        <a:latin typeface="Cambria Math" panose="02040503050406030204" pitchFamily="18" charset="0"/>
+                      </a:rPr>
+                      <m:t>cos</m:t>
+                    </m:r>
+                    <m:r>
+                      <a:rPr lang="fr-CA" i="1">
+                        <a:latin typeface="Cambria Math" panose="02040503050406030204" pitchFamily="18" charset="0"/>
+                      </a:rPr>
+                      <m:t>⁡(2 ∗</m:t>
+                    </m:r>
+                    <m:r>
+                      <a:rPr lang="fr-CA" i="1">
+                        <a:latin typeface="Cambria Math" panose="02040503050406030204" pitchFamily="18" charset="0"/>
+                      </a:rPr>
+                      <m:t>𝜋</m:t>
+                    </m:r>
+                    <m:r>
+                      <a:rPr lang="fr-CA" i="1">
+                        <a:latin typeface="Cambria Math" panose="02040503050406030204" pitchFamily="18" charset="0"/>
+                      </a:rPr>
+                      <m:t>∗</m:t>
+                    </m:r>
+                    <m:f>
+                      <m:fPr>
+                        <m:ctrlPr>
+                          <a:rPr lang="fr-CA" i="1">
+                            <a:latin typeface="Cambria Math" panose="02040503050406030204" pitchFamily="18" charset="0"/>
+                          </a:rPr>
+                        </m:ctrlPr>
+                      </m:fPr>
+                      <m:num>
+                        <m:r>
+                          <a:rPr lang="fr-CA" i="1">
+                            <a:latin typeface="Cambria Math" panose="02040503050406030204" pitchFamily="18" charset="0"/>
+                          </a:rPr>
+                          <m:t>𝑡</m:t>
+                        </m:r>
+                      </m:num>
+                      <m:den>
+                        <m:r>
+                          <a:rPr lang="fr-CA" i="1">
+                            <a:latin typeface="Cambria Math" panose="02040503050406030204" pitchFamily="18" charset="0"/>
+                          </a:rPr>
+                          <m:t>𝑡𝑒𝑚𝑝</m:t>
+                        </m:r>
+                        <m:sSub>
+                          <m:sSubPr>
+                            <m:ctrlPr>
+                              <a:rPr lang="fr-CA" i="1">
+                                <a:latin typeface="Cambria Math" panose="02040503050406030204" pitchFamily="18" charset="0"/>
+                              </a:rPr>
+                            </m:ctrlPr>
+                          </m:sSubPr>
+                          <m:e>
+                            <m:r>
+                              <a:rPr lang="fr-CA" i="1">
+                                <a:latin typeface="Cambria Math" panose="02040503050406030204" pitchFamily="18" charset="0"/>
+                              </a:rPr>
+                              <m:t>𝑠</m:t>
+                            </m:r>
+                          </m:e>
+                          <m:sub>
+                            <m:r>
+                              <a:rPr lang="fr-CA" i="1">
+                                <a:latin typeface="Cambria Math" panose="02040503050406030204" pitchFamily="18" charset="0"/>
+                              </a:rPr>
+                              <m:t>𝑓𝑖𝑛𝑎𝑙</m:t>
+                            </m:r>
+                          </m:sub>
+                        </m:sSub>
+                      </m:den>
+                    </m:f>
+                    <m:r>
+                      <a:rPr lang="fr-CA" i="1">
+                        <a:latin typeface="Cambria Math" panose="02040503050406030204" pitchFamily="18" charset="0"/>
+                      </a:rPr>
+                      <m:t>)</m:t>
+                    </m:r>
+                  </m:oMath>
+                </a14:m>
+                <a:r>
+                  <a:rPr lang="fr-CA" dirty="0"/>
+                  <a:t>,</a:t>
+                </a:r>
+              </a:p>
+              <a:p>
+                <a:pPr marL="0" indent="0" algn="ctr">
+                  <a:buNone/>
+                </a:pPr>
+                <a14:m>
+                  <m:oMath xmlns:m="http://schemas.openxmlformats.org/officeDocument/2006/math">
+                    <m:f>
+                      <m:fPr>
+                        <m:ctrlPr>
+                          <a:rPr lang="fr-CA" i="1">
+                            <a:latin typeface="Cambria Math" panose="02040503050406030204" pitchFamily="18" charset="0"/>
+                          </a:rPr>
+                        </m:ctrlPr>
+                      </m:fPr>
+                      <m:num>
+                        <m:sSup>
+                          <m:sSupPr>
+                            <m:ctrlPr>
+                              <a:rPr lang="fr-CA" b="0" i="1" smtClean="0">
+                                <a:latin typeface="Cambria Math" panose="02040503050406030204" pitchFamily="18" charset="0"/>
+                              </a:rPr>
+                            </m:ctrlPr>
+                          </m:sSupPr>
+                          <m:e>
+                            <m:r>
+                              <a:rPr lang="fr-CA" i="1">
+                                <a:latin typeface="Cambria Math" panose="02040503050406030204" pitchFamily="18" charset="0"/>
+                              </a:rPr>
+                              <m:t>𝜕</m:t>
+                            </m:r>
+                          </m:e>
+                          <m:sup>
+                            <m:r>
+                              <a:rPr lang="fr-CA" b="0" i="1" smtClean="0">
+                                <a:latin typeface="Cambria Math" panose="02040503050406030204" pitchFamily="18" charset="0"/>
+                              </a:rPr>
+                              <m:t>2</m:t>
+                            </m:r>
+                          </m:sup>
+                        </m:sSup>
+                        <m:r>
+                          <a:rPr lang="fr-CA" i="1">
+                            <a:latin typeface="Cambria Math" panose="02040503050406030204" pitchFamily="18" charset="0"/>
+                          </a:rPr>
+                          <m:t>Ĉ</m:t>
+                        </m:r>
+                      </m:num>
+                      <m:den>
+                        <m:r>
+                          <a:rPr lang="fr-CA" i="1">
+                            <a:latin typeface="Cambria Math" panose="02040503050406030204" pitchFamily="18" charset="0"/>
+                          </a:rPr>
+                          <m:t>𝜕</m:t>
+                        </m:r>
+                        <m:sSup>
+                          <m:sSupPr>
+                            <m:ctrlPr>
+                              <a:rPr lang="fr-CA" b="0" i="1" smtClean="0">
+                                <a:latin typeface="Cambria Math" panose="02040503050406030204" pitchFamily="18" charset="0"/>
+                              </a:rPr>
+                            </m:ctrlPr>
+                          </m:sSupPr>
+                          <m:e>
+                            <m:r>
+                              <a:rPr lang="fr-CA" i="1">
+                                <a:latin typeface="Cambria Math" panose="02040503050406030204" pitchFamily="18" charset="0"/>
+                              </a:rPr>
+                              <m:t>𝑟</m:t>
+                            </m:r>
+                          </m:e>
+                          <m:sup>
+                            <m:r>
+                              <a:rPr lang="fr-CA" b="0" i="1" smtClean="0">
+                                <a:latin typeface="Cambria Math" panose="02040503050406030204" pitchFamily="18" charset="0"/>
+                              </a:rPr>
+                              <m:t>2</m:t>
+                            </m:r>
+                          </m:sup>
+                        </m:sSup>
+                      </m:den>
+                    </m:f>
+                    <m:r>
+                      <a:rPr lang="fr-CA" i="1">
+                        <a:latin typeface="Cambria Math" panose="02040503050406030204" pitchFamily="18" charset="0"/>
+                      </a:rPr>
+                      <m:t>= </m:t>
+                    </m:r>
+                    <m:f>
+                      <m:fPr>
+                        <m:ctrlPr>
+                          <a:rPr lang="fr-CA" i="1">
+                            <a:latin typeface="Cambria Math" panose="02040503050406030204" pitchFamily="18" charset="0"/>
+                          </a:rPr>
+                        </m:ctrlPr>
+                      </m:fPr>
+                      <m:num>
+                        <m:r>
+                          <a:rPr lang="fr-CA" i="1">
+                            <a:latin typeface="Cambria Math" panose="02040503050406030204" pitchFamily="18" charset="0"/>
+                          </a:rPr>
+                          <m:t>−</m:t>
+                        </m:r>
+                        <m:r>
+                          <a:rPr lang="fr-CA" b="0" i="1" smtClean="0">
+                            <a:latin typeface="Cambria Math" panose="02040503050406030204" pitchFamily="18" charset="0"/>
+                          </a:rPr>
+                          <m:t>4</m:t>
+                        </m:r>
+                        <m:r>
+                          <a:rPr lang="fr-CA" i="1">
+                            <a:latin typeface="Cambria Math" panose="02040503050406030204" pitchFamily="18" charset="0"/>
+                          </a:rPr>
+                          <m:t>∗</m:t>
+                        </m:r>
+                        <m:sSup>
+                          <m:sSupPr>
+                            <m:ctrlPr>
+                              <a:rPr lang="fr-CA" b="0" i="1" smtClean="0">
+                                <a:latin typeface="Cambria Math" panose="02040503050406030204" pitchFamily="18" charset="0"/>
+                              </a:rPr>
+                            </m:ctrlPr>
+                          </m:sSupPr>
+                          <m:e>
+                            <m:r>
+                              <a:rPr lang="fr-CA" i="1">
+                                <a:latin typeface="Cambria Math" panose="02040503050406030204" pitchFamily="18" charset="0"/>
+                              </a:rPr>
+                              <m:t>𝜋</m:t>
+                            </m:r>
+                          </m:e>
+                          <m:sup>
+                            <m:r>
+                              <a:rPr lang="fr-CA" b="0" i="1" smtClean="0">
+                                <a:latin typeface="Cambria Math" panose="02040503050406030204" pitchFamily="18" charset="0"/>
+                              </a:rPr>
+                              <m:t>2</m:t>
+                            </m:r>
+                          </m:sup>
+                        </m:sSup>
+                      </m:num>
+                      <m:den>
+                        <m:sSup>
+                          <m:sSupPr>
+                            <m:ctrlPr>
+                              <a:rPr lang="fr-CA" b="0" i="1" smtClean="0">
+                                <a:latin typeface="Cambria Math" panose="02040503050406030204" pitchFamily="18" charset="0"/>
+                              </a:rPr>
+                            </m:ctrlPr>
+                          </m:sSupPr>
+                          <m:e>
+                            <m:r>
+                              <a:rPr lang="fr-CA" i="1">
+                                <a:latin typeface="Cambria Math" panose="02040503050406030204" pitchFamily="18" charset="0"/>
+                              </a:rPr>
+                              <m:t>𝑅</m:t>
+                            </m:r>
+                          </m:e>
+                          <m:sup>
+                            <m:r>
+                              <a:rPr lang="fr-CA" b="0" i="1" smtClean="0">
+                                <a:latin typeface="Cambria Math" panose="02040503050406030204" pitchFamily="18" charset="0"/>
+                              </a:rPr>
+                              <m:t>2</m:t>
+                            </m:r>
+                          </m:sup>
+                        </m:sSup>
+                      </m:den>
+                    </m:f>
+                    <m:r>
+                      <a:rPr lang="fr-CA" b="0" i="1" smtClean="0">
+                        <a:latin typeface="Cambria Math" panose="02040503050406030204" pitchFamily="18" charset="0"/>
+                      </a:rPr>
+                      <m:t>𝑐𝑜𝑠</m:t>
+                    </m:r>
+                    <m:d>
+                      <m:dPr>
+                        <m:ctrlPr>
+                          <a:rPr lang="fr-CA" i="1">
+                            <a:latin typeface="Cambria Math" panose="02040503050406030204" pitchFamily="18" charset="0"/>
+                          </a:rPr>
+                        </m:ctrlPr>
+                      </m:dPr>
+                      <m:e>
+                        <m:r>
+                          <a:rPr lang="fr-CA" i="1">
+                            <a:latin typeface="Cambria Math" panose="02040503050406030204" pitchFamily="18" charset="0"/>
+                          </a:rPr>
+                          <m:t>2 ∗</m:t>
+                        </m:r>
+                        <m:r>
+                          <a:rPr lang="fr-CA" i="1">
+                            <a:latin typeface="Cambria Math" panose="02040503050406030204" pitchFamily="18" charset="0"/>
+                          </a:rPr>
+                          <m:t>𝜋</m:t>
+                        </m:r>
+                        <m:r>
+                          <a:rPr lang="fr-CA" i="1">
+                            <a:latin typeface="Cambria Math" panose="02040503050406030204" pitchFamily="18" charset="0"/>
+                          </a:rPr>
+                          <m:t>∗</m:t>
+                        </m:r>
+                        <m:f>
+                          <m:fPr>
+                            <m:ctrlPr>
+                              <a:rPr lang="fr-CA" i="1">
+                                <a:latin typeface="Cambria Math" panose="02040503050406030204" pitchFamily="18" charset="0"/>
+                              </a:rPr>
+                            </m:ctrlPr>
+                          </m:fPr>
+                          <m:num>
+                            <m:r>
+                              <a:rPr lang="fr-CA" i="1">
+                                <a:latin typeface="Cambria Math" panose="02040503050406030204" pitchFamily="18" charset="0"/>
+                              </a:rPr>
+                              <m:t>𝑟</m:t>
+                            </m:r>
+                          </m:num>
+                          <m:den>
+                            <m:r>
+                              <a:rPr lang="fr-CA" i="1">
+                                <a:latin typeface="Cambria Math" panose="02040503050406030204" pitchFamily="18" charset="0"/>
+                              </a:rPr>
+                              <m:t>𝑅</m:t>
+                            </m:r>
+                          </m:den>
+                        </m:f>
+                      </m:e>
+                    </m:d>
+                    <m:r>
+                      <a:rPr lang="fr-CA" i="1">
+                        <a:latin typeface="Cambria Math" panose="02040503050406030204" pitchFamily="18" charset="0"/>
+                      </a:rPr>
+                      <m:t>∗</m:t>
+                    </m:r>
+                    <m:r>
+                      <m:rPr>
+                        <m:sty m:val="p"/>
+                      </m:rPr>
+                      <a:rPr lang="fr-CA">
+                        <a:latin typeface="Cambria Math" panose="02040503050406030204" pitchFamily="18" charset="0"/>
+                      </a:rPr>
+                      <m:t>cos</m:t>
+                    </m:r>
+                    <m:r>
+                      <a:rPr lang="fr-CA" i="1">
+                        <a:latin typeface="Cambria Math" panose="02040503050406030204" pitchFamily="18" charset="0"/>
+                      </a:rPr>
+                      <m:t>⁡(2 ∗</m:t>
+                    </m:r>
+                    <m:r>
+                      <a:rPr lang="fr-CA" i="1">
+                        <a:latin typeface="Cambria Math" panose="02040503050406030204" pitchFamily="18" charset="0"/>
+                      </a:rPr>
+                      <m:t>𝜋</m:t>
+                    </m:r>
+                    <m:r>
+                      <a:rPr lang="fr-CA" i="1">
+                        <a:latin typeface="Cambria Math" panose="02040503050406030204" pitchFamily="18" charset="0"/>
+                      </a:rPr>
+                      <m:t>∗</m:t>
+                    </m:r>
+                    <m:f>
+                      <m:fPr>
+                        <m:ctrlPr>
+                          <a:rPr lang="fr-CA" i="1">
+                            <a:latin typeface="Cambria Math" panose="02040503050406030204" pitchFamily="18" charset="0"/>
+                          </a:rPr>
+                        </m:ctrlPr>
+                      </m:fPr>
+                      <m:num>
+                        <m:r>
+                          <a:rPr lang="fr-CA" i="1">
+                            <a:latin typeface="Cambria Math" panose="02040503050406030204" pitchFamily="18" charset="0"/>
+                          </a:rPr>
+                          <m:t>𝑡</m:t>
+                        </m:r>
+                      </m:num>
+                      <m:den>
+                        <m:r>
+                          <a:rPr lang="fr-CA" i="1">
+                            <a:latin typeface="Cambria Math" panose="02040503050406030204" pitchFamily="18" charset="0"/>
+                          </a:rPr>
+                          <m:t>𝑡𝑒𝑚𝑝</m:t>
+                        </m:r>
+                        <m:sSub>
+                          <m:sSubPr>
+                            <m:ctrlPr>
+                              <a:rPr lang="fr-CA" i="1">
+                                <a:latin typeface="Cambria Math" panose="02040503050406030204" pitchFamily="18" charset="0"/>
+                              </a:rPr>
+                            </m:ctrlPr>
+                          </m:sSubPr>
+                          <m:e>
+                            <m:r>
+                              <a:rPr lang="fr-CA" i="1">
+                                <a:latin typeface="Cambria Math" panose="02040503050406030204" pitchFamily="18" charset="0"/>
+                              </a:rPr>
+                              <m:t>𝑠</m:t>
+                            </m:r>
+                          </m:e>
+                          <m:sub>
+                            <m:r>
+                              <a:rPr lang="fr-CA" i="1">
+                                <a:latin typeface="Cambria Math" panose="02040503050406030204" pitchFamily="18" charset="0"/>
+                              </a:rPr>
+                              <m:t>𝑓𝑖𝑛𝑎𝑙</m:t>
+                            </m:r>
+                          </m:sub>
+                        </m:sSub>
+                      </m:den>
+                    </m:f>
+                    <m:r>
+                      <a:rPr lang="fr-CA" i="1">
+                        <a:latin typeface="Cambria Math" panose="02040503050406030204" pitchFamily="18" charset="0"/>
+                      </a:rPr>
+                      <m:t>)</m:t>
+                    </m:r>
+                  </m:oMath>
+                </a14:m>
+                <a:r>
+                  <a:rPr lang="fr-CA" dirty="0"/>
+                  <a:t> </a:t>
+                </a:r>
+              </a:p>
+            </p:txBody>
+          </p:sp>
+        </mc:Choice>
+        <mc:Fallback xmlns="">
+          <p:sp>
+            <p:nvSpPr>
+              <p:cNvPr id="5" name="Espace réservé du contenu 4">
+                <a:extLst>
+                  <a:ext uri="{FF2B5EF4-FFF2-40B4-BE49-F238E27FC236}">
+                    <a16:creationId xmlns:a16="http://schemas.microsoft.com/office/drawing/2014/main" id="{02C72247-3DAB-DC54-91E4-C3BF5F0C7A40}"/>
+                  </a:ext>
+                </a:extLst>
+              </p:cNvPr>
+              <p:cNvSpPr>
+                <a:spLocks noGrp="1" noRot="1" noChangeAspect="1" noMove="1" noResize="1" noEditPoints="1" noAdjustHandles="1" noChangeArrowheads="1" noChangeShapeType="1" noTextEdit="1"/>
+              </p:cNvSpPr>
+              <p:nvPr>
+                <p:ph idx="1"/>
+              </p:nvPr>
+            </p:nvSpPr>
+            <p:spPr>
+              <a:xfrm>
+                <a:off x="774824" y="1113576"/>
+                <a:ext cx="10949414" cy="3576119"/>
+              </a:xfrm>
+              <a:blipFill>
+                <a:blip r:embed="rId3"/>
+                <a:stretch>
+                  <a:fillRect/>
+                </a:stretch>
+              </a:blipFill>
+              <a:ln w="28575">
+                <a:solidFill>
+                  <a:schemeClr val="accent5"/>
+                </a:solidFill>
+              </a:ln>
+            </p:spPr>
+            <p:txBody>
+              <a:bodyPr/>
+              <a:lstStyle/>
+              <a:p>
+                <a:r>
+                  <a:rPr lang="fr-CA">
+                    <a:noFill/>
+                  </a:rPr>
+                  <a:t> </a:t>
+                </a:r>
+              </a:p>
+            </p:txBody>
+          </p:sp>
+        </mc:Fallback>
+      </mc:AlternateContent>
+      <p:pic>
+        <p:nvPicPr>
+          <p:cNvPr id="4" name="Image 3">
+            <a:extLst>
+              <a:ext uri="{FF2B5EF4-FFF2-40B4-BE49-F238E27FC236}">
+                <a16:creationId xmlns:a16="http://schemas.microsoft.com/office/drawing/2014/main" id="{0F881B50-EA33-C38C-3D9C-8A6F8A9E9CEC}"/>
+              </a:ext>
+            </a:extLst>
+          </p:cNvPr>
+          <p:cNvPicPr>
+            <a:picLocks noChangeAspect="1"/>
+          </p:cNvPicPr>
+          <p:nvPr/>
+        </p:nvPicPr>
+        <p:blipFill>
+          <a:blip r:embed="rId4"/>
+          <a:stretch>
+            <a:fillRect/>
+          </a:stretch>
+        </p:blipFill>
+        <p:spPr>
+          <a:xfrm>
+            <a:off x="2778979" y="5458909"/>
+            <a:ext cx="6887536" cy="1181265"/>
+          </a:xfrm>
+          <a:prstGeom prst="rect">
+            <a:avLst/>
+          </a:prstGeom>
+        </p:spPr>
+      </p:pic>
+      <p:sp>
+        <p:nvSpPr>
+          <p:cNvPr id="6" name="ZoneTexte 5">
+            <a:extLst>
+              <a:ext uri="{FF2B5EF4-FFF2-40B4-BE49-F238E27FC236}">
+                <a16:creationId xmlns:a16="http://schemas.microsoft.com/office/drawing/2014/main" id="{98A94175-7F9C-5CB1-D127-EC94C8551DEA}"/>
+              </a:ext>
+            </a:extLst>
+          </p:cNvPr>
+          <p:cNvSpPr txBox="1"/>
+          <p:nvPr/>
+        </p:nvSpPr>
+        <p:spPr>
+          <a:xfrm>
+            <a:off x="2442926" y="4608214"/>
+            <a:ext cx="7559643" cy="1107996"/>
+          </a:xfrm>
+          <a:prstGeom prst="rect">
+            <a:avLst/>
+          </a:prstGeom>
+          <a:noFill/>
+        </p:spPr>
+        <p:txBody>
+          <a:bodyPr wrap="square" rtlCol="0">
+            <a:spAutoFit/>
+          </a:bodyPr>
+          <a:lstStyle/>
+          <a:p>
+            <a:pPr algn="ctr"/>
+            <a:endParaRPr lang="fr-CA" sz="1600" dirty="0"/>
+          </a:p>
+          <a:p>
+            <a:pPr algn="ctr"/>
+            <a:r>
+              <a:rPr lang="fr-CA" sz="1600" dirty="0"/>
+              <a:t>Note : pour se simplifier la tâche, les développements ont été faits à l’aide du calcul symbolique de </a:t>
+            </a:r>
+            <a:r>
+              <a:rPr lang="fr-CA" sz="1600" dirty="0" err="1"/>
+              <a:t>Sympy</a:t>
+            </a:r>
+            <a:r>
+              <a:rPr lang="fr-CA" sz="1600" dirty="0"/>
+              <a:t> dans Python :</a:t>
+            </a:r>
+          </a:p>
+          <a:p>
+            <a:endParaRPr lang="fr-CA" sz="1600" dirty="0"/>
+          </a:p>
+        </p:txBody>
+      </p:sp>
+    </p:spTree>
+    <p:extLst>
+      <p:ext uri="{BB962C8B-B14F-4D97-AF65-F5344CB8AC3E}">
+        <p14:creationId xmlns:p14="http://schemas.microsoft.com/office/powerpoint/2010/main" val="3417222333"/>
+      </p:ext>
+    </p:extLst>
+  </p:cSld>
+  <p:clrMapOvr>
+    <a:masterClrMapping/>
+  </p:clrMapOvr>
+</p:sld>
+</file>
+
+<file path=ppt/slides/slide8.xml><?xml version="1.0" encoding="utf-8"?>
+<p:sld xmlns:a="http://schemas.openxmlformats.org/drawingml/2006/main" xmlns:r="http://schemas.openxmlformats.org/officeDocument/2006/relationships" xmlns:p="http://schemas.openxmlformats.org/presentationml/2006/main">
+  <p:cSld>
+    <p:spTree>
+      <p:nvGrpSpPr>
+        <p:cNvPr id="1" name="">
+          <a:extLst>
+            <a:ext uri="{FF2B5EF4-FFF2-40B4-BE49-F238E27FC236}">
+              <a16:creationId xmlns:a16="http://schemas.microsoft.com/office/drawing/2014/main" id="{AED6F188-5146-F691-91E4-41C51DF4FF19}"/>
+            </a:ext>
+          </a:extLst>
+        </p:cNvPr>
+        <p:cNvGrpSpPr/>
+        <p:nvPr/>
+      </p:nvGrpSpPr>
+      <p:grpSpPr>
+        <a:xfrm>
+          <a:off x="0" y="0"/>
+          <a:ext cx="0" cy="0"/>
+          <a:chOff x="0" y="0"/>
+          <a:chExt cx="0" cy="0"/>
+        </a:xfrm>
+      </p:grpSpPr>
+      <p:sp>
+        <p:nvSpPr>
+          <p:cNvPr id="2" name="Titre 1">
+            <a:extLst>
+              <a:ext uri="{FF2B5EF4-FFF2-40B4-BE49-F238E27FC236}">
+                <a16:creationId xmlns:a16="http://schemas.microsoft.com/office/drawing/2014/main" id="{5F242EA4-2960-05DF-41AE-0DC6416C92F8}"/>
+              </a:ext>
+            </a:extLst>
+          </p:cNvPr>
+          <p:cNvSpPr>
+            <a:spLocks noGrp="1"/>
+          </p:cNvSpPr>
+          <p:nvPr>
+            <p:ph type="title"/>
+          </p:nvPr>
+        </p:nvSpPr>
+        <p:spPr>
+          <a:xfrm>
+            <a:off x="838200" y="118237"/>
+            <a:ext cx="10515600" cy="1325563"/>
+          </a:xfrm>
+        </p:spPr>
+        <p:txBody>
+          <a:bodyPr/>
+          <a:lstStyle/>
+          <a:p>
+            <a:r>
+              <a:rPr lang="fr-FR" dirty="0"/>
+              <a:t>C) Terme source : Tracé</a:t>
+            </a:r>
+          </a:p>
+        </p:txBody>
+      </p:sp>
+      <p:pic>
+        <p:nvPicPr>
+          <p:cNvPr id="9" name="Image 8">
+            <a:extLst>
+              <a:ext uri="{FF2B5EF4-FFF2-40B4-BE49-F238E27FC236}">
+                <a16:creationId xmlns:a16="http://schemas.microsoft.com/office/drawing/2014/main" id="{D7271FD1-7E6A-7FAA-5288-F2166FB90158}"/>
+              </a:ext>
+            </a:extLst>
+          </p:cNvPr>
+          <p:cNvPicPr>
+            <a:picLocks noChangeAspect="1"/>
+          </p:cNvPicPr>
+          <p:nvPr/>
+        </p:nvPicPr>
+        <p:blipFill>
+          <a:blip r:embed="rId3"/>
+          <a:stretch>
+            <a:fillRect/>
+          </a:stretch>
+        </p:blipFill>
+        <p:spPr>
+          <a:xfrm>
+            <a:off x="1533626" y="1108674"/>
+            <a:ext cx="9468050" cy="4839739"/>
+          </a:xfrm>
+          <a:prstGeom prst="rect">
+            <a:avLst/>
+          </a:prstGeom>
+        </p:spPr>
+      </p:pic>
+      <p:sp>
+        <p:nvSpPr>
+          <p:cNvPr id="10" name="ZoneTexte 9">
+            <a:extLst>
+              <a:ext uri="{FF2B5EF4-FFF2-40B4-BE49-F238E27FC236}">
+                <a16:creationId xmlns:a16="http://schemas.microsoft.com/office/drawing/2014/main" id="{906D4819-BB1A-32B7-D9A1-5D4AD7DF1990}"/>
+              </a:ext>
+            </a:extLst>
+          </p:cNvPr>
+          <p:cNvSpPr txBox="1"/>
+          <p:nvPr/>
+        </p:nvSpPr>
+        <p:spPr>
+          <a:xfrm>
+            <a:off x="3359217" y="6054291"/>
+            <a:ext cx="5130265" cy="646331"/>
+          </a:xfrm>
+          <a:prstGeom prst="rect">
+            <a:avLst/>
+          </a:prstGeom>
+          <a:noFill/>
+        </p:spPr>
+        <p:txBody>
+          <a:bodyPr wrap="square" rtlCol="0">
+            <a:spAutoFit/>
+          </a:bodyPr>
+          <a:lstStyle/>
+          <a:p>
+            <a:r>
+              <a:rPr lang="fr-CA" dirty="0"/>
+              <a:t>Note : ici le terme source n’est pas présent en r = 0 car il y a une division par 0</a:t>
+            </a:r>
+          </a:p>
+        </p:txBody>
+      </p:sp>
+    </p:spTree>
+    <p:extLst>
+      <p:ext uri="{BB962C8B-B14F-4D97-AF65-F5344CB8AC3E}">
+        <p14:creationId xmlns:p14="http://schemas.microsoft.com/office/powerpoint/2010/main" val="2004444017"/>
+      </p:ext>
+    </p:extLst>
+  </p:cSld>
+  <p:clrMapOvr>
+    <a:masterClrMapping/>
+  </p:clrMapOvr>
+</p:sld>
+</file>
+
+<file path=ppt/slides/slide9.xml><?xml version="1.0" encoding="utf-8"?>
+<p:sld xmlns:a="http://schemas.openxmlformats.org/drawingml/2006/main" xmlns:r="http://schemas.openxmlformats.org/officeDocument/2006/relationships" xmlns:p="http://schemas.openxmlformats.org/presentationml/2006/main">
+  <p:cSld>
+    <p:spTree>
+      <p:nvGrpSpPr>
+        <p:cNvPr id="1" name="">
+          <a:extLst>
+            <a:ext uri="{FF2B5EF4-FFF2-40B4-BE49-F238E27FC236}">
+              <a16:creationId xmlns:a16="http://schemas.microsoft.com/office/drawing/2014/main" id="{021CAD0A-2448-DAF0-376C-90852E39E223}"/>
+            </a:ext>
+          </a:extLst>
+        </p:cNvPr>
+        <p:cNvGrpSpPr/>
+        <p:nvPr/>
+      </p:nvGrpSpPr>
+      <p:grpSpPr>
+        <a:xfrm>
+          <a:off x="0" y="0"/>
+          <a:ext cx="0" cy="0"/>
+          <a:chOff x="0" y="0"/>
+          <a:chExt cx="0" cy="0"/>
+        </a:xfrm>
+      </p:grpSpPr>
+      <p:sp>
+        <p:nvSpPr>
+          <p:cNvPr id="2" name="Titre 1">
+            <a:extLst>
+              <a:ext uri="{FF2B5EF4-FFF2-40B4-BE49-F238E27FC236}">
+                <a16:creationId xmlns:a16="http://schemas.microsoft.com/office/drawing/2014/main" id="{1740A840-1C01-3EF1-0F52-D62BAADC83E7}"/>
+              </a:ext>
+            </a:extLst>
+          </p:cNvPr>
+          <p:cNvSpPr>
+            <a:spLocks noGrp="1"/>
+          </p:cNvSpPr>
+          <p:nvPr>
+            <p:ph type="title"/>
+          </p:nvPr>
+        </p:nvSpPr>
+        <p:spPr>
+          <a:xfrm>
+            <a:off x="838200" y="118237"/>
+            <a:ext cx="10515600" cy="1325563"/>
+          </a:xfrm>
+        </p:spPr>
+        <p:txBody>
+          <a:bodyPr/>
+          <a:lstStyle/>
+          <a:p>
+            <a:r>
+              <a:rPr lang="fr-FR" dirty="0"/>
+              <a:t>D) Graphiques de convergence : Espace</a:t>
+            </a:r>
+          </a:p>
+        </p:txBody>
+      </p:sp>
+      <p:sp>
+        <p:nvSpPr>
+          <p:cNvPr id="10" name="ZoneTexte 9">
+            <a:extLst>
+              <a:ext uri="{FF2B5EF4-FFF2-40B4-BE49-F238E27FC236}">
+                <a16:creationId xmlns:a16="http://schemas.microsoft.com/office/drawing/2014/main" id="{AC411E4E-3E3A-D7C0-2D5D-44E0A2C362BE}"/>
+              </a:ext>
+            </a:extLst>
+          </p:cNvPr>
+          <p:cNvSpPr txBox="1"/>
+          <p:nvPr/>
+        </p:nvSpPr>
+        <p:spPr>
+          <a:xfrm>
+            <a:off x="2164080" y="5365540"/>
+            <a:ext cx="8654716" cy="1384995"/>
+          </a:xfrm>
+          <a:prstGeom prst="rect">
+            <a:avLst/>
+          </a:prstGeom>
+          <a:noFill/>
+        </p:spPr>
+        <p:txBody>
+          <a:bodyPr wrap="square" rtlCol="0">
+            <a:spAutoFit/>
+          </a:bodyPr>
+          <a:lstStyle/>
+          <a:p>
+            <a:pPr algn="just"/>
+            <a:r>
+              <a:rPr lang="fr-CA" sz="1200" dirty="0"/>
+              <a:t>On peut voir que la convergence en espace est environ d’ordre 2 pour les trois types d’erreur. Cela est attendu avec les développements du terme de troncature montrés en A. Les écarts s’expliquent par les données prise en compte dans la convergence asymptotiques ; certaines erreurs sont aberrantes et ne devraient pas être prises en compte dans le calcul. Plus de pas de résolution pourraient aider à améliorer l’estimation de l’ordre de convergence asymptotique.</a:t>
+            </a:r>
+          </a:p>
+          <a:p>
+            <a:pPr algn="just"/>
+            <a:endParaRPr lang="fr-CA" sz="1200" dirty="0"/>
+          </a:p>
+          <a:p>
+            <a:pPr algn="just"/>
+            <a:r>
+              <a:rPr lang="fr-CA" sz="1200" dirty="0"/>
+              <a:t>L’erreur vers la fin atteint un plateau puisque l’erreur de discrétisation en temps commence à dominer. Réduire le pas de discrétisation en temps pourrait aussi améliorer les résultats de la convergence en espace.</a:t>
+            </a:r>
+          </a:p>
+        </p:txBody>
+      </p:sp>
+      <p:pic>
+        <p:nvPicPr>
+          <p:cNvPr id="4" name="Image 3">
+            <a:extLst>
+              <a:ext uri="{FF2B5EF4-FFF2-40B4-BE49-F238E27FC236}">
+                <a16:creationId xmlns:a16="http://schemas.microsoft.com/office/drawing/2014/main" id="{AF57EDE4-BA7E-EED8-3B59-73B8F9C5B917}"/>
+              </a:ext>
+            </a:extLst>
+          </p:cNvPr>
+          <p:cNvPicPr>
+            <a:picLocks noChangeAspect="1"/>
+          </p:cNvPicPr>
+          <p:nvPr/>
+        </p:nvPicPr>
+        <p:blipFill>
+          <a:blip r:embed="rId3"/>
+          <a:stretch>
+            <a:fillRect/>
+          </a:stretch>
+        </p:blipFill>
+        <p:spPr>
+          <a:xfrm>
+            <a:off x="2395086" y="1185279"/>
+            <a:ext cx="7401827" cy="4180261"/>
+          </a:xfrm>
+          <a:prstGeom prst="rect">
+            <a:avLst/>
+          </a:prstGeom>
+        </p:spPr>
+      </p:pic>
+      <p:sp>
+        <p:nvSpPr>
+          <p:cNvPr id="3" name="ZoneTexte 2">
+            <a:extLst>
+              <a:ext uri="{FF2B5EF4-FFF2-40B4-BE49-F238E27FC236}">
+                <a16:creationId xmlns:a16="http://schemas.microsoft.com/office/drawing/2014/main" id="{65E4D10F-53A7-0092-BAA3-52C256DDC492}"/>
+              </a:ext>
+            </a:extLst>
+          </p:cNvPr>
+          <p:cNvSpPr txBox="1"/>
+          <p:nvPr/>
+        </p:nvSpPr>
+        <p:spPr>
+          <a:xfrm>
+            <a:off x="10104730" y="1611517"/>
+            <a:ext cx="1710042" cy="923330"/>
+          </a:xfrm>
+          <a:prstGeom prst="rect">
+            <a:avLst/>
+          </a:prstGeom>
+          <a:noFill/>
+          <a:ln>
+            <a:solidFill>
+              <a:schemeClr val="accent6"/>
+            </a:solidFill>
+          </a:ln>
+        </p:spPr>
+        <p:txBody>
+          <a:bodyPr wrap="square" rtlCol="0">
+            <a:spAutoFit/>
+          </a:bodyPr>
+          <a:lstStyle/>
+          <a:p>
+            <a:r>
+              <a:rPr lang="fr-CA" dirty="0"/>
+              <a:t>*Résultats obtenus avec un script Bash</a:t>
+            </a:r>
+          </a:p>
+        </p:txBody>
+      </p:sp>
+    </p:spTree>
+    <p:extLst>
+      <p:ext uri="{BB962C8B-B14F-4D97-AF65-F5344CB8AC3E}">
+        <p14:creationId xmlns:p14="http://schemas.microsoft.com/office/powerpoint/2010/main" val="3797620382"/>
+      </p:ext>
+    </p:extLst>
+  </p:cSld>
+  <p:clrMapOvr>
+    <a:masterClrMapping/>
+  </p:clrMapOvr>
+</p:sld>
+</file>
+
 <file path=ppt/theme/theme1.xml><?xml version="1.0" encoding="utf-8"?>
 <a:theme xmlns:a="http://schemas.openxmlformats.org/drawingml/2006/main" name="Thème Office">
   <a:themeElements>

</xml_diff>